<commit_message>
feat(integrated): add memstat and fdinfo copyout workflow
</commit_message>
<xml_diff>
--- a/slides/final_defense_ppt.pptx
+++ b/slides/final_defense_ppt.pptx
@@ -462,7 +462,7 @@
                 <a:ea typeface="Microsoft YaHei"/>
                 <a:cs typeface="Microsoft YaHei"/>
               </a:rPr>
-              <a:t>Speaker Notes - Slide 11: integrated-labs 0001-0007 与一键验证</a:t>
+              <a:t>Speaker Notes - Slide 11: integrated-labs 0001-0009 与一键验证</a:t>
             </a:r>
             <a:endParaRPr lang="zh-CN" sz="1400"/>
           </a:p>
@@ -2970,7 +2970,7 @@
                 <a:ea typeface="Microsoft YaHei"/>
                 <a:cs typeface="Microsoft YaHei"/>
               </a:rPr>
-              <a:t>• 最终工程 commit：`e8e2fb9`。</a:t>
+              <a:t>• historical stable checkpoint commit：`e8e2fb9`（integrated `0001-0007`，三方 full PASS）。</a:t>
             </a:r>
             <a:endParaRPr lang="zh-CN" sz="1200"/>
           </a:p>
@@ -2985,7 +2985,7 @@
                 <a:ea typeface="Microsoft YaHei"/>
                 <a:cs typeface="Microsoft YaHei"/>
               </a:rPr>
-              <a:t>• 最终证据 commit：`03aad04`。</a:t>
+              <a:t>• 最终证据 commit：`03aad04`（covers `0001-0007`）；新 `0001-0009` final commit 为 TBD。</a:t>
             </a:r>
             <a:endParaRPr lang="zh-CN" sz="1200"/>
           </a:p>
@@ -3291,7 +3291,7 @@
                 <a:ea typeface="Microsoft YaHei"/>
                 <a:cs typeface="Microsoft YaHei"/>
               </a:rPr>
-              <a:t>• 顺序应用 integrated `0001-0007`。</a:t>
+              <a:t>• 顺序应用 integrated `0001-0009`。</a:t>
             </a:r>
             <a:endParaRPr lang="zh-CN" sz="1200"/>
           </a:p>
@@ -3756,7 +3756,7 @@
                 <a:ea typeface="Microsoft YaHei"/>
                 <a:cs typeface="Microsoft YaHei"/>
               </a:rPr>
-              <a:t>integrated-labs 0001-0007 与一键验证</a:t>
+              <a:t>integrated-labs 0001-0009 与一键验证</a:t>
             </a:r>
             <a:endParaRPr lang="zh-CN" sz="2100"/>
           </a:p>
@@ -3960,7 +3960,37 @@
                 <a:ea typeface="Microsoft YaHei"/>
                 <a:cs typeface="Microsoft YaHei"/>
               </a:rPr>
-              <a:t>• 推荐命令：`bash scripts/xv6/teammate-verify.sh --full`。</a:t>
+              <a:t>• `0008`：Lab3 进阶 memstat（`SYS 29`，argaddr+copyout+struct ABI）。</a:t>
+            </a:r>
+            <a:endParaRPr lang="zh-CN" sz="1200"/>
+          </a:p>
+          <a:p>
+            <a:pPr algn="l"/>
+            <a:r>
+              <a:rPr lang="zh-CN" sz="1200">
+                <a:solidFill>
+                  <a:srgbClr val="FFFFFF"/>
+                </a:solidFill>
+                <a:latin typeface="Microsoft YaHei"/>
+                <a:ea typeface="Microsoft YaHei"/>
+                <a:cs typeface="Microsoft YaHei"/>
+              </a:rPr>
+              <a:t>• `0009`：Lab4 进阶 fdinfo（`SYS 30`，argint+argaddr+copyout+struct ABI）。</a:t>
+            </a:r>
+            <a:endParaRPr lang="zh-CN" sz="1200"/>
+          </a:p>
+          <a:p>
+            <a:pPr algn="l"/>
+            <a:r>
+              <a:rPr lang="zh-CN" sz="1200">
+                <a:solidFill>
+                  <a:srgbClr val="FFFFFF"/>
+                </a:solidFill>
+                <a:latin typeface="Microsoft YaHei"/>
+                <a:ea typeface="Microsoft YaHei"/>
+                <a:cs typeface="Microsoft YaHei"/>
+              </a:rPr>
+              <a:t>• 推荐命令：`bash scripts/xv6/teammate-verify.sh --full`（现含 memstattest/fdinfotest）。</a:t>
             </a:r>
             <a:endParaRPr lang="zh-CN" sz="1200"/>
           </a:p>
@@ -4595,7 +4625,7 @@
                 <a:ea typeface="Microsoft YaHei"/>
                 <a:cs typeface="Microsoft YaHei"/>
               </a:rPr>
-              <a:t>final `e8e2fb9` 已完成队长本机和两位队友的 full verification PASS。</a:t>
+              <a:t>`e8e2fb9 / 0001-0007` 已完成队长本机和两位队友的 full verification PASS（historical stable checkpoint）；含 memstat/fdinfo 的 `0001-0009` 三方复现为 TBD。</a:t>
             </a:r>
             <a:endParaRPr lang="zh-CN" sz="1400"/>
           </a:p>
@@ -4683,7 +4713,22 @@
                 <a:ea typeface="Microsoft YaHei"/>
                 <a:cs typeface="Microsoft YaHei"/>
               </a:rPr>
-              <a:t>• 覆盖 doctor/check-env/baseline/apply+make/boot/all user tests/overall。</a:t>
+              <a:t>• 覆盖 doctor/check-env/baseline/apply+make/boot/all user tests/overall，但只覆盖 `0001-0007`（不含 memstat/fdinfo）。</a:t>
+            </a:r>
+            <a:endParaRPr lang="zh-CN" sz="1200"/>
+          </a:p>
+          <a:p>
+            <a:pPr algn="l"/>
+            <a:r>
+              <a:rPr lang="zh-CN" sz="1200">
+                <a:solidFill>
+                  <a:srgbClr val="FFFFFF"/>
+                </a:solidFill>
+                <a:latin typeface="Microsoft YaHei"/>
+                <a:ea typeface="Microsoft YaHei"/>
+                <a:cs typeface="Microsoft YaHei"/>
+              </a:rPr>
+              <a:t>• stage11b `0001-0009` 队长本机 `local-verify --full` overall PASS；rain/root/z2996 的 `0001-0009` 三方 full verify 为 TBD，不得伪造。</a:t>
             </a:r>
             <a:endParaRPr lang="zh-CN" sz="1200"/>
           </a:p>
@@ -5309,7 +5354,7 @@
                 <a:ea typeface="Microsoft YaHei"/>
                 <a:cs typeface="Microsoft YaHei"/>
               </a:rPr>
-              <a:t>• final video：`20260606_final_integrated_0001_0007_demo.mp4`。</a:t>
+              <a:t>• `0001-0007` 视频（historical stable checkpoint）：`20260606_final_integrated_0001_0007_demo.mp4`。</a:t>
             </a:r>
             <a:endParaRPr lang="zh-CN" sz="1200"/>
           </a:p>
@@ -5324,7 +5369,7 @@
                 <a:ea typeface="Microsoft YaHei"/>
                 <a:cs typeface="Microsoft YaHei"/>
               </a:rPr>
-              <a:t>• SHA256：`0FF2D3581552B3FD3A2630E827251CF46C36BC3BE8F8B9D9DDB691FC0668A93B`。</a:t>
+              <a:t>• 该视频 SHA256：`0FF2D3581552B3FD3A2630E827251CF46C36BC3BE8F8B9D9DDB691FC0668A93B`（只覆盖 `0001-0007`）。</a:t>
             </a:r>
             <a:endParaRPr lang="zh-CN" sz="1200"/>
           </a:p>
@@ -5339,6 +5384,21 @@
                 <a:ea typeface="Microsoft YaHei"/>
                 <a:cs typeface="Microsoft YaHei"/>
               </a:rPr>
+              <a:t>• 覆盖 `0001-0009`（含 memstat/fdinfo）的新视频与新 SHA256：TBD，须重新录制，不得伪造。</a:t>
+            </a:r>
+            <a:endParaRPr lang="zh-CN" sz="1200"/>
+          </a:p>
+          <a:p>
+            <a:pPr algn="l"/>
+            <a:r>
+              <a:rPr lang="zh-CN" sz="1200">
+                <a:solidFill>
+                  <a:srgbClr val="FFFFFF"/>
+                </a:solidFill>
+                <a:latin typeface="Microsoft YaHei"/>
+                <a:ea typeface="Microsoft YaHei"/>
+                <a:cs typeface="Microsoft YaHei"/>
+              </a:rPr>
               <a:t>• 中央索引：`submissions/evidence_manifest.md`。</a:t>
             </a:r>
             <a:endParaRPr lang="zh-CN" sz="1200"/>
@@ -5354,7 +5414,7 @@
                 <a:ea typeface="Microsoft YaHei"/>
                 <a:cs typeface="Microsoft YaHei"/>
               </a:rPr>
-              <a:t>• historical videos 只覆盖 earlier `0001-0005`，不覆盖 final `e8e2fb9`。</a:t>
+              <a:t>• historical videos 只覆盖 earlier `0001-0005`，不覆盖 `e8e2fb9`。</a:t>
             </a:r>
             <a:endParaRPr lang="zh-CN" sz="1200"/>
           </a:p>
@@ -13069,7 +13129,22 @@
                 <a:ea typeface="Microsoft YaHei"/>
                 <a:cs typeface="Microsoft YaHei"/>
               </a:rPr>
-              <a:t>• integrated 编号：`SYS_fcount=26`，`SYS_fdcount=28`。</a:t>
+              <a:t>• 进阶 `fdinfo(int fd, struct fdinfo*)`：用 `argint + argaddr + copyout` 把 `{type, readable, writable, ref}` 拷回用户态（只查自己的 `ofile[fd]`，不返回路径/inode/内容）。</a:t>
+            </a:r>
+            <a:endParaRPr lang="zh-CN" sz="1200"/>
+          </a:p>
+          <a:p>
+            <a:pPr algn="l"/>
+            <a:r>
+              <a:rPr lang="zh-CN" sz="1200">
+                <a:solidFill>
+                  <a:srgbClr val="FFFFFF"/>
+                </a:solidFill>
+                <a:latin typeface="Microsoft YaHei"/>
+                <a:ea typeface="Microsoft YaHei"/>
+                <a:cs typeface="Microsoft YaHei"/>
+              </a:rPr>
+              <a:t>• integrated 编号：`SYS_fcount=26`，`SYS_fdcount=28`，进阶 `SYS_fdinfo=30`（integrated `0009`）。</a:t>
             </a:r>
             <a:endParaRPr lang="zh-CN" sz="1200"/>
           </a:p>

</xml_diff>

<commit_message>
docs: record final db85947 evidence
</commit_message>
<xml_diff>
--- a/slides/final_defense_ppt.pptx
+++ b/slides/final_defense_ppt.pptx
@@ -2970,7 +2970,7 @@
                 <a:ea typeface="Microsoft YaHei"/>
                 <a:cs typeface="Microsoft YaHei"/>
               </a:rPr>
-              <a:t>• historical stable checkpoint commit：`e8e2fb9`（integrated `0001-0007`，三方 full PASS）。</a:t>
+              <a:t>• current final commit：`db85947`（integrated `0001-0009`，rain/root/z2996 三方 full PASS + 新视频 + SHA256 已登记）。</a:t>
             </a:r>
             <a:endParaRPr lang="zh-CN" sz="1200"/>
           </a:p>
@@ -2985,7 +2985,7 @@
                 <a:ea typeface="Microsoft YaHei"/>
                 <a:cs typeface="Microsoft YaHei"/>
               </a:rPr>
-              <a:t>• 最终证据 commit：`03aad04`（covers `0001-0007`）；新 `0001-0009` final commit 为 TBD。</a:t>
+              <a:t>• historical stable checkpoint commit：`e8e2fb9`（integrated `0001-0007`，三方 full PASS；evidence commit `03aad04`）。</a:t>
             </a:r>
             <a:endParaRPr lang="zh-CN" sz="1200"/>
           </a:p>
@@ -4625,7 +4625,7 @@
                 <a:ea typeface="Microsoft YaHei"/>
                 <a:cs typeface="Microsoft YaHei"/>
               </a:rPr>
-              <a:t>`e8e2fb9 / 0001-0007` 已完成队长本机和两位队友的 full verification PASS（historical stable checkpoint）；含 memstat/fdinfo 的 `0001-0009` 三方复现为 TBD。</a:t>
+              <a:t>current final `db85947 / 0001-0009`（含 memstat/fdinfo）已完成 rain/root/z2996 三方 full verification PASS；更早的 `e8e2fb9 / 0001-0007` 三方 PASS 保留为 historical stable checkpoint。</a:t>
             </a:r>
             <a:endParaRPr lang="zh-CN" sz="1400"/>
           </a:p>
@@ -4713,7 +4713,7 @@
                 <a:ea typeface="Microsoft YaHei"/>
                 <a:cs typeface="Microsoft YaHei"/>
               </a:rPr>
-              <a:t>• 覆盖 doctor/check-env/baseline/apply+make/boot/all user tests/overall，但只覆盖 `0001-0007`（不含 memstat/fdinfo）。</a:t>
+              <a:t>• current final：`db85947 / 0001-0009` 三方 full PASS，覆盖全部 10 个用户程序（含 memstattest/fdinfotest）。</a:t>
             </a:r>
             <a:endParaRPr lang="zh-CN" sz="1200"/>
           </a:p>
@@ -4728,7 +4728,7 @@
                 <a:ea typeface="Microsoft YaHei"/>
                 <a:cs typeface="Microsoft YaHei"/>
               </a:rPr>
-              <a:t>• stage11b `0001-0009` 队长本机 `local-verify --full` overall PASS；rain/root/z2996 的 `0001-0009` 三方 full verify 为 TBD，不得伪造。</a:t>
+              <a:t>• 三份 summary 经 grade-summaries 批量核对 3/3 clean PASS；summary/screenshot SHA256 已登记并可一键核验。</a:t>
             </a:r>
             <a:endParaRPr lang="zh-CN" sz="1200"/>
           </a:p>
@@ -4743,7 +4743,7 @@
                 <a:ea typeface="Microsoft YaHei"/>
                 <a:cs typeface="Microsoft YaHei"/>
               </a:rPr>
-              <a:t>• raw summary/log/screenshot 不入 Git；仓库只记录摘要和 SHA256。</a:t>
+              <a:t>• historical：`e8e2fb9 / 0001-0007` 三方 PASS 保留为 checkpoint；raw summary/log/screenshot 不入 Git，仓库只记录摘要和 SHA256。</a:t>
             </a:r>
             <a:endParaRPr lang="zh-CN" sz="1200"/>
           </a:p>
@@ -5384,7 +5384,7 @@
                 <a:ea typeface="Microsoft YaHei"/>
                 <a:cs typeface="Microsoft YaHei"/>
               </a:rPr>
-              <a:t>• 覆盖 `0001-0009`（含 memstat/fdinfo）的新视频与新 SHA256：TBD，须重新录制，不得伪造。</a:t>
+              <a:t>• current final 视频：`20260611_final_integrated_0001_0009_demo.mp4`（31,529,984 bytes），SHA256 `2A2C9863...C7BC0365` 已登记。</a:t>
             </a:r>
             <a:endParaRPr lang="zh-CN" sz="1200"/>
           </a:p>
@@ -7355,7 +7355,7 @@
                 <a:ea typeface="Microsoft YaHei"/>
                 <a:cs typeface="Microsoft YaHei"/>
               </a:rPr>
-              <a:t>• timeout/QEMU 输出捕获不是长期稳定性测试；`0001-0009` 队友复现与新视频为 TBD。</a:t>
+              <a:t>• timeout/QEMU 输出捕获不是长期稳定性测试。</a:t>
             </a:r>
             <a:endParaRPr lang="zh-CN" sz="1200"/>
           </a:p>

</xml_diff>

<commit_message>
docs: align scoring rubric and evidence commit on final materials
</commit_message>
<xml_diff>
--- a/slides/final_defense_ppt.pptx
+++ b/slides/final_defense_ppt.pptx
@@ -205,7 +205,7 @@
             </a:lvl1pPr>
           </a:lstStyle>
           <a:p>
-            <a:fld id="{2D76A37E-E816-4A73-9653-190516B38373}" type="datetimeFigureOut">
+            <a:fld id="{AF336372-A25F-4368-8962-B4BF27106C7A}" type="datetimeFigureOut">
               <a:rPr lang="zh-CN" altLang="en-US" smtClean="0"/>
               <a:t>2026/6/11</a:t>
             </a:fld>
@@ -363,7 +363,7 @@
             </a:lvl1pPr>
           </a:lstStyle>
           <a:p>
-            <a:fld id="{A963AC9B-4540-4870-B076-ED4637A3BAC5}" type="slidenum">
+            <a:fld id="{67EA2E30-806A-480E-8F92-6D6AC26C6F2A}" type="slidenum">
               <a:rPr lang="zh-CN" altLang="en-US" smtClean="0"/>
               <a:t>‹#›</a:t>
             </a:fld>
@@ -374,7 +374,7 @@
     </p:spTree>
     <p:extLst>
       <p:ext uri="{BB962C8B-B14F-4D97-AF65-F5344CB8AC3E}">
-        <p14:creationId xmlns:p14="http://schemas.microsoft.com/office/powerpoint/2010/main" val="1312298620"/>
+        <p14:creationId xmlns:p14="http://schemas.microsoft.com/office/powerpoint/2010/main" val="3352667995"/>
       </p:ext>
     </p:extLst>
   </p:cSld>
@@ -563,7 +563,7 @@
           <a:bodyPr/>
           <a:lstStyle/>
           <a:p>
-            <a:fld id="{A963AC9B-4540-4870-B076-ED4637A3BAC5}" type="slidenum">
+            <a:fld id="{67EA2E30-806A-480E-8F92-6D6AC26C6F2A}" type="slidenum">
               <a:rPr lang="zh-CN" altLang="en-US" smtClean="0"/>
               <a:t>1</a:t>
             </a:fld>
@@ -574,7 +574,7 @@
     </p:spTree>
     <p:extLst>
       <p:ext uri="{BB962C8B-B14F-4D97-AF65-F5344CB8AC3E}">
-        <p14:creationId xmlns:p14="http://schemas.microsoft.com/office/powerpoint/2010/main" val="879753075"/>
+        <p14:creationId xmlns:p14="http://schemas.microsoft.com/office/powerpoint/2010/main" val="3812064456"/>
       </p:ext>
     </p:extLst>
   </p:cSld>
@@ -664,7 +664,7 @@
           <a:bodyPr/>
           <a:lstStyle/>
           <a:p>
-            <a:fld id="{A963AC9B-4540-4870-B076-ED4637A3BAC5}" type="slidenum">
+            <a:fld id="{67EA2E30-806A-480E-8F92-6D6AC26C6F2A}" type="slidenum">
               <a:rPr lang="zh-CN" altLang="en-US" smtClean="0"/>
               <a:t>10</a:t>
             </a:fld>
@@ -675,7 +675,7 @@
     </p:spTree>
     <p:extLst>
       <p:ext uri="{BB962C8B-B14F-4D97-AF65-F5344CB8AC3E}">
-        <p14:creationId xmlns:p14="http://schemas.microsoft.com/office/powerpoint/2010/main" val="4279947628"/>
+        <p14:creationId xmlns:p14="http://schemas.microsoft.com/office/powerpoint/2010/main" val="315538144"/>
       </p:ext>
     </p:extLst>
   </p:cSld>
@@ -756,7 +756,7 @@
           <a:bodyPr/>
           <a:lstStyle/>
           <a:p>
-            <a:fld id="{A963AC9B-4540-4870-B076-ED4637A3BAC5}" type="slidenum">
+            <a:fld id="{67EA2E30-806A-480E-8F92-6D6AC26C6F2A}" type="slidenum">
               <a:rPr lang="zh-CN" altLang="en-US" smtClean="0"/>
               <a:t>11</a:t>
             </a:fld>
@@ -767,7 +767,7 @@
     </p:spTree>
     <p:extLst>
       <p:ext uri="{BB962C8B-B14F-4D97-AF65-F5344CB8AC3E}">
-        <p14:creationId xmlns:p14="http://schemas.microsoft.com/office/powerpoint/2010/main" val="1980138981"/>
+        <p14:creationId xmlns:p14="http://schemas.microsoft.com/office/powerpoint/2010/main" val="3376125628"/>
       </p:ext>
     </p:extLst>
   </p:cSld>
@@ -900,7 +900,133 @@
                 </a:solidFill>
                 <a:latin typeface="Microsoft YaHei" panose="020B0503020204020204" pitchFamily="34" charset="-122"/>
               </a:rPr>
-              <a:t>。</a:t>
+              <a:t>。三方 </a:t>
+            </a:r>
+            <a:r>
+              <a:rPr lang="en-US" altLang="zh-CN" sz="1100">
+                <a:solidFill>
+                  <a:srgbClr val="09243D"/>
+                </a:solidFill>
+                <a:latin typeface="Microsoft YaHei" panose="020B0503020204020204" pitchFamily="34" charset="-122"/>
+              </a:rPr>
+              <a:t>full verification summary </a:t>
+            </a:r>
+            <a:r>
+              <a:rPr lang="zh-CN" altLang="en-US" sz="1100">
+                <a:solidFill>
+                  <a:srgbClr val="09243D"/>
+                </a:solidFill>
+                <a:latin typeface="Microsoft YaHei" panose="020B0503020204020204" pitchFamily="34" charset="-122"/>
+              </a:rPr>
+              <a:t>的 </a:t>
+            </a:r>
+            <a:r>
+              <a:rPr lang="en-US" altLang="zh-CN" sz="1100">
+                <a:solidFill>
+                  <a:srgbClr val="09243D"/>
+                </a:solidFill>
+                <a:latin typeface="Microsoft YaHei" panose="020B0503020204020204" pitchFamily="34" charset="-122"/>
+              </a:rPr>
+              <a:t>current commit </a:t>
+            </a:r>
+            <a:r>
+              <a:rPr lang="zh-CN" altLang="en-US" sz="1100">
+                <a:solidFill>
+                  <a:srgbClr val="09243D"/>
+                </a:solidFill>
+                <a:latin typeface="Microsoft YaHei" panose="020B0503020204020204" pitchFamily="34" charset="-122"/>
+              </a:rPr>
+              <a:t>是 </a:t>
+            </a:r>
+            <a:r>
+              <a:rPr lang="en-US" altLang="zh-CN" sz="1100">
+                <a:solidFill>
+                  <a:srgbClr val="09243D"/>
+                </a:solidFill>
+                <a:latin typeface="Microsoft YaHei" panose="020B0503020204020204" pitchFamily="34" charset="-122"/>
+              </a:rPr>
+              <a:t>db85947</a:t>
+            </a:r>
+            <a:r>
+              <a:rPr lang="zh-CN" altLang="en-US" sz="1100">
+                <a:solidFill>
+                  <a:srgbClr val="09243D"/>
+                </a:solidFill>
+                <a:latin typeface="Microsoft YaHei" panose="020B0503020204020204" pitchFamily="34" charset="-122"/>
+              </a:rPr>
+              <a:t>；</a:t>
+            </a:r>
+            <a:r>
+              <a:rPr lang="en-US" altLang="zh-CN" sz="1100">
+                <a:solidFill>
+                  <a:srgbClr val="09243D"/>
+                </a:solidFill>
+                <a:latin typeface="Microsoft YaHei" panose="020B0503020204020204" pitchFamily="34" charset="-122"/>
+              </a:rPr>
+              <a:t>caf8ced </a:t>
+            </a:r>
+            <a:r>
+              <a:rPr lang="zh-CN" altLang="en-US" sz="1100">
+                <a:solidFill>
+                  <a:srgbClr val="09243D"/>
+                </a:solidFill>
+                <a:latin typeface="Microsoft YaHei" panose="020B0503020204020204" pitchFamily="34" charset="-122"/>
+              </a:rPr>
+              <a:t>只是 </a:t>
+            </a:r>
+            <a:r>
+              <a:rPr lang="en-US" altLang="zh-CN" sz="1100">
+                <a:solidFill>
+                  <a:srgbClr val="09243D"/>
+                </a:solidFill>
+                <a:latin typeface="Microsoft YaHei" panose="020B0503020204020204" pitchFamily="34" charset="-122"/>
+              </a:rPr>
+              <a:t>evidence documentation commit</a:t>
+            </a:r>
+            <a:r>
+              <a:rPr lang="zh-CN" altLang="en-US" sz="1100">
+                <a:solidFill>
+                  <a:srgbClr val="09243D"/>
+                </a:solidFill>
+                <a:latin typeface="Microsoft YaHei" panose="020B0503020204020204" pitchFamily="34" charset="-122"/>
+              </a:rPr>
+              <a:t>，用于记录 </a:t>
+            </a:r>
+            <a:r>
+              <a:rPr lang="en-US" altLang="zh-CN" sz="1100">
+                <a:solidFill>
+                  <a:srgbClr val="09243D"/>
+                </a:solidFill>
+                <a:latin typeface="Microsoft YaHei" panose="020B0503020204020204" pitchFamily="34" charset="-122"/>
+              </a:rPr>
+              <a:t>final demo</a:t>
+            </a:r>
+            <a:r>
+              <a:rPr lang="zh-CN" altLang="en-US" sz="1100">
+                <a:solidFill>
+                  <a:srgbClr val="09243D"/>
+                </a:solidFill>
+                <a:latin typeface="Microsoft YaHei" panose="020B0503020204020204" pitchFamily="34" charset="-122"/>
+              </a:rPr>
+              <a:t>、三方复现、</a:t>
+            </a:r>
+            <a:r>
+              <a:rPr lang="en-US" altLang="zh-CN" sz="1100">
+                <a:solidFill>
+                  <a:srgbClr val="09243D"/>
+                </a:solidFill>
+                <a:latin typeface="Microsoft YaHei" panose="020B0503020204020204" pitchFamily="34" charset="-122"/>
+              </a:rPr>
+              <a:t>SHA256 </a:t>
+            </a:r>
+            <a:r>
+              <a:rPr lang="zh-CN" altLang="en-US" sz="1100">
+                <a:solidFill>
+                  <a:srgbClr val="09243D"/>
+                </a:solidFill>
+                <a:latin typeface="Microsoft YaHei" panose="020B0503020204020204" pitchFamily="34" charset="-122"/>
+              </a:rPr>
+              <a:t>和外部资产索引。</a:t>
             </a:r>
           </a:p>
         </p:txBody>
@@ -920,7 +1046,7 @@
           <a:bodyPr/>
           <a:lstStyle/>
           <a:p>
-            <a:fld id="{A963AC9B-4540-4870-B076-ED4637A3BAC5}" type="slidenum">
+            <a:fld id="{67EA2E30-806A-480E-8F92-6D6AC26C6F2A}" type="slidenum">
               <a:rPr lang="zh-CN" altLang="en-US" smtClean="0"/>
               <a:t>12</a:t>
             </a:fld>
@@ -931,7 +1057,7 @@
     </p:spTree>
     <p:extLst>
       <p:ext uri="{BB962C8B-B14F-4D97-AF65-F5344CB8AC3E}">
-        <p14:creationId xmlns:p14="http://schemas.microsoft.com/office/powerpoint/2010/main" val="3826499318"/>
+        <p14:creationId xmlns:p14="http://schemas.microsoft.com/office/powerpoint/2010/main" val="1099837776"/>
       </p:ext>
     </p:extLst>
   </p:cSld>
@@ -1030,7 +1156,7 @@
           <a:bodyPr/>
           <a:lstStyle/>
           <a:p>
-            <a:fld id="{A963AC9B-4540-4870-B076-ED4637A3BAC5}" type="slidenum">
+            <a:fld id="{67EA2E30-806A-480E-8F92-6D6AC26C6F2A}" type="slidenum">
               <a:rPr lang="zh-CN" altLang="en-US" smtClean="0"/>
               <a:t>13</a:t>
             </a:fld>
@@ -1041,7 +1167,7 @@
     </p:spTree>
     <p:extLst>
       <p:ext uri="{BB962C8B-B14F-4D97-AF65-F5344CB8AC3E}">
-        <p14:creationId xmlns:p14="http://schemas.microsoft.com/office/powerpoint/2010/main" val="234995770"/>
+        <p14:creationId xmlns:p14="http://schemas.microsoft.com/office/powerpoint/2010/main" val="3129303203"/>
       </p:ext>
     </p:extLst>
   </p:cSld>
@@ -1122,7 +1248,7 @@
           <a:bodyPr/>
           <a:lstStyle/>
           <a:p>
-            <a:fld id="{A963AC9B-4540-4870-B076-ED4637A3BAC5}" type="slidenum">
+            <a:fld id="{67EA2E30-806A-480E-8F92-6D6AC26C6F2A}" type="slidenum">
               <a:rPr lang="zh-CN" altLang="en-US" smtClean="0"/>
               <a:t>14</a:t>
             </a:fld>
@@ -1133,7 +1259,7 @@
     </p:spTree>
     <p:extLst>
       <p:ext uri="{BB962C8B-B14F-4D97-AF65-F5344CB8AC3E}">
-        <p14:creationId xmlns:p14="http://schemas.microsoft.com/office/powerpoint/2010/main" val="1714392315"/>
+        <p14:creationId xmlns:p14="http://schemas.microsoft.com/office/powerpoint/2010/main" val="2572412798"/>
       </p:ext>
     </p:extLst>
   </p:cSld>
@@ -1214,7 +1340,7 @@
           <a:bodyPr/>
           <a:lstStyle/>
           <a:p>
-            <a:fld id="{A963AC9B-4540-4870-B076-ED4637A3BAC5}" type="slidenum">
+            <a:fld id="{67EA2E30-806A-480E-8F92-6D6AC26C6F2A}" type="slidenum">
               <a:rPr lang="zh-CN" altLang="en-US" smtClean="0"/>
               <a:t>15</a:t>
             </a:fld>
@@ -1225,7 +1351,7 @@
     </p:spTree>
     <p:extLst>
       <p:ext uri="{BB962C8B-B14F-4D97-AF65-F5344CB8AC3E}">
-        <p14:creationId xmlns:p14="http://schemas.microsoft.com/office/powerpoint/2010/main" val="3435793810"/>
+        <p14:creationId xmlns:p14="http://schemas.microsoft.com/office/powerpoint/2010/main" val="4160256957"/>
       </p:ext>
     </p:extLst>
   </p:cSld>
@@ -1306,7 +1432,7 @@
           <a:bodyPr/>
           <a:lstStyle/>
           <a:p>
-            <a:fld id="{A963AC9B-4540-4870-B076-ED4637A3BAC5}" type="slidenum">
+            <a:fld id="{67EA2E30-806A-480E-8F92-6D6AC26C6F2A}" type="slidenum">
               <a:rPr lang="zh-CN" altLang="en-US" smtClean="0"/>
               <a:t>16</a:t>
             </a:fld>
@@ -1317,7 +1443,7 @@
     </p:spTree>
     <p:extLst>
       <p:ext uri="{BB962C8B-B14F-4D97-AF65-F5344CB8AC3E}">
-        <p14:creationId xmlns:p14="http://schemas.microsoft.com/office/powerpoint/2010/main" val="3117755213"/>
+        <p14:creationId xmlns:p14="http://schemas.microsoft.com/office/powerpoint/2010/main" val="1906727641"/>
       </p:ext>
     </p:extLst>
   </p:cSld>
@@ -1378,25 +1504,7 @@
                 </a:solidFill>
                 <a:latin typeface="Microsoft YaHei" panose="020B0503020204020204" pitchFamily="34" charset="-122"/>
               </a:rPr>
-              <a:t>这一页必须纠正旧版本的 </a:t>
-            </a:r>
-            <a:r>
-              <a:rPr lang="en-US" altLang="zh-CN" sz="1100">
-                <a:solidFill>
-                  <a:srgbClr val="09243D"/>
-                </a:solidFill>
-                <a:latin typeface="Microsoft YaHei" panose="020B0503020204020204" pitchFamily="34" charset="-122"/>
-              </a:rPr>
-              <a:t>50/30/10/10 </a:t>
-            </a:r>
-            <a:r>
-              <a:rPr lang="zh-CN" altLang="en-US" sz="1100">
-                <a:solidFill>
-                  <a:srgbClr val="09243D"/>
-                </a:solidFill>
-                <a:latin typeface="Microsoft YaHei" panose="020B0503020204020204" pitchFamily="34" charset="-122"/>
-              </a:rPr>
-              <a:t>表述。我们现在按官方口径讲：初赛看执行展示和文档，决赛还看现场答辩、过程记录、源码分析、最终方案、</a:t>
+              <a:t>这一页必须纠正旧版本的非官方权重表述。我们现在按官方口径讲：初赛看执行展示和文档，决赛还看现场答辩、过程记录、源码分析、最终方案、</a:t>
             </a:r>
             <a:r>
               <a:rPr lang="en-US" altLang="zh-CN" sz="1100">
@@ -1434,7 +1542,7 @@
           <a:bodyPr/>
           <a:lstStyle/>
           <a:p>
-            <a:fld id="{A963AC9B-4540-4870-B076-ED4637A3BAC5}" type="slidenum">
+            <a:fld id="{67EA2E30-806A-480E-8F92-6D6AC26C6F2A}" type="slidenum">
               <a:rPr lang="zh-CN" altLang="en-US" smtClean="0"/>
               <a:t>2</a:t>
             </a:fld>
@@ -1445,7 +1553,7 @@
     </p:spTree>
     <p:extLst>
       <p:ext uri="{BB962C8B-B14F-4D97-AF65-F5344CB8AC3E}">
-        <p14:creationId xmlns:p14="http://schemas.microsoft.com/office/powerpoint/2010/main" val="3636567788"/>
+        <p14:creationId xmlns:p14="http://schemas.microsoft.com/office/powerpoint/2010/main" val="273412898"/>
       </p:ext>
     </p:extLst>
   </p:cSld>
@@ -1544,7 +1652,7 @@
           <a:bodyPr/>
           <a:lstStyle/>
           <a:p>
-            <a:fld id="{A963AC9B-4540-4870-B076-ED4637A3BAC5}" type="slidenum">
+            <a:fld id="{67EA2E30-806A-480E-8F92-6D6AC26C6F2A}" type="slidenum">
               <a:rPr lang="zh-CN" altLang="en-US" smtClean="0"/>
               <a:t>3</a:t>
             </a:fld>
@@ -1555,7 +1663,7 @@
     </p:spTree>
     <p:extLst>
       <p:ext uri="{BB962C8B-B14F-4D97-AF65-F5344CB8AC3E}">
-        <p14:creationId xmlns:p14="http://schemas.microsoft.com/office/powerpoint/2010/main" val="1854521235"/>
+        <p14:creationId xmlns:p14="http://schemas.microsoft.com/office/powerpoint/2010/main" val="485578811"/>
       </p:ext>
     </p:extLst>
   </p:cSld>
@@ -1726,7 +1834,7 @@
           <a:bodyPr/>
           <a:lstStyle/>
           <a:p>
-            <a:fld id="{A963AC9B-4540-4870-B076-ED4637A3BAC5}" type="slidenum">
+            <a:fld id="{67EA2E30-806A-480E-8F92-6D6AC26C6F2A}" type="slidenum">
               <a:rPr lang="zh-CN" altLang="en-US" smtClean="0"/>
               <a:t>4</a:t>
             </a:fld>
@@ -1737,7 +1845,7 @@
     </p:spTree>
     <p:extLst>
       <p:ext uri="{BB962C8B-B14F-4D97-AF65-F5344CB8AC3E}">
-        <p14:creationId xmlns:p14="http://schemas.microsoft.com/office/powerpoint/2010/main" val="3483014899"/>
+        <p14:creationId xmlns:p14="http://schemas.microsoft.com/office/powerpoint/2010/main" val="3424282355"/>
       </p:ext>
     </p:extLst>
   </p:cSld>
@@ -1908,7 +2016,7 @@
           <a:bodyPr/>
           <a:lstStyle/>
           <a:p>
-            <a:fld id="{A963AC9B-4540-4870-B076-ED4637A3BAC5}" type="slidenum">
+            <a:fld id="{67EA2E30-806A-480E-8F92-6D6AC26C6F2A}" type="slidenum">
               <a:rPr lang="zh-CN" altLang="en-US" smtClean="0"/>
               <a:t>5</a:t>
             </a:fld>
@@ -1919,7 +2027,7 @@
     </p:spTree>
     <p:extLst>
       <p:ext uri="{BB962C8B-B14F-4D97-AF65-F5344CB8AC3E}">
-        <p14:creationId xmlns:p14="http://schemas.microsoft.com/office/powerpoint/2010/main" val="2159605865"/>
+        <p14:creationId xmlns:p14="http://schemas.microsoft.com/office/powerpoint/2010/main" val="84961849"/>
       </p:ext>
     </p:extLst>
   </p:cSld>
@@ -2045,7 +2153,7 @@
           <a:bodyPr/>
           <a:lstStyle/>
           <a:p>
-            <a:fld id="{A963AC9B-4540-4870-B076-ED4637A3BAC5}" type="slidenum">
+            <a:fld id="{67EA2E30-806A-480E-8F92-6D6AC26C6F2A}" type="slidenum">
               <a:rPr lang="zh-CN" altLang="en-US" smtClean="0"/>
               <a:t>6</a:t>
             </a:fld>
@@ -2056,7 +2164,7 @@
     </p:spTree>
     <p:extLst>
       <p:ext uri="{BB962C8B-B14F-4D97-AF65-F5344CB8AC3E}">
-        <p14:creationId xmlns:p14="http://schemas.microsoft.com/office/powerpoint/2010/main" val="1348221030"/>
+        <p14:creationId xmlns:p14="http://schemas.microsoft.com/office/powerpoint/2010/main" val="1630411214"/>
       </p:ext>
     </p:extLst>
   </p:cSld>
@@ -2200,7 +2308,7 @@
           <a:bodyPr/>
           <a:lstStyle/>
           <a:p>
-            <a:fld id="{A963AC9B-4540-4870-B076-ED4637A3BAC5}" type="slidenum">
+            <a:fld id="{67EA2E30-806A-480E-8F92-6D6AC26C6F2A}" type="slidenum">
               <a:rPr lang="zh-CN" altLang="en-US" smtClean="0"/>
               <a:t>7</a:t>
             </a:fld>
@@ -2211,7 +2319,7 @@
     </p:spTree>
     <p:extLst>
       <p:ext uri="{BB962C8B-B14F-4D97-AF65-F5344CB8AC3E}">
-        <p14:creationId xmlns:p14="http://schemas.microsoft.com/office/powerpoint/2010/main" val="1712649939"/>
+        <p14:creationId xmlns:p14="http://schemas.microsoft.com/office/powerpoint/2010/main" val="3947409130"/>
       </p:ext>
     </p:extLst>
   </p:cSld>
@@ -2364,7 +2472,7 @@
           <a:bodyPr/>
           <a:lstStyle/>
           <a:p>
-            <a:fld id="{A963AC9B-4540-4870-B076-ED4637A3BAC5}" type="slidenum">
+            <a:fld id="{67EA2E30-806A-480E-8F92-6D6AC26C6F2A}" type="slidenum">
               <a:rPr lang="zh-CN" altLang="en-US" smtClean="0"/>
               <a:t>8</a:t>
             </a:fld>
@@ -2375,7 +2483,7 @@
     </p:spTree>
     <p:extLst>
       <p:ext uri="{BB962C8B-B14F-4D97-AF65-F5344CB8AC3E}">
-        <p14:creationId xmlns:p14="http://schemas.microsoft.com/office/powerpoint/2010/main" val="3429464616"/>
+        <p14:creationId xmlns:p14="http://schemas.microsoft.com/office/powerpoint/2010/main" val="1531965844"/>
       </p:ext>
     </p:extLst>
   </p:cSld>
@@ -2582,7 +2690,7 @@
           <a:bodyPr/>
           <a:lstStyle/>
           <a:p>
-            <a:fld id="{A963AC9B-4540-4870-B076-ED4637A3BAC5}" type="slidenum">
+            <a:fld id="{67EA2E30-806A-480E-8F92-6D6AC26C6F2A}" type="slidenum">
               <a:rPr lang="zh-CN" altLang="en-US" smtClean="0"/>
               <a:t>9</a:t>
             </a:fld>
@@ -2593,7 +2701,7 @@
     </p:spTree>
     <p:extLst>
       <p:ext uri="{BB962C8B-B14F-4D97-AF65-F5344CB8AC3E}">
-        <p14:creationId xmlns:p14="http://schemas.microsoft.com/office/powerpoint/2010/main" val="1412085405"/>
+        <p14:creationId xmlns:p14="http://schemas.microsoft.com/office/powerpoint/2010/main" val="3622560902"/>
       </p:ext>
     </p:extLst>
   </p:cSld>
@@ -2625,7 +2733,7 @@
           <p:cNvPr id="2" name="标题 1">
             <a:extLst>
               <a:ext uri="{FF2B5EF4-FFF2-40B4-BE49-F238E27FC236}">
-                <a16:creationId xmlns:a16="http://schemas.microsoft.com/office/drawing/2014/main" id="{BBBAB6D0-8FB6-A822-8395-E69D0428B822}"/>
+                <a16:creationId xmlns:a16="http://schemas.microsoft.com/office/drawing/2014/main" id="{98168855-CCBD-3EB7-D80C-A8CB8074C58C}"/>
               </a:ext>
             </a:extLst>
           </p:cNvPr>
@@ -2662,7 +2770,7 @@
           <p:cNvPr id="3" name="副标题 2">
             <a:extLst>
               <a:ext uri="{FF2B5EF4-FFF2-40B4-BE49-F238E27FC236}">
-                <a16:creationId xmlns:a16="http://schemas.microsoft.com/office/drawing/2014/main" id="{97B45B50-5212-A084-488D-88E0A5DB856D}"/>
+                <a16:creationId xmlns:a16="http://schemas.microsoft.com/office/drawing/2014/main" id="{3BB2D522-4F05-424E-B6AA-71817B21FB49}"/>
               </a:ext>
             </a:extLst>
           </p:cNvPr>
@@ -2732,7 +2840,7 @@
           <p:cNvPr id="4" name="日期占位符 3">
             <a:extLst>
               <a:ext uri="{FF2B5EF4-FFF2-40B4-BE49-F238E27FC236}">
-                <a16:creationId xmlns:a16="http://schemas.microsoft.com/office/drawing/2014/main" id="{D0BF3300-B7CE-D9B3-D994-7855622995CC}"/>
+                <a16:creationId xmlns:a16="http://schemas.microsoft.com/office/drawing/2014/main" id="{C3519304-122F-0015-5DA2-84AA9934ACC5}"/>
               </a:ext>
             </a:extLst>
           </p:cNvPr>
@@ -2748,7 +2856,7 @@
           <a:bodyPr/>
           <a:lstStyle/>
           <a:p>
-            <a:fld id="{A66D2391-A4DD-43E6-B9B0-4ECCF2FB388B}" type="datetimeFigureOut">
+            <a:fld id="{BCA83E38-FE1A-46D7-AAB8-6C2A5536F75A}" type="datetimeFigureOut">
               <a:rPr lang="zh-CN" altLang="en-US" smtClean="0"/>
               <a:t>2026/6/11</a:t>
             </a:fld>
@@ -2761,7 +2869,7 @@
           <p:cNvPr id="5" name="页脚占位符 4">
             <a:extLst>
               <a:ext uri="{FF2B5EF4-FFF2-40B4-BE49-F238E27FC236}">
-                <a16:creationId xmlns:a16="http://schemas.microsoft.com/office/drawing/2014/main" id="{DE5665CE-7BD0-BAED-22DF-E8571FDD121C}"/>
+                <a16:creationId xmlns:a16="http://schemas.microsoft.com/office/drawing/2014/main" id="{9B582E84-3D4C-9F5B-C3A9-425DD9D110DF}"/>
               </a:ext>
             </a:extLst>
           </p:cNvPr>
@@ -2786,7 +2894,7 @@
           <p:cNvPr id="6" name="灯片编号占位符 5">
             <a:extLst>
               <a:ext uri="{FF2B5EF4-FFF2-40B4-BE49-F238E27FC236}">
-                <a16:creationId xmlns:a16="http://schemas.microsoft.com/office/drawing/2014/main" id="{A5262210-A1F5-706B-25FB-E8E26C133E73}"/>
+                <a16:creationId xmlns:a16="http://schemas.microsoft.com/office/drawing/2014/main" id="{9C0E8243-5800-BC57-7F8D-D8E904C9C410}"/>
               </a:ext>
             </a:extLst>
           </p:cNvPr>
@@ -2802,7 +2910,7 @@
           <a:bodyPr/>
           <a:lstStyle/>
           <a:p>
-            <a:fld id="{233D886B-2453-4F0C-A339-24213FCE6F2F}" type="slidenum">
+            <a:fld id="{9DD4CD2A-584A-455B-ADD7-345520253A92}" type="slidenum">
               <a:rPr lang="zh-CN" altLang="en-US" smtClean="0"/>
               <a:t>‹#›</a:t>
             </a:fld>
@@ -2813,7 +2921,7 @@
     </p:spTree>
     <p:extLst>
       <p:ext uri="{BB962C8B-B14F-4D97-AF65-F5344CB8AC3E}">
-        <p14:creationId xmlns:p14="http://schemas.microsoft.com/office/powerpoint/2010/main" val="686228384"/>
+        <p14:creationId xmlns:p14="http://schemas.microsoft.com/office/powerpoint/2010/main" val="1783749646"/>
       </p:ext>
     </p:extLst>
   </p:cSld>
@@ -2845,7 +2953,7 @@
           <p:cNvPr id="2" name="标题 1">
             <a:extLst>
               <a:ext uri="{FF2B5EF4-FFF2-40B4-BE49-F238E27FC236}">
-                <a16:creationId xmlns:a16="http://schemas.microsoft.com/office/drawing/2014/main" id="{6270A85F-82B3-E31A-8E9A-AAE49B0DDD56}"/>
+                <a16:creationId xmlns:a16="http://schemas.microsoft.com/office/drawing/2014/main" id="{37F16A1B-253D-44E0-ED39-7B37CD389085}"/>
               </a:ext>
             </a:extLst>
           </p:cNvPr>
@@ -2873,7 +2981,7 @@
           <p:cNvPr id="3" name="竖排文字占位符 2">
             <a:extLst>
               <a:ext uri="{FF2B5EF4-FFF2-40B4-BE49-F238E27FC236}">
-                <a16:creationId xmlns:a16="http://schemas.microsoft.com/office/drawing/2014/main" id="{AA52C733-1D66-32A0-5838-CBA823C1E414}"/>
+                <a16:creationId xmlns:a16="http://schemas.microsoft.com/office/drawing/2014/main" id="{6DB2CA4A-18F4-78F6-DD47-8A7E613E1766}"/>
               </a:ext>
             </a:extLst>
           </p:cNvPr>
@@ -2930,7 +3038,7 @@
           <p:cNvPr id="4" name="日期占位符 3">
             <a:extLst>
               <a:ext uri="{FF2B5EF4-FFF2-40B4-BE49-F238E27FC236}">
-                <a16:creationId xmlns:a16="http://schemas.microsoft.com/office/drawing/2014/main" id="{C87E72A4-4B4D-3A68-21C0-D546605CBE30}"/>
+                <a16:creationId xmlns:a16="http://schemas.microsoft.com/office/drawing/2014/main" id="{51BE2741-84F4-6094-41B2-A4700982F7B1}"/>
               </a:ext>
             </a:extLst>
           </p:cNvPr>
@@ -2946,7 +3054,7 @@
           <a:bodyPr/>
           <a:lstStyle/>
           <a:p>
-            <a:fld id="{A66D2391-A4DD-43E6-B9B0-4ECCF2FB388B}" type="datetimeFigureOut">
+            <a:fld id="{BCA83E38-FE1A-46D7-AAB8-6C2A5536F75A}" type="datetimeFigureOut">
               <a:rPr lang="zh-CN" altLang="en-US" smtClean="0"/>
               <a:t>2026/6/11</a:t>
             </a:fld>
@@ -2959,7 +3067,7 @@
           <p:cNvPr id="5" name="页脚占位符 4">
             <a:extLst>
               <a:ext uri="{FF2B5EF4-FFF2-40B4-BE49-F238E27FC236}">
-                <a16:creationId xmlns:a16="http://schemas.microsoft.com/office/drawing/2014/main" id="{FD05261C-EDEB-E9D1-57F0-995C2FC5B135}"/>
+                <a16:creationId xmlns:a16="http://schemas.microsoft.com/office/drawing/2014/main" id="{928A572D-91D3-EC73-D4AD-006B5B3A1CEE}"/>
               </a:ext>
             </a:extLst>
           </p:cNvPr>
@@ -2984,7 +3092,7 @@
           <p:cNvPr id="6" name="灯片编号占位符 5">
             <a:extLst>
               <a:ext uri="{FF2B5EF4-FFF2-40B4-BE49-F238E27FC236}">
-                <a16:creationId xmlns:a16="http://schemas.microsoft.com/office/drawing/2014/main" id="{1F10B000-8CFF-7470-4E58-6E34E1D362D1}"/>
+                <a16:creationId xmlns:a16="http://schemas.microsoft.com/office/drawing/2014/main" id="{715C5B6F-C95A-E91D-2826-0AB6B47C28E2}"/>
               </a:ext>
             </a:extLst>
           </p:cNvPr>
@@ -3000,7 +3108,7 @@
           <a:bodyPr/>
           <a:lstStyle/>
           <a:p>
-            <a:fld id="{233D886B-2453-4F0C-A339-24213FCE6F2F}" type="slidenum">
+            <a:fld id="{9DD4CD2A-584A-455B-ADD7-345520253A92}" type="slidenum">
               <a:rPr lang="zh-CN" altLang="en-US" smtClean="0"/>
               <a:t>‹#›</a:t>
             </a:fld>
@@ -3011,7 +3119,7 @@
     </p:spTree>
     <p:extLst>
       <p:ext uri="{BB962C8B-B14F-4D97-AF65-F5344CB8AC3E}">
-        <p14:creationId xmlns:p14="http://schemas.microsoft.com/office/powerpoint/2010/main" val="3112276077"/>
+        <p14:creationId xmlns:p14="http://schemas.microsoft.com/office/powerpoint/2010/main" val="289763170"/>
       </p:ext>
     </p:extLst>
   </p:cSld>
@@ -3043,7 +3151,7 @@
           <p:cNvPr id="2" name="竖排标题 1">
             <a:extLst>
               <a:ext uri="{FF2B5EF4-FFF2-40B4-BE49-F238E27FC236}">
-                <a16:creationId xmlns:a16="http://schemas.microsoft.com/office/drawing/2014/main" id="{95D8879E-68C5-A1A7-DCFA-5042B3D9BB78}"/>
+                <a16:creationId xmlns:a16="http://schemas.microsoft.com/office/drawing/2014/main" id="{8B657317-C372-4BE5-D559-5CC42F0248D2}"/>
               </a:ext>
             </a:extLst>
           </p:cNvPr>
@@ -3076,7 +3184,7 @@
           <p:cNvPr id="3" name="竖排文字占位符 2">
             <a:extLst>
               <a:ext uri="{FF2B5EF4-FFF2-40B4-BE49-F238E27FC236}">
-                <a16:creationId xmlns:a16="http://schemas.microsoft.com/office/drawing/2014/main" id="{5C595B6D-2E9C-D947-687A-B0E534BACAE4}"/>
+                <a16:creationId xmlns:a16="http://schemas.microsoft.com/office/drawing/2014/main" id="{E62C7B1E-7FEA-D777-8841-DF15CAA1ED7F}"/>
               </a:ext>
             </a:extLst>
           </p:cNvPr>
@@ -3138,7 +3246,7 @@
           <p:cNvPr id="4" name="日期占位符 3">
             <a:extLst>
               <a:ext uri="{FF2B5EF4-FFF2-40B4-BE49-F238E27FC236}">
-                <a16:creationId xmlns:a16="http://schemas.microsoft.com/office/drawing/2014/main" id="{5AD4215D-E3D8-4BC5-E042-DBEC9E1BA79E}"/>
+                <a16:creationId xmlns:a16="http://schemas.microsoft.com/office/drawing/2014/main" id="{A69D10DD-5192-9DB1-5010-66907CED95F1}"/>
               </a:ext>
             </a:extLst>
           </p:cNvPr>
@@ -3154,7 +3262,7 @@
           <a:bodyPr/>
           <a:lstStyle/>
           <a:p>
-            <a:fld id="{A66D2391-A4DD-43E6-B9B0-4ECCF2FB388B}" type="datetimeFigureOut">
+            <a:fld id="{BCA83E38-FE1A-46D7-AAB8-6C2A5536F75A}" type="datetimeFigureOut">
               <a:rPr lang="zh-CN" altLang="en-US" smtClean="0"/>
               <a:t>2026/6/11</a:t>
             </a:fld>
@@ -3167,7 +3275,7 @@
           <p:cNvPr id="5" name="页脚占位符 4">
             <a:extLst>
               <a:ext uri="{FF2B5EF4-FFF2-40B4-BE49-F238E27FC236}">
-                <a16:creationId xmlns:a16="http://schemas.microsoft.com/office/drawing/2014/main" id="{920354D1-7686-7CDC-236D-E209A9E668C5}"/>
+                <a16:creationId xmlns:a16="http://schemas.microsoft.com/office/drawing/2014/main" id="{F9A45D31-DA46-97D5-2774-7F71C152AE64}"/>
               </a:ext>
             </a:extLst>
           </p:cNvPr>
@@ -3192,7 +3300,7 @@
           <p:cNvPr id="6" name="灯片编号占位符 5">
             <a:extLst>
               <a:ext uri="{FF2B5EF4-FFF2-40B4-BE49-F238E27FC236}">
-                <a16:creationId xmlns:a16="http://schemas.microsoft.com/office/drawing/2014/main" id="{F8BE1CC4-F4EB-D169-D705-432C4CE041D1}"/>
+                <a16:creationId xmlns:a16="http://schemas.microsoft.com/office/drawing/2014/main" id="{16A9F4D9-47F1-771C-9C8A-0B7EF2C7A3CF}"/>
               </a:ext>
             </a:extLst>
           </p:cNvPr>
@@ -3208,7 +3316,7 @@
           <a:bodyPr/>
           <a:lstStyle/>
           <a:p>
-            <a:fld id="{233D886B-2453-4F0C-A339-24213FCE6F2F}" type="slidenum">
+            <a:fld id="{9DD4CD2A-584A-455B-ADD7-345520253A92}" type="slidenum">
               <a:rPr lang="zh-CN" altLang="en-US" smtClean="0"/>
               <a:t>‹#›</a:t>
             </a:fld>
@@ -3219,7 +3327,7 @@
     </p:spTree>
     <p:extLst>
       <p:ext uri="{BB962C8B-B14F-4D97-AF65-F5344CB8AC3E}">
-        <p14:creationId xmlns:p14="http://schemas.microsoft.com/office/powerpoint/2010/main" val="1516463186"/>
+        <p14:creationId xmlns:p14="http://schemas.microsoft.com/office/powerpoint/2010/main" val="3304785534"/>
       </p:ext>
     </p:extLst>
   </p:cSld>
@@ -3251,7 +3359,7 @@
           <p:cNvPr id="2" name="标题 1">
             <a:extLst>
               <a:ext uri="{FF2B5EF4-FFF2-40B4-BE49-F238E27FC236}">
-                <a16:creationId xmlns:a16="http://schemas.microsoft.com/office/drawing/2014/main" id="{0EC5B78C-73C9-0560-C6E8-096D0B26D81B}"/>
+                <a16:creationId xmlns:a16="http://schemas.microsoft.com/office/drawing/2014/main" id="{D740502F-50DE-7058-0790-D128256EF672}"/>
               </a:ext>
             </a:extLst>
           </p:cNvPr>
@@ -3279,7 +3387,7 @@
           <p:cNvPr id="3" name="内容占位符 2">
             <a:extLst>
               <a:ext uri="{FF2B5EF4-FFF2-40B4-BE49-F238E27FC236}">
-                <a16:creationId xmlns:a16="http://schemas.microsoft.com/office/drawing/2014/main" id="{1E45BE94-059E-A8AA-D2B1-0AFE76771AC1}"/>
+                <a16:creationId xmlns:a16="http://schemas.microsoft.com/office/drawing/2014/main" id="{FA1796B7-16FC-102C-B7E8-BFA20AE57304}"/>
               </a:ext>
             </a:extLst>
           </p:cNvPr>
@@ -3336,7 +3444,7 @@
           <p:cNvPr id="4" name="日期占位符 3">
             <a:extLst>
               <a:ext uri="{FF2B5EF4-FFF2-40B4-BE49-F238E27FC236}">
-                <a16:creationId xmlns:a16="http://schemas.microsoft.com/office/drawing/2014/main" id="{62CB9224-624C-4BAE-FD37-7D2CA0C8A047}"/>
+                <a16:creationId xmlns:a16="http://schemas.microsoft.com/office/drawing/2014/main" id="{2B72B3FF-CD8D-7469-A96A-DDF16645F50B}"/>
               </a:ext>
             </a:extLst>
           </p:cNvPr>
@@ -3352,7 +3460,7 @@
           <a:bodyPr/>
           <a:lstStyle/>
           <a:p>
-            <a:fld id="{A66D2391-A4DD-43E6-B9B0-4ECCF2FB388B}" type="datetimeFigureOut">
+            <a:fld id="{BCA83E38-FE1A-46D7-AAB8-6C2A5536F75A}" type="datetimeFigureOut">
               <a:rPr lang="zh-CN" altLang="en-US" smtClean="0"/>
               <a:t>2026/6/11</a:t>
             </a:fld>
@@ -3365,7 +3473,7 @@
           <p:cNvPr id="5" name="页脚占位符 4">
             <a:extLst>
               <a:ext uri="{FF2B5EF4-FFF2-40B4-BE49-F238E27FC236}">
-                <a16:creationId xmlns:a16="http://schemas.microsoft.com/office/drawing/2014/main" id="{2CC192EE-D4A8-3968-F2B0-295C7333119B}"/>
+                <a16:creationId xmlns:a16="http://schemas.microsoft.com/office/drawing/2014/main" id="{DA521682-7E74-B6E8-5F24-7D4DDA1ED09A}"/>
               </a:ext>
             </a:extLst>
           </p:cNvPr>
@@ -3390,7 +3498,7 @@
           <p:cNvPr id="6" name="灯片编号占位符 5">
             <a:extLst>
               <a:ext uri="{FF2B5EF4-FFF2-40B4-BE49-F238E27FC236}">
-                <a16:creationId xmlns:a16="http://schemas.microsoft.com/office/drawing/2014/main" id="{2144EE77-90FB-7A4E-8CAA-ED557FF00602}"/>
+                <a16:creationId xmlns:a16="http://schemas.microsoft.com/office/drawing/2014/main" id="{9987F4E5-2835-A365-F15B-6B0C58588F22}"/>
               </a:ext>
             </a:extLst>
           </p:cNvPr>
@@ -3406,7 +3514,7 @@
           <a:bodyPr/>
           <a:lstStyle/>
           <a:p>
-            <a:fld id="{233D886B-2453-4F0C-A339-24213FCE6F2F}" type="slidenum">
+            <a:fld id="{9DD4CD2A-584A-455B-ADD7-345520253A92}" type="slidenum">
               <a:rPr lang="zh-CN" altLang="en-US" smtClean="0"/>
               <a:t>‹#›</a:t>
             </a:fld>
@@ -3417,7 +3525,7 @@
     </p:spTree>
     <p:extLst>
       <p:ext uri="{BB962C8B-B14F-4D97-AF65-F5344CB8AC3E}">
-        <p14:creationId xmlns:p14="http://schemas.microsoft.com/office/powerpoint/2010/main" val="4170069407"/>
+        <p14:creationId xmlns:p14="http://schemas.microsoft.com/office/powerpoint/2010/main" val="444506625"/>
       </p:ext>
     </p:extLst>
   </p:cSld>
@@ -3449,7 +3557,7 @@
           <p:cNvPr id="2" name="标题 1">
             <a:extLst>
               <a:ext uri="{FF2B5EF4-FFF2-40B4-BE49-F238E27FC236}">
-                <a16:creationId xmlns:a16="http://schemas.microsoft.com/office/drawing/2014/main" id="{DD421844-05C1-D672-193D-E6CFC7FBF675}"/>
+                <a16:creationId xmlns:a16="http://schemas.microsoft.com/office/drawing/2014/main" id="{22646FD1-57C7-D061-3E36-B923337977B8}"/>
               </a:ext>
             </a:extLst>
           </p:cNvPr>
@@ -3486,7 +3594,7 @@
           <p:cNvPr id="3" name="文本占位符 2">
             <a:extLst>
               <a:ext uri="{FF2B5EF4-FFF2-40B4-BE49-F238E27FC236}">
-                <a16:creationId xmlns:a16="http://schemas.microsoft.com/office/drawing/2014/main" id="{70DA4474-FB94-92D6-B170-CB993DE2B55E}"/>
+                <a16:creationId xmlns:a16="http://schemas.microsoft.com/office/drawing/2014/main" id="{0FADD52B-B5AA-E297-F330-57333441B5F0}"/>
               </a:ext>
             </a:extLst>
           </p:cNvPr>
@@ -3611,7 +3719,7 @@
           <p:cNvPr id="4" name="日期占位符 3">
             <a:extLst>
               <a:ext uri="{FF2B5EF4-FFF2-40B4-BE49-F238E27FC236}">
-                <a16:creationId xmlns:a16="http://schemas.microsoft.com/office/drawing/2014/main" id="{E3A81231-9803-E8FA-F4BE-E210E993C7F1}"/>
+                <a16:creationId xmlns:a16="http://schemas.microsoft.com/office/drawing/2014/main" id="{C8B57D13-C1B3-A9CA-581B-0642446F3173}"/>
               </a:ext>
             </a:extLst>
           </p:cNvPr>
@@ -3627,7 +3735,7 @@
           <a:bodyPr/>
           <a:lstStyle/>
           <a:p>
-            <a:fld id="{A66D2391-A4DD-43E6-B9B0-4ECCF2FB388B}" type="datetimeFigureOut">
+            <a:fld id="{BCA83E38-FE1A-46D7-AAB8-6C2A5536F75A}" type="datetimeFigureOut">
               <a:rPr lang="zh-CN" altLang="en-US" smtClean="0"/>
               <a:t>2026/6/11</a:t>
             </a:fld>
@@ -3640,7 +3748,7 @@
           <p:cNvPr id="5" name="页脚占位符 4">
             <a:extLst>
               <a:ext uri="{FF2B5EF4-FFF2-40B4-BE49-F238E27FC236}">
-                <a16:creationId xmlns:a16="http://schemas.microsoft.com/office/drawing/2014/main" id="{A2F4EFA8-B418-8756-E6DD-E9D99665B3C4}"/>
+                <a16:creationId xmlns:a16="http://schemas.microsoft.com/office/drawing/2014/main" id="{49329875-BFFB-F0A6-48CD-734225E67063}"/>
               </a:ext>
             </a:extLst>
           </p:cNvPr>
@@ -3665,7 +3773,7 @@
           <p:cNvPr id="6" name="灯片编号占位符 5">
             <a:extLst>
               <a:ext uri="{FF2B5EF4-FFF2-40B4-BE49-F238E27FC236}">
-                <a16:creationId xmlns:a16="http://schemas.microsoft.com/office/drawing/2014/main" id="{32909F60-335C-A687-5CE1-D895BCFB6B0D}"/>
+                <a16:creationId xmlns:a16="http://schemas.microsoft.com/office/drawing/2014/main" id="{9203AB45-02FF-83D0-6AB0-4AD955296E7C}"/>
               </a:ext>
             </a:extLst>
           </p:cNvPr>
@@ -3681,7 +3789,7 @@
           <a:bodyPr/>
           <a:lstStyle/>
           <a:p>
-            <a:fld id="{233D886B-2453-4F0C-A339-24213FCE6F2F}" type="slidenum">
+            <a:fld id="{9DD4CD2A-584A-455B-ADD7-345520253A92}" type="slidenum">
               <a:rPr lang="zh-CN" altLang="en-US" smtClean="0"/>
               <a:t>‹#›</a:t>
             </a:fld>
@@ -3692,7 +3800,7 @@
     </p:spTree>
     <p:extLst>
       <p:ext uri="{BB962C8B-B14F-4D97-AF65-F5344CB8AC3E}">
-        <p14:creationId xmlns:p14="http://schemas.microsoft.com/office/powerpoint/2010/main" val="1295544454"/>
+        <p14:creationId xmlns:p14="http://schemas.microsoft.com/office/powerpoint/2010/main" val="3693064327"/>
       </p:ext>
     </p:extLst>
   </p:cSld>
@@ -3724,7 +3832,7 @@
           <p:cNvPr id="2" name="标题 1">
             <a:extLst>
               <a:ext uri="{FF2B5EF4-FFF2-40B4-BE49-F238E27FC236}">
-                <a16:creationId xmlns:a16="http://schemas.microsoft.com/office/drawing/2014/main" id="{35746585-39AF-FD81-212B-4F0944EB9BA7}"/>
+                <a16:creationId xmlns:a16="http://schemas.microsoft.com/office/drawing/2014/main" id="{3450C9BA-6644-AEB0-622F-C84A52FF18F3}"/>
               </a:ext>
             </a:extLst>
           </p:cNvPr>
@@ -3752,7 +3860,7 @@
           <p:cNvPr id="3" name="内容占位符 2">
             <a:extLst>
               <a:ext uri="{FF2B5EF4-FFF2-40B4-BE49-F238E27FC236}">
-                <a16:creationId xmlns:a16="http://schemas.microsoft.com/office/drawing/2014/main" id="{5A611AEE-C5C0-0072-239F-087124544DC5}"/>
+                <a16:creationId xmlns:a16="http://schemas.microsoft.com/office/drawing/2014/main" id="{4F5BF811-D9FA-24DF-1733-1C5B3A72F9C2}"/>
               </a:ext>
             </a:extLst>
           </p:cNvPr>
@@ -3814,7 +3922,7 @@
           <p:cNvPr id="4" name="内容占位符 3">
             <a:extLst>
               <a:ext uri="{FF2B5EF4-FFF2-40B4-BE49-F238E27FC236}">
-                <a16:creationId xmlns:a16="http://schemas.microsoft.com/office/drawing/2014/main" id="{04C3563B-6D1B-C45F-924C-B5D5DE273304}"/>
+                <a16:creationId xmlns:a16="http://schemas.microsoft.com/office/drawing/2014/main" id="{0C677C67-D1C2-3F4A-D213-5B8B1C5A0533}"/>
               </a:ext>
             </a:extLst>
           </p:cNvPr>
@@ -3876,7 +3984,7 @@
           <p:cNvPr id="5" name="日期占位符 4">
             <a:extLst>
               <a:ext uri="{FF2B5EF4-FFF2-40B4-BE49-F238E27FC236}">
-                <a16:creationId xmlns:a16="http://schemas.microsoft.com/office/drawing/2014/main" id="{A50BAB22-B2FB-03FA-B652-7E90ACE76C70}"/>
+                <a16:creationId xmlns:a16="http://schemas.microsoft.com/office/drawing/2014/main" id="{49D88583-ADB0-5152-D43A-BFB2B274DF6A}"/>
               </a:ext>
             </a:extLst>
           </p:cNvPr>
@@ -3892,7 +4000,7 @@
           <a:bodyPr/>
           <a:lstStyle/>
           <a:p>
-            <a:fld id="{A66D2391-A4DD-43E6-B9B0-4ECCF2FB388B}" type="datetimeFigureOut">
+            <a:fld id="{BCA83E38-FE1A-46D7-AAB8-6C2A5536F75A}" type="datetimeFigureOut">
               <a:rPr lang="zh-CN" altLang="en-US" smtClean="0"/>
               <a:t>2026/6/11</a:t>
             </a:fld>
@@ -3905,7 +4013,7 @@
           <p:cNvPr id="6" name="页脚占位符 5">
             <a:extLst>
               <a:ext uri="{FF2B5EF4-FFF2-40B4-BE49-F238E27FC236}">
-                <a16:creationId xmlns:a16="http://schemas.microsoft.com/office/drawing/2014/main" id="{7362FA74-A0C9-16AA-D7A8-5E996330B54B}"/>
+                <a16:creationId xmlns:a16="http://schemas.microsoft.com/office/drawing/2014/main" id="{42169E9D-6C5D-8D26-136E-D90A3520FCC3}"/>
               </a:ext>
             </a:extLst>
           </p:cNvPr>
@@ -3930,7 +4038,7 @@
           <p:cNvPr id="7" name="灯片编号占位符 6">
             <a:extLst>
               <a:ext uri="{FF2B5EF4-FFF2-40B4-BE49-F238E27FC236}">
-                <a16:creationId xmlns:a16="http://schemas.microsoft.com/office/drawing/2014/main" id="{796C6736-B0FF-3396-43E5-6A8985D6BBB2}"/>
+                <a16:creationId xmlns:a16="http://schemas.microsoft.com/office/drawing/2014/main" id="{D2C4FF7C-38BC-46C9-5859-9D3AE9CAB797}"/>
               </a:ext>
             </a:extLst>
           </p:cNvPr>
@@ -3946,7 +4054,7 @@
           <a:bodyPr/>
           <a:lstStyle/>
           <a:p>
-            <a:fld id="{233D886B-2453-4F0C-A339-24213FCE6F2F}" type="slidenum">
+            <a:fld id="{9DD4CD2A-584A-455B-ADD7-345520253A92}" type="slidenum">
               <a:rPr lang="zh-CN" altLang="en-US" smtClean="0"/>
               <a:t>‹#›</a:t>
             </a:fld>
@@ -3957,7 +4065,7 @@
     </p:spTree>
     <p:extLst>
       <p:ext uri="{BB962C8B-B14F-4D97-AF65-F5344CB8AC3E}">
-        <p14:creationId xmlns:p14="http://schemas.microsoft.com/office/powerpoint/2010/main" val="2595254360"/>
+        <p14:creationId xmlns:p14="http://schemas.microsoft.com/office/powerpoint/2010/main" val="4031751101"/>
       </p:ext>
     </p:extLst>
   </p:cSld>
@@ -3989,7 +4097,7 @@
           <p:cNvPr id="2" name="标题 1">
             <a:extLst>
               <a:ext uri="{FF2B5EF4-FFF2-40B4-BE49-F238E27FC236}">
-                <a16:creationId xmlns:a16="http://schemas.microsoft.com/office/drawing/2014/main" id="{47067ED4-9654-296C-2B15-842DD853073B}"/>
+                <a16:creationId xmlns:a16="http://schemas.microsoft.com/office/drawing/2014/main" id="{C006542E-6A76-CBFF-05C9-77863D195026}"/>
               </a:ext>
             </a:extLst>
           </p:cNvPr>
@@ -4022,7 +4130,7 @@
           <p:cNvPr id="3" name="文本占位符 2">
             <a:extLst>
               <a:ext uri="{FF2B5EF4-FFF2-40B4-BE49-F238E27FC236}">
-                <a16:creationId xmlns:a16="http://schemas.microsoft.com/office/drawing/2014/main" id="{FE1717A7-A287-AA44-4E2C-FBAB732CD620}"/>
+                <a16:creationId xmlns:a16="http://schemas.microsoft.com/office/drawing/2014/main" id="{9435F6B6-04C8-107A-C87B-74B3D7448A8F}"/>
               </a:ext>
             </a:extLst>
           </p:cNvPr>
@@ -4093,7 +4201,7 @@
           <p:cNvPr id="4" name="内容占位符 3">
             <a:extLst>
               <a:ext uri="{FF2B5EF4-FFF2-40B4-BE49-F238E27FC236}">
-                <a16:creationId xmlns:a16="http://schemas.microsoft.com/office/drawing/2014/main" id="{46DADE8D-0DD5-7970-2D1D-A39F68662312}"/>
+                <a16:creationId xmlns:a16="http://schemas.microsoft.com/office/drawing/2014/main" id="{DCD014C7-A42D-4143-E048-98CB8A6EE82C}"/>
               </a:ext>
             </a:extLst>
           </p:cNvPr>
@@ -4155,7 +4263,7 @@
           <p:cNvPr id="5" name="文本占位符 4">
             <a:extLst>
               <a:ext uri="{FF2B5EF4-FFF2-40B4-BE49-F238E27FC236}">
-                <a16:creationId xmlns:a16="http://schemas.microsoft.com/office/drawing/2014/main" id="{CE3228AA-034B-FE12-3F90-699DD3484382}"/>
+                <a16:creationId xmlns:a16="http://schemas.microsoft.com/office/drawing/2014/main" id="{E76DA2DC-6C50-CB20-C074-7DCE260F33D7}"/>
               </a:ext>
             </a:extLst>
           </p:cNvPr>
@@ -4226,7 +4334,7 @@
           <p:cNvPr id="6" name="内容占位符 5">
             <a:extLst>
               <a:ext uri="{FF2B5EF4-FFF2-40B4-BE49-F238E27FC236}">
-                <a16:creationId xmlns:a16="http://schemas.microsoft.com/office/drawing/2014/main" id="{CA7C5C5F-D2C5-604F-FB5C-C27462F8B3F2}"/>
+                <a16:creationId xmlns:a16="http://schemas.microsoft.com/office/drawing/2014/main" id="{F476644F-0A9A-7787-D3DE-9599FE9FD141}"/>
               </a:ext>
             </a:extLst>
           </p:cNvPr>
@@ -4288,7 +4396,7 @@
           <p:cNvPr id="7" name="日期占位符 6">
             <a:extLst>
               <a:ext uri="{FF2B5EF4-FFF2-40B4-BE49-F238E27FC236}">
-                <a16:creationId xmlns:a16="http://schemas.microsoft.com/office/drawing/2014/main" id="{84F33C2E-573B-2D60-4A35-4973D4672684}"/>
+                <a16:creationId xmlns:a16="http://schemas.microsoft.com/office/drawing/2014/main" id="{D6A2D558-BF2B-ECA2-4502-D726B27F08E8}"/>
               </a:ext>
             </a:extLst>
           </p:cNvPr>
@@ -4304,7 +4412,7 @@
           <a:bodyPr/>
           <a:lstStyle/>
           <a:p>
-            <a:fld id="{A66D2391-A4DD-43E6-B9B0-4ECCF2FB388B}" type="datetimeFigureOut">
+            <a:fld id="{BCA83E38-FE1A-46D7-AAB8-6C2A5536F75A}" type="datetimeFigureOut">
               <a:rPr lang="zh-CN" altLang="en-US" smtClean="0"/>
               <a:t>2026/6/11</a:t>
             </a:fld>
@@ -4317,7 +4425,7 @@
           <p:cNvPr id="8" name="页脚占位符 7">
             <a:extLst>
               <a:ext uri="{FF2B5EF4-FFF2-40B4-BE49-F238E27FC236}">
-                <a16:creationId xmlns:a16="http://schemas.microsoft.com/office/drawing/2014/main" id="{442A28ED-6773-57B2-1086-BE44869DF5E3}"/>
+                <a16:creationId xmlns:a16="http://schemas.microsoft.com/office/drawing/2014/main" id="{701F9E26-F996-56BC-EBCD-B6F5074DC39B}"/>
               </a:ext>
             </a:extLst>
           </p:cNvPr>
@@ -4342,7 +4450,7 @@
           <p:cNvPr id="9" name="灯片编号占位符 8">
             <a:extLst>
               <a:ext uri="{FF2B5EF4-FFF2-40B4-BE49-F238E27FC236}">
-                <a16:creationId xmlns:a16="http://schemas.microsoft.com/office/drawing/2014/main" id="{73D829A7-6FC3-A33B-70D5-437C3975C0AA}"/>
+                <a16:creationId xmlns:a16="http://schemas.microsoft.com/office/drawing/2014/main" id="{AF38B9D5-7DF3-7806-44A4-E63FD880C50F}"/>
               </a:ext>
             </a:extLst>
           </p:cNvPr>
@@ -4358,7 +4466,7 @@
           <a:bodyPr/>
           <a:lstStyle/>
           <a:p>
-            <a:fld id="{233D886B-2453-4F0C-A339-24213FCE6F2F}" type="slidenum">
+            <a:fld id="{9DD4CD2A-584A-455B-ADD7-345520253A92}" type="slidenum">
               <a:rPr lang="zh-CN" altLang="en-US" smtClean="0"/>
               <a:t>‹#›</a:t>
             </a:fld>
@@ -4369,7 +4477,7 @@
     </p:spTree>
     <p:extLst>
       <p:ext uri="{BB962C8B-B14F-4D97-AF65-F5344CB8AC3E}">
-        <p14:creationId xmlns:p14="http://schemas.microsoft.com/office/powerpoint/2010/main" val="13261655"/>
+        <p14:creationId xmlns:p14="http://schemas.microsoft.com/office/powerpoint/2010/main" val="1634958874"/>
       </p:ext>
     </p:extLst>
   </p:cSld>
@@ -4401,7 +4509,7 @@
           <p:cNvPr id="2" name="标题 1">
             <a:extLst>
               <a:ext uri="{FF2B5EF4-FFF2-40B4-BE49-F238E27FC236}">
-                <a16:creationId xmlns:a16="http://schemas.microsoft.com/office/drawing/2014/main" id="{DC1FD518-63EA-1426-484D-A4E07C5115CE}"/>
+                <a16:creationId xmlns:a16="http://schemas.microsoft.com/office/drawing/2014/main" id="{FA08E854-151C-AD04-90CF-92F539BF583E}"/>
               </a:ext>
             </a:extLst>
           </p:cNvPr>
@@ -4429,7 +4537,7 @@
           <p:cNvPr id="3" name="日期占位符 2">
             <a:extLst>
               <a:ext uri="{FF2B5EF4-FFF2-40B4-BE49-F238E27FC236}">
-                <a16:creationId xmlns:a16="http://schemas.microsoft.com/office/drawing/2014/main" id="{6E9AE478-BCCA-9C1C-8D5B-09E5F18C6F4F}"/>
+                <a16:creationId xmlns:a16="http://schemas.microsoft.com/office/drawing/2014/main" id="{9AFF4CCE-CE64-A034-C166-44994D36A0F0}"/>
               </a:ext>
             </a:extLst>
           </p:cNvPr>
@@ -4445,7 +4553,7 @@
           <a:bodyPr/>
           <a:lstStyle/>
           <a:p>
-            <a:fld id="{A66D2391-A4DD-43E6-B9B0-4ECCF2FB388B}" type="datetimeFigureOut">
+            <a:fld id="{BCA83E38-FE1A-46D7-AAB8-6C2A5536F75A}" type="datetimeFigureOut">
               <a:rPr lang="zh-CN" altLang="en-US" smtClean="0"/>
               <a:t>2026/6/11</a:t>
             </a:fld>
@@ -4458,7 +4566,7 @@
           <p:cNvPr id="4" name="页脚占位符 3">
             <a:extLst>
               <a:ext uri="{FF2B5EF4-FFF2-40B4-BE49-F238E27FC236}">
-                <a16:creationId xmlns:a16="http://schemas.microsoft.com/office/drawing/2014/main" id="{D532D639-A8FF-6448-801F-CE9E0548A4E1}"/>
+                <a16:creationId xmlns:a16="http://schemas.microsoft.com/office/drawing/2014/main" id="{AF610A60-D7D7-02DD-DF23-250859E9CA9C}"/>
               </a:ext>
             </a:extLst>
           </p:cNvPr>
@@ -4483,7 +4591,7 @@
           <p:cNvPr id="5" name="灯片编号占位符 4">
             <a:extLst>
               <a:ext uri="{FF2B5EF4-FFF2-40B4-BE49-F238E27FC236}">
-                <a16:creationId xmlns:a16="http://schemas.microsoft.com/office/drawing/2014/main" id="{93B6F76D-6245-8B23-96F3-6E26E091553F}"/>
+                <a16:creationId xmlns:a16="http://schemas.microsoft.com/office/drawing/2014/main" id="{9090A6F3-640D-DEC5-71BE-63C2F58D8F28}"/>
               </a:ext>
             </a:extLst>
           </p:cNvPr>
@@ -4499,7 +4607,7 @@
           <a:bodyPr/>
           <a:lstStyle/>
           <a:p>
-            <a:fld id="{233D886B-2453-4F0C-A339-24213FCE6F2F}" type="slidenum">
+            <a:fld id="{9DD4CD2A-584A-455B-ADD7-345520253A92}" type="slidenum">
               <a:rPr lang="zh-CN" altLang="en-US" smtClean="0"/>
               <a:t>‹#›</a:t>
             </a:fld>
@@ -4510,7 +4618,7 @@
     </p:spTree>
     <p:extLst>
       <p:ext uri="{BB962C8B-B14F-4D97-AF65-F5344CB8AC3E}">
-        <p14:creationId xmlns:p14="http://schemas.microsoft.com/office/powerpoint/2010/main" val="2145530606"/>
+        <p14:creationId xmlns:p14="http://schemas.microsoft.com/office/powerpoint/2010/main" val="477275844"/>
       </p:ext>
     </p:extLst>
   </p:cSld>
@@ -4542,7 +4650,7 @@
           <p:cNvPr id="2" name="日期占位符 1">
             <a:extLst>
               <a:ext uri="{FF2B5EF4-FFF2-40B4-BE49-F238E27FC236}">
-                <a16:creationId xmlns:a16="http://schemas.microsoft.com/office/drawing/2014/main" id="{C7BC17B3-F9B4-547D-6037-EDF65E4F0C2B}"/>
+                <a16:creationId xmlns:a16="http://schemas.microsoft.com/office/drawing/2014/main" id="{CA459AA8-BB2F-5F1C-9A45-FBF62F832806}"/>
               </a:ext>
             </a:extLst>
           </p:cNvPr>
@@ -4558,7 +4666,7 @@
           <a:bodyPr/>
           <a:lstStyle/>
           <a:p>
-            <a:fld id="{A66D2391-A4DD-43E6-B9B0-4ECCF2FB388B}" type="datetimeFigureOut">
+            <a:fld id="{BCA83E38-FE1A-46D7-AAB8-6C2A5536F75A}" type="datetimeFigureOut">
               <a:rPr lang="zh-CN" altLang="en-US" smtClean="0"/>
               <a:t>2026/6/11</a:t>
             </a:fld>
@@ -4571,7 +4679,7 @@
           <p:cNvPr id="3" name="页脚占位符 2">
             <a:extLst>
               <a:ext uri="{FF2B5EF4-FFF2-40B4-BE49-F238E27FC236}">
-                <a16:creationId xmlns:a16="http://schemas.microsoft.com/office/drawing/2014/main" id="{794C95B6-1E2B-3366-923C-F3005E8C70EA}"/>
+                <a16:creationId xmlns:a16="http://schemas.microsoft.com/office/drawing/2014/main" id="{EE4B8CF9-356E-99C4-AB53-01A7D0ED3D73}"/>
               </a:ext>
             </a:extLst>
           </p:cNvPr>
@@ -4596,7 +4704,7 @@
           <p:cNvPr id="4" name="灯片编号占位符 3">
             <a:extLst>
               <a:ext uri="{FF2B5EF4-FFF2-40B4-BE49-F238E27FC236}">
-                <a16:creationId xmlns:a16="http://schemas.microsoft.com/office/drawing/2014/main" id="{9554F20A-97F5-EDA6-0424-C77FB9AADF83}"/>
+                <a16:creationId xmlns:a16="http://schemas.microsoft.com/office/drawing/2014/main" id="{0A2FA83E-3CBD-EB41-BC7F-663EAB688532}"/>
               </a:ext>
             </a:extLst>
           </p:cNvPr>
@@ -4612,7 +4720,7 @@
           <a:bodyPr/>
           <a:lstStyle/>
           <a:p>
-            <a:fld id="{233D886B-2453-4F0C-A339-24213FCE6F2F}" type="slidenum">
+            <a:fld id="{9DD4CD2A-584A-455B-ADD7-345520253A92}" type="slidenum">
               <a:rPr lang="zh-CN" altLang="en-US" smtClean="0"/>
               <a:t>‹#›</a:t>
             </a:fld>
@@ -4623,7 +4731,7 @@
     </p:spTree>
     <p:extLst>
       <p:ext uri="{BB962C8B-B14F-4D97-AF65-F5344CB8AC3E}">
-        <p14:creationId xmlns:p14="http://schemas.microsoft.com/office/powerpoint/2010/main" val="959714589"/>
+        <p14:creationId xmlns:p14="http://schemas.microsoft.com/office/powerpoint/2010/main" val="3082109602"/>
       </p:ext>
     </p:extLst>
   </p:cSld>
@@ -4655,7 +4763,7 @@
           <p:cNvPr id="2" name="标题 1">
             <a:extLst>
               <a:ext uri="{FF2B5EF4-FFF2-40B4-BE49-F238E27FC236}">
-                <a16:creationId xmlns:a16="http://schemas.microsoft.com/office/drawing/2014/main" id="{757C621C-ECFF-7D1D-FB8E-1ED4620C5CF9}"/>
+                <a16:creationId xmlns:a16="http://schemas.microsoft.com/office/drawing/2014/main" id="{03C7CFAF-28E9-6E60-1AB4-A2213DBF029F}"/>
               </a:ext>
             </a:extLst>
           </p:cNvPr>
@@ -4692,7 +4800,7 @@
           <p:cNvPr id="3" name="内容占位符 2">
             <a:extLst>
               <a:ext uri="{FF2B5EF4-FFF2-40B4-BE49-F238E27FC236}">
-                <a16:creationId xmlns:a16="http://schemas.microsoft.com/office/drawing/2014/main" id="{6E8C6F58-7980-2B94-0432-5428E42B65CD}"/>
+                <a16:creationId xmlns:a16="http://schemas.microsoft.com/office/drawing/2014/main" id="{C92D878A-FC8D-146C-4707-1F2DDA37708C}"/>
               </a:ext>
             </a:extLst>
           </p:cNvPr>
@@ -4782,7 +4890,7 @@
           <p:cNvPr id="4" name="文本占位符 3">
             <a:extLst>
               <a:ext uri="{FF2B5EF4-FFF2-40B4-BE49-F238E27FC236}">
-                <a16:creationId xmlns:a16="http://schemas.microsoft.com/office/drawing/2014/main" id="{4D273499-5811-0D8A-64BF-51E9AB0A4DEB}"/>
+                <a16:creationId xmlns:a16="http://schemas.microsoft.com/office/drawing/2014/main" id="{BFEE00CB-4A69-2462-12C0-B688E211990A}"/>
               </a:ext>
             </a:extLst>
           </p:cNvPr>
@@ -4853,7 +4961,7 @@
           <p:cNvPr id="5" name="日期占位符 4">
             <a:extLst>
               <a:ext uri="{FF2B5EF4-FFF2-40B4-BE49-F238E27FC236}">
-                <a16:creationId xmlns:a16="http://schemas.microsoft.com/office/drawing/2014/main" id="{4A7AAC29-FD21-617F-DB5C-1C94037D9745}"/>
+                <a16:creationId xmlns:a16="http://schemas.microsoft.com/office/drawing/2014/main" id="{CB872B19-E67E-ED38-7629-A2ED99C67D30}"/>
               </a:ext>
             </a:extLst>
           </p:cNvPr>
@@ -4869,7 +4977,7 @@
           <a:bodyPr/>
           <a:lstStyle/>
           <a:p>
-            <a:fld id="{A66D2391-A4DD-43E6-B9B0-4ECCF2FB388B}" type="datetimeFigureOut">
+            <a:fld id="{BCA83E38-FE1A-46D7-AAB8-6C2A5536F75A}" type="datetimeFigureOut">
               <a:rPr lang="zh-CN" altLang="en-US" smtClean="0"/>
               <a:t>2026/6/11</a:t>
             </a:fld>
@@ -4882,7 +4990,7 @@
           <p:cNvPr id="6" name="页脚占位符 5">
             <a:extLst>
               <a:ext uri="{FF2B5EF4-FFF2-40B4-BE49-F238E27FC236}">
-                <a16:creationId xmlns:a16="http://schemas.microsoft.com/office/drawing/2014/main" id="{C3612E0A-34FF-829B-7DD5-87B4CD2F0E83}"/>
+                <a16:creationId xmlns:a16="http://schemas.microsoft.com/office/drawing/2014/main" id="{0CD388CC-0DE7-EDC7-DF77-A789B131E125}"/>
               </a:ext>
             </a:extLst>
           </p:cNvPr>
@@ -4907,7 +5015,7 @@
           <p:cNvPr id="7" name="灯片编号占位符 6">
             <a:extLst>
               <a:ext uri="{FF2B5EF4-FFF2-40B4-BE49-F238E27FC236}">
-                <a16:creationId xmlns:a16="http://schemas.microsoft.com/office/drawing/2014/main" id="{8A10BB22-2FC2-F967-D7EF-3FDA5E47E955}"/>
+                <a16:creationId xmlns:a16="http://schemas.microsoft.com/office/drawing/2014/main" id="{A665F3A8-1810-6DC9-980C-71CF8C761E7F}"/>
               </a:ext>
             </a:extLst>
           </p:cNvPr>
@@ -4923,7 +5031,7 @@
           <a:bodyPr/>
           <a:lstStyle/>
           <a:p>
-            <a:fld id="{233D886B-2453-4F0C-A339-24213FCE6F2F}" type="slidenum">
+            <a:fld id="{9DD4CD2A-584A-455B-ADD7-345520253A92}" type="slidenum">
               <a:rPr lang="zh-CN" altLang="en-US" smtClean="0"/>
               <a:t>‹#›</a:t>
             </a:fld>
@@ -4934,7 +5042,7 @@
     </p:spTree>
     <p:extLst>
       <p:ext uri="{BB962C8B-B14F-4D97-AF65-F5344CB8AC3E}">
-        <p14:creationId xmlns:p14="http://schemas.microsoft.com/office/powerpoint/2010/main" val="93751065"/>
+        <p14:creationId xmlns:p14="http://schemas.microsoft.com/office/powerpoint/2010/main" val="4250577993"/>
       </p:ext>
     </p:extLst>
   </p:cSld>
@@ -4966,7 +5074,7 @@
           <p:cNvPr id="2" name="标题 1">
             <a:extLst>
               <a:ext uri="{FF2B5EF4-FFF2-40B4-BE49-F238E27FC236}">
-                <a16:creationId xmlns:a16="http://schemas.microsoft.com/office/drawing/2014/main" id="{60EBC479-B7D6-A75A-221B-090D99C44D7C}"/>
+                <a16:creationId xmlns:a16="http://schemas.microsoft.com/office/drawing/2014/main" id="{C7F6CD7A-EC2E-BC85-1B5C-B9DB3DA52BFB}"/>
               </a:ext>
             </a:extLst>
           </p:cNvPr>
@@ -5003,7 +5111,7 @@
           <p:cNvPr id="3" name="图片占位符 2">
             <a:extLst>
               <a:ext uri="{FF2B5EF4-FFF2-40B4-BE49-F238E27FC236}">
-                <a16:creationId xmlns:a16="http://schemas.microsoft.com/office/drawing/2014/main" id="{AED3165A-3406-E0D0-1847-5E332EA8C3E8}"/>
+                <a16:creationId xmlns:a16="http://schemas.microsoft.com/office/drawing/2014/main" id="{47889227-E830-E0D2-829A-6243A73CDE1A}"/>
               </a:ext>
             </a:extLst>
           </p:cNvPr>
@@ -5070,7 +5178,7 @@
           <p:cNvPr id="4" name="文本占位符 3">
             <a:extLst>
               <a:ext uri="{FF2B5EF4-FFF2-40B4-BE49-F238E27FC236}">
-                <a16:creationId xmlns:a16="http://schemas.microsoft.com/office/drawing/2014/main" id="{CD8D3841-CDC4-71FE-E6E1-6D41DB60D40F}"/>
+                <a16:creationId xmlns:a16="http://schemas.microsoft.com/office/drawing/2014/main" id="{AFC8818B-A402-D326-0073-12A5577EA954}"/>
               </a:ext>
             </a:extLst>
           </p:cNvPr>
@@ -5141,7 +5249,7 @@
           <p:cNvPr id="5" name="日期占位符 4">
             <a:extLst>
               <a:ext uri="{FF2B5EF4-FFF2-40B4-BE49-F238E27FC236}">
-                <a16:creationId xmlns:a16="http://schemas.microsoft.com/office/drawing/2014/main" id="{8246ABCE-EFE5-DB0C-9215-1810B6093430}"/>
+                <a16:creationId xmlns:a16="http://schemas.microsoft.com/office/drawing/2014/main" id="{8728CEB8-6243-DA8A-9299-014443CBE3DD}"/>
               </a:ext>
             </a:extLst>
           </p:cNvPr>
@@ -5157,7 +5265,7 @@
           <a:bodyPr/>
           <a:lstStyle/>
           <a:p>
-            <a:fld id="{A66D2391-A4DD-43E6-B9B0-4ECCF2FB388B}" type="datetimeFigureOut">
+            <a:fld id="{BCA83E38-FE1A-46D7-AAB8-6C2A5536F75A}" type="datetimeFigureOut">
               <a:rPr lang="zh-CN" altLang="en-US" smtClean="0"/>
               <a:t>2026/6/11</a:t>
             </a:fld>
@@ -5170,7 +5278,7 @@
           <p:cNvPr id="6" name="页脚占位符 5">
             <a:extLst>
               <a:ext uri="{FF2B5EF4-FFF2-40B4-BE49-F238E27FC236}">
-                <a16:creationId xmlns:a16="http://schemas.microsoft.com/office/drawing/2014/main" id="{836BF6F3-E976-8EFC-4AEE-1B46F9EF0136}"/>
+                <a16:creationId xmlns:a16="http://schemas.microsoft.com/office/drawing/2014/main" id="{4FF5B9E7-0C32-DFB1-C9B7-0AD3F87EA543}"/>
               </a:ext>
             </a:extLst>
           </p:cNvPr>
@@ -5195,7 +5303,7 @@
           <p:cNvPr id="7" name="灯片编号占位符 6">
             <a:extLst>
               <a:ext uri="{FF2B5EF4-FFF2-40B4-BE49-F238E27FC236}">
-                <a16:creationId xmlns:a16="http://schemas.microsoft.com/office/drawing/2014/main" id="{0362A250-9C6C-71C6-A512-AF48EE16E67C}"/>
+                <a16:creationId xmlns:a16="http://schemas.microsoft.com/office/drawing/2014/main" id="{51C39A36-EAFF-259A-A15F-0FD643587162}"/>
               </a:ext>
             </a:extLst>
           </p:cNvPr>
@@ -5211,7 +5319,7 @@
           <a:bodyPr/>
           <a:lstStyle/>
           <a:p>
-            <a:fld id="{233D886B-2453-4F0C-A339-24213FCE6F2F}" type="slidenum">
+            <a:fld id="{9DD4CD2A-584A-455B-ADD7-345520253A92}" type="slidenum">
               <a:rPr lang="zh-CN" altLang="en-US" smtClean="0"/>
               <a:t>‹#›</a:t>
             </a:fld>
@@ -5222,7 +5330,7 @@
     </p:spTree>
     <p:extLst>
       <p:ext uri="{BB962C8B-B14F-4D97-AF65-F5344CB8AC3E}">
-        <p14:creationId xmlns:p14="http://schemas.microsoft.com/office/powerpoint/2010/main" val="1532972892"/>
+        <p14:creationId xmlns:p14="http://schemas.microsoft.com/office/powerpoint/2010/main" val="1042633100"/>
       </p:ext>
     </p:extLst>
   </p:cSld>
@@ -5259,7 +5367,7 @@
           <p:cNvPr id="2" name="标题占位符 1">
             <a:extLst>
               <a:ext uri="{FF2B5EF4-FFF2-40B4-BE49-F238E27FC236}">
-                <a16:creationId xmlns:a16="http://schemas.microsoft.com/office/drawing/2014/main" id="{76089386-CC22-AC8A-36E2-1D17C4D8ED1E}"/>
+                <a16:creationId xmlns:a16="http://schemas.microsoft.com/office/drawing/2014/main" id="{935AA5F3-D0BC-CD24-5DB5-D99DE2F2DD26}"/>
               </a:ext>
             </a:extLst>
           </p:cNvPr>
@@ -5297,7 +5405,7 @@
           <p:cNvPr id="3" name="文本占位符 2">
             <a:extLst>
               <a:ext uri="{FF2B5EF4-FFF2-40B4-BE49-F238E27FC236}">
-                <a16:creationId xmlns:a16="http://schemas.microsoft.com/office/drawing/2014/main" id="{61DF9755-6E61-16AF-32D6-4226F140FAC6}"/>
+                <a16:creationId xmlns:a16="http://schemas.microsoft.com/office/drawing/2014/main" id="{65CA3D6C-A6CD-DB61-CE47-21D249C8BA2C}"/>
               </a:ext>
             </a:extLst>
           </p:cNvPr>
@@ -5364,7 +5472,7 @@
           <p:cNvPr id="4" name="日期占位符 3">
             <a:extLst>
               <a:ext uri="{FF2B5EF4-FFF2-40B4-BE49-F238E27FC236}">
-                <a16:creationId xmlns:a16="http://schemas.microsoft.com/office/drawing/2014/main" id="{104D8F0D-9976-B141-8152-BBA53A604F51}"/>
+                <a16:creationId xmlns:a16="http://schemas.microsoft.com/office/drawing/2014/main" id="{80F21F56-26AD-5596-75DA-459697BDA448}"/>
               </a:ext>
             </a:extLst>
           </p:cNvPr>
@@ -5398,7 +5506,7 @@
             </a:lvl1pPr>
           </a:lstStyle>
           <a:p>
-            <a:fld id="{A66D2391-A4DD-43E6-B9B0-4ECCF2FB388B}" type="datetimeFigureOut">
+            <a:fld id="{BCA83E38-FE1A-46D7-AAB8-6C2A5536F75A}" type="datetimeFigureOut">
               <a:rPr lang="zh-CN" altLang="en-US" smtClean="0"/>
               <a:t>2026/6/11</a:t>
             </a:fld>
@@ -5411,7 +5519,7 @@
           <p:cNvPr id="5" name="页脚占位符 4">
             <a:extLst>
               <a:ext uri="{FF2B5EF4-FFF2-40B4-BE49-F238E27FC236}">
-                <a16:creationId xmlns:a16="http://schemas.microsoft.com/office/drawing/2014/main" id="{29E1DE2D-DB41-571D-FB02-B8845C6B7B9B}"/>
+                <a16:creationId xmlns:a16="http://schemas.microsoft.com/office/drawing/2014/main" id="{BE4CCA01-DA2B-159F-1509-6DCABB35975D}"/>
               </a:ext>
             </a:extLst>
           </p:cNvPr>
@@ -5454,7 +5562,7 @@
           <p:cNvPr id="6" name="灯片编号占位符 5">
             <a:extLst>
               <a:ext uri="{FF2B5EF4-FFF2-40B4-BE49-F238E27FC236}">
-                <a16:creationId xmlns:a16="http://schemas.microsoft.com/office/drawing/2014/main" id="{B9BC5E65-2DCA-62F2-3A46-F8872AEC006D}"/>
+                <a16:creationId xmlns:a16="http://schemas.microsoft.com/office/drawing/2014/main" id="{34D67B11-8D72-E64C-A9E9-D9B57050E750}"/>
               </a:ext>
             </a:extLst>
           </p:cNvPr>
@@ -5488,7 +5596,7 @@
             </a:lvl1pPr>
           </a:lstStyle>
           <a:p>
-            <a:fld id="{233D886B-2453-4F0C-A339-24213FCE6F2F}" type="slidenum">
+            <a:fld id="{9DD4CD2A-584A-455B-ADD7-345520253A92}" type="slidenum">
               <a:rPr lang="zh-CN" altLang="en-US" smtClean="0"/>
               <a:t>‹#›</a:t>
             </a:fld>
@@ -5499,7 +5607,7 @@
     </p:spTree>
     <p:extLst>
       <p:ext uri="{BB962C8B-B14F-4D97-AF65-F5344CB8AC3E}">
-        <p14:creationId xmlns:p14="http://schemas.microsoft.com/office/powerpoint/2010/main" val="632117711"/>
+        <p14:creationId xmlns:p14="http://schemas.microsoft.com/office/powerpoint/2010/main" val="3145690014"/>
       </p:ext>
     </p:extLst>
   </p:cSld>
@@ -5822,7 +5930,7 @@
           <p:cNvPr id="2" name="矩形 1">
             <a:extLst>
               <a:ext uri="{FF2B5EF4-FFF2-40B4-BE49-F238E27FC236}">
-                <a16:creationId xmlns:a16="http://schemas.microsoft.com/office/drawing/2014/main" id="{D60219D2-6019-BE1C-7C57-0AF144602828}"/>
+                <a16:creationId xmlns:a16="http://schemas.microsoft.com/office/drawing/2014/main" id="{158E8219-6304-CF78-58DD-6B7CD3BC53B2}"/>
               </a:ext>
             </a:extLst>
           </p:cNvPr>
@@ -5876,7 +5984,7 @@
           <p:cNvPr id="3" name="矩形 2">
             <a:extLst>
               <a:ext uri="{FF2B5EF4-FFF2-40B4-BE49-F238E27FC236}">
-                <a16:creationId xmlns:a16="http://schemas.microsoft.com/office/drawing/2014/main" id="{F7264270-B5E7-EE5C-BDD8-BC21D1578FF3}"/>
+                <a16:creationId xmlns:a16="http://schemas.microsoft.com/office/drawing/2014/main" id="{521D9577-9063-C423-5063-7C765C488049}"/>
               </a:ext>
             </a:extLst>
           </p:cNvPr>
@@ -5930,7 +6038,7 @@
           <p:cNvPr id="4" name="矩形 3">
             <a:extLst>
               <a:ext uri="{FF2B5EF4-FFF2-40B4-BE49-F238E27FC236}">
-                <a16:creationId xmlns:a16="http://schemas.microsoft.com/office/drawing/2014/main" id="{4FF0A0C2-4F71-C653-E117-25CB1143F716}"/>
+                <a16:creationId xmlns:a16="http://schemas.microsoft.com/office/drawing/2014/main" id="{7E976E6D-CCE6-7611-D9FB-0D8684F49E5E}"/>
               </a:ext>
             </a:extLst>
           </p:cNvPr>
@@ -5984,7 +6092,7 @@
           <p:cNvPr id="5" name="文本框 4">
             <a:extLst>
               <a:ext uri="{FF2B5EF4-FFF2-40B4-BE49-F238E27FC236}">
-                <a16:creationId xmlns:a16="http://schemas.microsoft.com/office/drawing/2014/main" id="{3DD848BF-EB72-1F94-EE00-851C0A8CF4B2}"/>
+                <a16:creationId xmlns:a16="http://schemas.microsoft.com/office/drawing/2014/main" id="{2CFCDF9B-D0E0-EA40-226C-EA434F98F3B7}"/>
               </a:ext>
             </a:extLst>
           </p:cNvPr>
@@ -6030,7 +6138,7 @@
           <p:cNvPr id="6" name="文本框 5">
             <a:extLst>
               <a:ext uri="{FF2B5EF4-FFF2-40B4-BE49-F238E27FC236}">
-                <a16:creationId xmlns:a16="http://schemas.microsoft.com/office/drawing/2014/main" id="{D453DB46-96CD-4872-5F84-193A9BF3907C}"/>
+                <a16:creationId xmlns:a16="http://schemas.microsoft.com/office/drawing/2014/main" id="{93A6CA71-D07B-6DD3-7418-81C41EA19C03}"/>
               </a:ext>
             </a:extLst>
           </p:cNvPr>
@@ -6106,7 +6214,7 @@
           <p:cNvPr id="7" name="矩形 6">
             <a:extLst>
               <a:ext uri="{FF2B5EF4-FFF2-40B4-BE49-F238E27FC236}">
-                <a16:creationId xmlns:a16="http://schemas.microsoft.com/office/drawing/2014/main" id="{6ACA3814-1F4B-BF27-8473-879328AB4876}"/>
+                <a16:creationId xmlns:a16="http://schemas.microsoft.com/office/drawing/2014/main" id="{AC3AC1CD-2195-9B06-02B4-621D8E3D9070}"/>
               </a:ext>
             </a:extLst>
           </p:cNvPr>
@@ -6160,7 +6268,7 @@
           <p:cNvPr id="8" name="矩形: 圆角 7">
             <a:extLst>
               <a:ext uri="{FF2B5EF4-FFF2-40B4-BE49-F238E27FC236}">
-                <a16:creationId xmlns:a16="http://schemas.microsoft.com/office/drawing/2014/main" id="{5EE13946-4B66-3445-EFB4-7295A5B0AB41}"/>
+                <a16:creationId xmlns:a16="http://schemas.microsoft.com/office/drawing/2014/main" id="{213AE171-B740-8E9F-420A-071DF19C56E2}"/>
               </a:ext>
             </a:extLst>
           </p:cNvPr>
@@ -6222,7 +6330,7 @@
           <p:cNvPr id="9" name="矩形: 圆角 8">
             <a:extLst>
               <a:ext uri="{FF2B5EF4-FFF2-40B4-BE49-F238E27FC236}">
-                <a16:creationId xmlns:a16="http://schemas.microsoft.com/office/drawing/2014/main" id="{81B3C0BB-AFC9-E5A2-71C0-C55CC93D976F}"/>
+                <a16:creationId xmlns:a16="http://schemas.microsoft.com/office/drawing/2014/main" id="{257D383F-6523-E347-8464-76C582B9048A}"/>
               </a:ext>
             </a:extLst>
           </p:cNvPr>
@@ -6284,7 +6392,7 @@
           <p:cNvPr id="10" name="矩形: 圆角 9">
             <a:extLst>
               <a:ext uri="{FF2B5EF4-FFF2-40B4-BE49-F238E27FC236}">
-                <a16:creationId xmlns:a16="http://schemas.microsoft.com/office/drawing/2014/main" id="{93CD0442-7A3C-8CA1-1CCB-7710923172AF}"/>
+                <a16:creationId xmlns:a16="http://schemas.microsoft.com/office/drawing/2014/main" id="{7DAC582D-B367-E738-3C28-B6A4F6A16A2C}"/>
               </a:ext>
             </a:extLst>
           </p:cNvPr>
@@ -6346,7 +6454,7 @@
           <p:cNvPr id="11" name="矩形: 圆角 10">
             <a:extLst>
               <a:ext uri="{FF2B5EF4-FFF2-40B4-BE49-F238E27FC236}">
-                <a16:creationId xmlns:a16="http://schemas.microsoft.com/office/drawing/2014/main" id="{854EEAC3-F31E-D53A-DB33-62A028EC93AA}"/>
+                <a16:creationId xmlns:a16="http://schemas.microsoft.com/office/drawing/2014/main" id="{DDD0C16A-EEA0-F77E-1E4E-524FC5C20731}"/>
               </a:ext>
             </a:extLst>
           </p:cNvPr>
@@ -6414,7 +6522,7 @@
           <p:cNvPr id="12" name="矩形: 圆角 11">
             <a:extLst>
               <a:ext uri="{FF2B5EF4-FFF2-40B4-BE49-F238E27FC236}">
-                <a16:creationId xmlns:a16="http://schemas.microsoft.com/office/drawing/2014/main" id="{86623F25-60A4-D949-79AA-3AC777CFADF1}"/>
+                <a16:creationId xmlns:a16="http://schemas.microsoft.com/office/drawing/2014/main" id="{DAB55F58-9AB0-48F9-8FB4-7D59B37BBB6F}"/>
               </a:ext>
             </a:extLst>
           </p:cNvPr>
@@ -6482,7 +6590,7 @@
           <p:cNvPr id="13" name="矩形: 圆角 12">
             <a:extLst>
               <a:ext uri="{FF2B5EF4-FFF2-40B4-BE49-F238E27FC236}">
-                <a16:creationId xmlns:a16="http://schemas.microsoft.com/office/drawing/2014/main" id="{19FFFEEF-20D2-CD58-71CD-6B34D95F13A4}"/>
+                <a16:creationId xmlns:a16="http://schemas.microsoft.com/office/drawing/2014/main" id="{C9B4DBD0-E628-9470-7FE9-13C3CD496B67}"/>
               </a:ext>
             </a:extLst>
           </p:cNvPr>
@@ -6544,7 +6652,7 @@
           <p:cNvPr id="14" name="文本框 13">
             <a:extLst>
               <a:ext uri="{FF2B5EF4-FFF2-40B4-BE49-F238E27FC236}">
-                <a16:creationId xmlns:a16="http://schemas.microsoft.com/office/drawing/2014/main" id="{5BA591E2-5FB7-AFF6-F97B-11393A3AFFA8}"/>
+                <a16:creationId xmlns:a16="http://schemas.microsoft.com/office/drawing/2014/main" id="{26A3D307-20AA-74A7-3F27-8AD88001EC93}"/>
               </a:ext>
             </a:extLst>
           </p:cNvPr>
@@ -6617,7 +6725,7 @@
           <p:cNvPr id="15" name="文本框 14">
             <a:extLst>
               <a:ext uri="{FF2B5EF4-FFF2-40B4-BE49-F238E27FC236}">
-                <a16:creationId xmlns:a16="http://schemas.microsoft.com/office/drawing/2014/main" id="{BF95E8AB-23E8-3A5A-1617-D379E6CC9CEE}"/>
+                <a16:creationId xmlns:a16="http://schemas.microsoft.com/office/drawing/2014/main" id="{3B105C53-8882-4E21-E38E-7BE1F5811DF1}"/>
               </a:ext>
             </a:extLst>
           </p:cNvPr>
@@ -6655,7 +6763,7 @@
     </p:spTree>
     <p:extLst>
       <p:ext uri="{BB962C8B-B14F-4D97-AF65-F5344CB8AC3E}">
-        <p14:creationId xmlns:p14="http://schemas.microsoft.com/office/powerpoint/2010/main" val="224463890"/>
+        <p14:creationId xmlns:p14="http://schemas.microsoft.com/office/powerpoint/2010/main" val="2031822557"/>
       </p:ext>
     </p:extLst>
   </p:cSld>
@@ -6687,7 +6795,7 @@
           <p:cNvPr id="2" name="矩形 1">
             <a:extLst>
               <a:ext uri="{FF2B5EF4-FFF2-40B4-BE49-F238E27FC236}">
-                <a16:creationId xmlns:a16="http://schemas.microsoft.com/office/drawing/2014/main" id="{1AAC5742-7CF6-E0DB-DE81-7B599FBCA391}"/>
+                <a16:creationId xmlns:a16="http://schemas.microsoft.com/office/drawing/2014/main" id="{9CA33609-6A5E-02BC-49C7-7C926AD95959}"/>
               </a:ext>
             </a:extLst>
           </p:cNvPr>
@@ -6741,7 +6849,7 @@
           <p:cNvPr id="3" name="矩形 2">
             <a:extLst>
               <a:ext uri="{FF2B5EF4-FFF2-40B4-BE49-F238E27FC236}">
-                <a16:creationId xmlns:a16="http://schemas.microsoft.com/office/drawing/2014/main" id="{3C849D4F-C836-3029-99E1-30C608474529}"/>
+                <a16:creationId xmlns:a16="http://schemas.microsoft.com/office/drawing/2014/main" id="{34AC2457-DB77-F837-77EC-42E7D3D3CA1D}"/>
               </a:ext>
             </a:extLst>
           </p:cNvPr>
@@ -6795,7 +6903,7 @@
           <p:cNvPr id="4" name="矩形 3">
             <a:extLst>
               <a:ext uri="{FF2B5EF4-FFF2-40B4-BE49-F238E27FC236}">
-                <a16:creationId xmlns:a16="http://schemas.microsoft.com/office/drawing/2014/main" id="{4461881B-959E-8E03-DEFC-1C4D862F8882}"/>
+                <a16:creationId xmlns:a16="http://schemas.microsoft.com/office/drawing/2014/main" id="{EB9040B7-C64C-F2F0-7DC3-AFB8B6A3DEAF}"/>
               </a:ext>
             </a:extLst>
           </p:cNvPr>
@@ -6849,7 +6957,7 @@
           <p:cNvPr id="5" name="文本框 4">
             <a:extLst>
               <a:ext uri="{FF2B5EF4-FFF2-40B4-BE49-F238E27FC236}">
-                <a16:creationId xmlns:a16="http://schemas.microsoft.com/office/drawing/2014/main" id="{049AEE9A-296F-FCA1-102B-7EC6B1F20A11}"/>
+                <a16:creationId xmlns:a16="http://schemas.microsoft.com/office/drawing/2014/main" id="{5E641022-7B63-F707-34FA-901F248E779A}"/>
               </a:ext>
             </a:extLst>
           </p:cNvPr>
@@ -6898,7 +7006,7 @@
           <p:cNvPr id="6" name="文本框 5">
             <a:extLst>
               <a:ext uri="{FF2B5EF4-FFF2-40B4-BE49-F238E27FC236}">
-                <a16:creationId xmlns:a16="http://schemas.microsoft.com/office/drawing/2014/main" id="{9A424A29-C4B0-DAF3-AF89-2AC611D36E72}"/>
+                <a16:creationId xmlns:a16="http://schemas.microsoft.com/office/drawing/2014/main" id="{18ECBCC5-2225-8D1F-7B52-B945A7F916E8}"/>
               </a:ext>
             </a:extLst>
           </p:cNvPr>
@@ -6945,7 +7053,7 @@
           <p:cNvPr id="7" name="文本框 6">
             <a:extLst>
               <a:ext uri="{FF2B5EF4-FFF2-40B4-BE49-F238E27FC236}">
-                <a16:creationId xmlns:a16="http://schemas.microsoft.com/office/drawing/2014/main" id="{DE948816-A991-B31E-0225-56E02A5C14B5}"/>
+                <a16:creationId xmlns:a16="http://schemas.microsoft.com/office/drawing/2014/main" id="{09469399-8B7E-41A1-2699-0538D9C1C5A7}"/>
               </a:ext>
             </a:extLst>
           </p:cNvPr>
@@ -7012,7 +7120,7 @@
           <p:cNvPr id="8" name="矩形: 圆角 7">
             <a:extLst>
               <a:ext uri="{FF2B5EF4-FFF2-40B4-BE49-F238E27FC236}">
-                <a16:creationId xmlns:a16="http://schemas.microsoft.com/office/drawing/2014/main" id="{BAB074E6-0A2D-5AC7-0904-80B41408FD4D}"/>
+                <a16:creationId xmlns:a16="http://schemas.microsoft.com/office/drawing/2014/main" id="{9DED6EF3-108E-553F-975B-2E3788360433}"/>
               </a:ext>
             </a:extLst>
           </p:cNvPr>
@@ -7074,7 +7182,7 @@
           <p:cNvPr id="9" name="矩形: 圆角 8">
             <a:extLst>
               <a:ext uri="{FF2B5EF4-FFF2-40B4-BE49-F238E27FC236}">
-                <a16:creationId xmlns:a16="http://schemas.microsoft.com/office/drawing/2014/main" id="{2B182556-58D7-15CD-F71A-8F428666F468}"/>
+                <a16:creationId xmlns:a16="http://schemas.microsoft.com/office/drawing/2014/main" id="{461FE7F4-C884-4CA8-F4DC-A45F1736BA96}"/>
               </a:ext>
             </a:extLst>
           </p:cNvPr>
@@ -7151,7 +7259,7 @@
           <p:cNvPr id="10" name="矩形: 圆角 9">
             <a:extLst>
               <a:ext uri="{FF2B5EF4-FFF2-40B4-BE49-F238E27FC236}">
-                <a16:creationId xmlns:a16="http://schemas.microsoft.com/office/drawing/2014/main" id="{4D71DC1B-821B-1374-437A-1BE74492D399}"/>
+                <a16:creationId xmlns:a16="http://schemas.microsoft.com/office/drawing/2014/main" id="{ACD8DD0E-F1C0-FDD8-3587-20DB9D3C3043}"/>
               </a:ext>
             </a:extLst>
           </p:cNvPr>
@@ -7219,7 +7327,7 @@
           <p:cNvPr id="11" name="矩形: 圆角 10">
             <a:extLst>
               <a:ext uri="{FF2B5EF4-FFF2-40B4-BE49-F238E27FC236}">
-                <a16:creationId xmlns:a16="http://schemas.microsoft.com/office/drawing/2014/main" id="{2889872F-083D-756D-9F92-AFBF0C05BD8E}"/>
+                <a16:creationId xmlns:a16="http://schemas.microsoft.com/office/drawing/2014/main" id="{2B959DFC-B1C7-C180-C9DF-D166B25DBC2B}"/>
               </a:ext>
             </a:extLst>
           </p:cNvPr>
@@ -7287,7 +7395,7 @@
           <p:cNvPr id="12" name="矩形: 圆角 11">
             <a:extLst>
               <a:ext uri="{FF2B5EF4-FFF2-40B4-BE49-F238E27FC236}">
-                <a16:creationId xmlns:a16="http://schemas.microsoft.com/office/drawing/2014/main" id="{2F2E1413-9662-6B44-1AF2-7DB0885AA981}"/>
+                <a16:creationId xmlns:a16="http://schemas.microsoft.com/office/drawing/2014/main" id="{85959C21-6C78-2C52-1376-28B6D72E2A5D}"/>
               </a:ext>
             </a:extLst>
           </p:cNvPr>
@@ -7349,7 +7457,7 @@
           <p:cNvPr id="13" name="矩形: 圆角 12">
             <a:extLst>
               <a:ext uri="{FF2B5EF4-FFF2-40B4-BE49-F238E27FC236}">
-                <a16:creationId xmlns:a16="http://schemas.microsoft.com/office/drawing/2014/main" id="{6F5E2E1F-E1FE-5A2A-4A69-F340A2F2ACA4}"/>
+                <a16:creationId xmlns:a16="http://schemas.microsoft.com/office/drawing/2014/main" id="{C26ADCD8-6D2E-ADDF-03BD-DABC7700370D}"/>
               </a:ext>
             </a:extLst>
           </p:cNvPr>
@@ -7411,7 +7519,7 @@
           <p:cNvPr id="14" name="矩形: 圆角 13">
             <a:extLst>
               <a:ext uri="{FF2B5EF4-FFF2-40B4-BE49-F238E27FC236}">
-                <a16:creationId xmlns:a16="http://schemas.microsoft.com/office/drawing/2014/main" id="{EA058F14-58DA-8A6B-3D41-1147B7E83314}"/>
+                <a16:creationId xmlns:a16="http://schemas.microsoft.com/office/drawing/2014/main" id="{1F8CDDEF-8CAD-A4DA-AD88-B0B1D24CCF88}"/>
               </a:ext>
             </a:extLst>
           </p:cNvPr>
@@ -7473,7 +7581,7 @@
           <p:cNvPr id="15" name="矩形: 圆角 14">
             <a:extLst>
               <a:ext uri="{FF2B5EF4-FFF2-40B4-BE49-F238E27FC236}">
-                <a16:creationId xmlns:a16="http://schemas.microsoft.com/office/drawing/2014/main" id="{85F0BA75-3CBA-83AF-6618-A6D0200D49FA}"/>
+                <a16:creationId xmlns:a16="http://schemas.microsoft.com/office/drawing/2014/main" id="{E32651A2-25E1-58B1-3A01-60401600EC6D}"/>
               </a:ext>
             </a:extLst>
           </p:cNvPr>
@@ -7544,7 +7652,7 @@
           <p:cNvPr id="16" name="矩形: 圆角 15">
             <a:extLst>
               <a:ext uri="{FF2B5EF4-FFF2-40B4-BE49-F238E27FC236}">
-                <a16:creationId xmlns:a16="http://schemas.microsoft.com/office/drawing/2014/main" id="{BC9CD9E7-EC4E-4CAB-7812-B2488BDBD7FA}"/>
+                <a16:creationId xmlns:a16="http://schemas.microsoft.com/office/drawing/2014/main" id="{6BFD2688-3A2C-F114-FE3E-4F69627559E4}"/>
               </a:ext>
             </a:extLst>
           </p:cNvPr>
@@ -7658,7 +7766,7 @@
     </p:spTree>
     <p:extLst>
       <p:ext uri="{BB962C8B-B14F-4D97-AF65-F5344CB8AC3E}">
-        <p14:creationId xmlns:p14="http://schemas.microsoft.com/office/powerpoint/2010/main" val="3362482287"/>
+        <p14:creationId xmlns:p14="http://schemas.microsoft.com/office/powerpoint/2010/main" val="1718397827"/>
       </p:ext>
     </p:extLst>
   </p:cSld>
@@ -7690,7 +7798,7 @@
           <p:cNvPr id="2" name="矩形 1">
             <a:extLst>
               <a:ext uri="{FF2B5EF4-FFF2-40B4-BE49-F238E27FC236}">
-                <a16:creationId xmlns:a16="http://schemas.microsoft.com/office/drawing/2014/main" id="{FA1725EB-D632-535E-2CE5-791F3669BB5E}"/>
+                <a16:creationId xmlns:a16="http://schemas.microsoft.com/office/drawing/2014/main" id="{5F7F1F63-11D8-8D4B-DBCE-E4D74C9EC19E}"/>
               </a:ext>
             </a:extLst>
           </p:cNvPr>
@@ -7744,7 +7852,7 @@
           <p:cNvPr id="3" name="矩形 2">
             <a:extLst>
               <a:ext uri="{FF2B5EF4-FFF2-40B4-BE49-F238E27FC236}">
-                <a16:creationId xmlns:a16="http://schemas.microsoft.com/office/drawing/2014/main" id="{BB593799-C29E-4C34-E4F8-67BDDD54CBC7}"/>
+                <a16:creationId xmlns:a16="http://schemas.microsoft.com/office/drawing/2014/main" id="{E979A9EB-C689-35A1-C4A0-E73816EC6D9B}"/>
               </a:ext>
             </a:extLst>
           </p:cNvPr>
@@ -7798,7 +7906,7 @@
           <p:cNvPr id="4" name="矩形 3">
             <a:extLst>
               <a:ext uri="{FF2B5EF4-FFF2-40B4-BE49-F238E27FC236}">
-                <a16:creationId xmlns:a16="http://schemas.microsoft.com/office/drawing/2014/main" id="{22B5104A-1289-557D-908F-57570ABC3BCD}"/>
+                <a16:creationId xmlns:a16="http://schemas.microsoft.com/office/drawing/2014/main" id="{E11B97D0-A467-03D5-B32B-511825CAE4ED}"/>
               </a:ext>
             </a:extLst>
           </p:cNvPr>
@@ -7852,7 +7960,7 @@
           <p:cNvPr id="5" name="文本框 4">
             <a:extLst>
               <a:ext uri="{FF2B5EF4-FFF2-40B4-BE49-F238E27FC236}">
-                <a16:creationId xmlns:a16="http://schemas.microsoft.com/office/drawing/2014/main" id="{C465C5B6-5329-0EFA-FA50-DB4C67831010}"/>
+                <a16:creationId xmlns:a16="http://schemas.microsoft.com/office/drawing/2014/main" id="{D8C82B6C-B97B-AF0E-85CB-0315FDDD6139}"/>
               </a:ext>
             </a:extLst>
           </p:cNvPr>
@@ -7892,7 +8000,7 @@
           <p:cNvPr id="6" name="文本框 5">
             <a:extLst>
               <a:ext uri="{FF2B5EF4-FFF2-40B4-BE49-F238E27FC236}">
-                <a16:creationId xmlns:a16="http://schemas.microsoft.com/office/drawing/2014/main" id="{EAC7C47C-FA97-0FC7-22B5-B90DD9DDF82A}"/>
+                <a16:creationId xmlns:a16="http://schemas.microsoft.com/office/drawing/2014/main" id="{6DC5BA3B-54B4-24F2-F5E1-0FACE2388BC1}"/>
               </a:ext>
             </a:extLst>
           </p:cNvPr>
@@ -7939,7 +8047,7 @@
           <p:cNvPr id="7" name="文本框 6">
             <a:extLst>
               <a:ext uri="{FF2B5EF4-FFF2-40B4-BE49-F238E27FC236}">
-                <a16:creationId xmlns:a16="http://schemas.microsoft.com/office/drawing/2014/main" id="{0B2FA947-772A-4292-5933-19D2AFD6D3D1}"/>
+                <a16:creationId xmlns:a16="http://schemas.microsoft.com/office/drawing/2014/main" id="{F41C2387-8CB2-6906-757B-CCDD24AB4A33}"/>
               </a:ext>
             </a:extLst>
           </p:cNvPr>
@@ -7979,7 +8087,7 @@
           <p:cNvPr id="8" name="矩形: 圆角 7">
             <a:extLst>
               <a:ext uri="{FF2B5EF4-FFF2-40B4-BE49-F238E27FC236}">
-                <a16:creationId xmlns:a16="http://schemas.microsoft.com/office/drawing/2014/main" id="{D8CBE1D1-59F5-9CD5-E0E0-FEB583288575}"/>
+                <a16:creationId xmlns:a16="http://schemas.microsoft.com/office/drawing/2014/main" id="{1ACEF9A0-880F-1F84-134E-D39A2887CED0}"/>
               </a:ext>
             </a:extLst>
           </p:cNvPr>
@@ -8047,7 +8155,7 @@
           <p:cNvPr id="9" name="矩形: 圆角 8">
             <a:extLst>
               <a:ext uri="{FF2B5EF4-FFF2-40B4-BE49-F238E27FC236}">
-                <a16:creationId xmlns:a16="http://schemas.microsoft.com/office/drawing/2014/main" id="{11E8EB87-08BC-8761-8581-BF0B133FF98C}"/>
+                <a16:creationId xmlns:a16="http://schemas.microsoft.com/office/drawing/2014/main" id="{146C6872-6112-3155-FDB1-88FDA7851BBA}"/>
               </a:ext>
             </a:extLst>
           </p:cNvPr>
@@ -8115,7 +8223,7 @@
           <p:cNvPr id="10" name="矩形: 圆角 9">
             <a:extLst>
               <a:ext uri="{FF2B5EF4-FFF2-40B4-BE49-F238E27FC236}">
-                <a16:creationId xmlns:a16="http://schemas.microsoft.com/office/drawing/2014/main" id="{8A5B5C21-F080-290F-5E6F-F56261EA3A86}"/>
+                <a16:creationId xmlns:a16="http://schemas.microsoft.com/office/drawing/2014/main" id="{17ED00E9-6513-5211-43C6-C4A8934A2E01}"/>
               </a:ext>
             </a:extLst>
           </p:cNvPr>
@@ -8183,7 +8291,7 @@
           <p:cNvPr id="11" name="矩形: 圆角 10">
             <a:extLst>
               <a:ext uri="{FF2B5EF4-FFF2-40B4-BE49-F238E27FC236}">
-                <a16:creationId xmlns:a16="http://schemas.microsoft.com/office/drawing/2014/main" id="{A21DB3CC-D22C-1DF7-7DC3-0BCAC6C7EA52}"/>
+                <a16:creationId xmlns:a16="http://schemas.microsoft.com/office/drawing/2014/main" id="{0CF855A3-B818-672E-F902-BC69FC32F7F3}"/>
               </a:ext>
             </a:extLst>
           </p:cNvPr>
@@ -8245,7 +8353,7 @@
           <p:cNvPr id="12" name="矩形: 圆角 11">
             <a:extLst>
               <a:ext uri="{FF2B5EF4-FFF2-40B4-BE49-F238E27FC236}">
-                <a16:creationId xmlns:a16="http://schemas.microsoft.com/office/drawing/2014/main" id="{957DECAF-7A57-842D-8899-01ECCFDE9746}"/>
+                <a16:creationId xmlns:a16="http://schemas.microsoft.com/office/drawing/2014/main" id="{567828AB-6F3A-606B-367D-AC5E7CBFE711}"/>
               </a:ext>
             </a:extLst>
           </p:cNvPr>
@@ -8313,7 +8421,7 @@
           <p:cNvPr id="13" name="矩形: 圆角 12">
             <a:extLst>
               <a:ext uri="{FF2B5EF4-FFF2-40B4-BE49-F238E27FC236}">
-                <a16:creationId xmlns:a16="http://schemas.microsoft.com/office/drawing/2014/main" id="{C8FE6869-5F72-563A-54E4-3BCC2C9CDCA2}"/>
+                <a16:creationId xmlns:a16="http://schemas.microsoft.com/office/drawing/2014/main" id="{209BA874-5E3B-DAA2-88AB-9DFA57ABB770}"/>
               </a:ext>
             </a:extLst>
           </p:cNvPr>
@@ -8396,7 +8504,7 @@
           <p:cNvPr id="14" name="矩形: 圆角 13">
             <a:extLst>
               <a:ext uri="{FF2B5EF4-FFF2-40B4-BE49-F238E27FC236}">
-                <a16:creationId xmlns:a16="http://schemas.microsoft.com/office/drawing/2014/main" id="{CC863F4E-4AB8-7B65-5F39-0E0A58714BC5}"/>
+                <a16:creationId xmlns:a16="http://schemas.microsoft.com/office/drawing/2014/main" id="{B19ADA3A-4CBD-D85B-93A4-EAC990B82A19}"/>
               </a:ext>
             </a:extLst>
           </p:cNvPr>
@@ -8456,7 +8564,7 @@
     </p:spTree>
     <p:extLst>
       <p:ext uri="{BB962C8B-B14F-4D97-AF65-F5344CB8AC3E}">
-        <p14:creationId xmlns:p14="http://schemas.microsoft.com/office/powerpoint/2010/main" val="3938280469"/>
+        <p14:creationId xmlns:p14="http://schemas.microsoft.com/office/powerpoint/2010/main" val="2145871417"/>
       </p:ext>
     </p:extLst>
   </p:cSld>
@@ -8488,7 +8596,7 @@
           <p:cNvPr id="2" name="矩形 1">
             <a:extLst>
               <a:ext uri="{FF2B5EF4-FFF2-40B4-BE49-F238E27FC236}">
-                <a16:creationId xmlns:a16="http://schemas.microsoft.com/office/drawing/2014/main" id="{2AF162C2-7C46-45E7-6ADF-5805CDDC00C8}"/>
+                <a16:creationId xmlns:a16="http://schemas.microsoft.com/office/drawing/2014/main" id="{CEFAD57A-163B-4D67-816E-3E2482AC39E7}"/>
               </a:ext>
             </a:extLst>
           </p:cNvPr>
@@ -8542,7 +8650,7 @@
           <p:cNvPr id="3" name="矩形 2">
             <a:extLst>
               <a:ext uri="{FF2B5EF4-FFF2-40B4-BE49-F238E27FC236}">
-                <a16:creationId xmlns:a16="http://schemas.microsoft.com/office/drawing/2014/main" id="{A609B6CC-2F42-A851-A2E3-8CC7764FC869}"/>
+                <a16:creationId xmlns:a16="http://schemas.microsoft.com/office/drawing/2014/main" id="{A85622F5-1711-8B8A-77D0-D75416D35228}"/>
               </a:ext>
             </a:extLst>
           </p:cNvPr>
@@ -8596,7 +8704,7 @@
           <p:cNvPr id="4" name="矩形 3">
             <a:extLst>
               <a:ext uri="{FF2B5EF4-FFF2-40B4-BE49-F238E27FC236}">
-                <a16:creationId xmlns:a16="http://schemas.microsoft.com/office/drawing/2014/main" id="{6804F4E2-B45B-7184-63A4-69EEBEDE5DBF}"/>
+                <a16:creationId xmlns:a16="http://schemas.microsoft.com/office/drawing/2014/main" id="{15FBD4E8-4512-D59B-AB67-60D3AA717CB3}"/>
               </a:ext>
             </a:extLst>
           </p:cNvPr>
@@ -8650,7 +8758,7 @@
           <p:cNvPr id="5" name="文本框 4">
             <a:extLst>
               <a:ext uri="{FF2B5EF4-FFF2-40B4-BE49-F238E27FC236}">
-                <a16:creationId xmlns:a16="http://schemas.microsoft.com/office/drawing/2014/main" id="{01AA7144-7661-02B1-D2A4-43516AACB9F2}"/>
+                <a16:creationId xmlns:a16="http://schemas.microsoft.com/office/drawing/2014/main" id="{7BCBE96C-F9A9-4713-2272-E69A2244F28A}"/>
               </a:ext>
             </a:extLst>
           </p:cNvPr>
@@ -8690,7 +8798,7 @@
           <p:cNvPr id="6" name="文本框 5">
             <a:extLst>
               <a:ext uri="{FF2B5EF4-FFF2-40B4-BE49-F238E27FC236}">
-                <a16:creationId xmlns:a16="http://schemas.microsoft.com/office/drawing/2014/main" id="{A22AFA4F-FEB3-7C24-C23B-69BAEA9914F7}"/>
+                <a16:creationId xmlns:a16="http://schemas.microsoft.com/office/drawing/2014/main" id="{4B631D54-CB7E-E8B3-E44C-E6E5B1E1ABA5}"/>
               </a:ext>
             </a:extLst>
           </p:cNvPr>
@@ -8737,7 +8845,7 @@
           <p:cNvPr id="7" name="文本框 6">
             <a:extLst>
               <a:ext uri="{FF2B5EF4-FFF2-40B4-BE49-F238E27FC236}">
-                <a16:creationId xmlns:a16="http://schemas.microsoft.com/office/drawing/2014/main" id="{DE5AE72F-CC39-B5AE-8C13-F9CA23D02B4B}"/>
+                <a16:creationId xmlns:a16="http://schemas.microsoft.com/office/drawing/2014/main" id="{F832F44B-A79E-5FE6-61FF-75CF055FFF38}"/>
               </a:ext>
             </a:extLst>
           </p:cNvPr>
@@ -8795,7 +8903,7 @@
           <p:cNvPr id="8" name="矩形: 圆角 7">
             <a:extLst>
               <a:ext uri="{FF2B5EF4-FFF2-40B4-BE49-F238E27FC236}">
-                <a16:creationId xmlns:a16="http://schemas.microsoft.com/office/drawing/2014/main" id="{89EED204-2B32-9D15-966C-ACB0BFF1363B}"/>
+                <a16:creationId xmlns:a16="http://schemas.microsoft.com/office/drawing/2014/main" id="{990332CD-5B21-0E31-E81E-DDCDB4CC0357}"/>
               </a:ext>
             </a:extLst>
           </p:cNvPr>
@@ -8863,7 +8971,7 @@
           <p:cNvPr id="9" name="矩形: 圆角 8">
             <a:extLst>
               <a:ext uri="{FF2B5EF4-FFF2-40B4-BE49-F238E27FC236}">
-                <a16:creationId xmlns:a16="http://schemas.microsoft.com/office/drawing/2014/main" id="{CBA7DD8C-D73A-6967-B7DA-083849BBD261}"/>
+                <a16:creationId xmlns:a16="http://schemas.microsoft.com/office/drawing/2014/main" id="{8447CA28-0EB5-5E6A-44F7-6A63C0E2E396}"/>
               </a:ext>
             </a:extLst>
           </p:cNvPr>
@@ -8925,7 +9033,7 @@
           <p:cNvPr id="10" name="矩形: 圆角 9">
             <a:extLst>
               <a:ext uri="{FF2B5EF4-FFF2-40B4-BE49-F238E27FC236}">
-                <a16:creationId xmlns:a16="http://schemas.microsoft.com/office/drawing/2014/main" id="{728CCA64-CD03-2F88-7E5E-DAA58D23338E}"/>
+                <a16:creationId xmlns:a16="http://schemas.microsoft.com/office/drawing/2014/main" id="{67FFE6F3-0A82-F201-3C1D-499BD8C55DF9}"/>
               </a:ext>
             </a:extLst>
           </p:cNvPr>
@@ -8993,7 +9101,7 @@
           <p:cNvPr id="11" name="矩形: 圆角 10">
             <a:extLst>
               <a:ext uri="{FF2B5EF4-FFF2-40B4-BE49-F238E27FC236}">
-                <a16:creationId xmlns:a16="http://schemas.microsoft.com/office/drawing/2014/main" id="{D55FD758-6DFC-CD84-6A70-E7E3CB7972DE}"/>
+                <a16:creationId xmlns:a16="http://schemas.microsoft.com/office/drawing/2014/main" id="{51366FB0-C79C-2F52-B4B7-D28DB915D56B}"/>
               </a:ext>
             </a:extLst>
           </p:cNvPr>
@@ -9055,7 +9163,7 @@
           <p:cNvPr id="12" name="矩形: 圆角 11">
             <a:extLst>
               <a:ext uri="{FF2B5EF4-FFF2-40B4-BE49-F238E27FC236}">
-                <a16:creationId xmlns:a16="http://schemas.microsoft.com/office/drawing/2014/main" id="{3C96BFCF-9396-1B12-C23A-BBE9E38458E5}"/>
+                <a16:creationId xmlns:a16="http://schemas.microsoft.com/office/drawing/2014/main" id="{674CC7A5-08C9-F7CD-8AB5-0D3168E94805}"/>
               </a:ext>
             </a:extLst>
           </p:cNvPr>
@@ -9123,7 +9231,7 @@
           <p:cNvPr id="13" name="矩形: 圆角 12">
             <a:extLst>
               <a:ext uri="{FF2B5EF4-FFF2-40B4-BE49-F238E27FC236}">
-                <a16:creationId xmlns:a16="http://schemas.microsoft.com/office/drawing/2014/main" id="{1237E2B6-CA28-0B19-6BA7-8F05E4BDBF58}"/>
+                <a16:creationId xmlns:a16="http://schemas.microsoft.com/office/drawing/2014/main" id="{966352F6-7D80-854D-F492-EA3BCDDACF1A}"/>
               </a:ext>
             </a:extLst>
           </p:cNvPr>
@@ -9185,7 +9293,7 @@
           <p:cNvPr id="14" name="矩形: 圆角 13">
             <a:extLst>
               <a:ext uri="{FF2B5EF4-FFF2-40B4-BE49-F238E27FC236}">
-                <a16:creationId xmlns:a16="http://schemas.microsoft.com/office/drawing/2014/main" id="{9EE6FE8F-C177-66BB-E002-BF29DB3B3097}"/>
+                <a16:creationId xmlns:a16="http://schemas.microsoft.com/office/drawing/2014/main" id="{026BC49F-EAE4-FF36-241D-71C00A4A43C3}"/>
               </a:ext>
             </a:extLst>
           </p:cNvPr>
@@ -9194,8 +9302,8 @@
         </p:nvSpPr>
         <p:spPr>
           <a:xfrm>
-            <a:off x="2794000" y="4953000"/>
-            <a:ext cx="4318000" cy="685800"/>
+            <a:off x="2667000" y="4953000"/>
+            <a:ext cx="4191000" cy="685800"/>
           </a:xfrm>
           <a:prstGeom prst="roundRect">
             <a:avLst/>
@@ -9265,7 +9373,7 @@
           <p:cNvPr id="15" name="矩形: 圆角 14">
             <a:extLst>
               <a:ext uri="{FF2B5EF4-FFF2-40B4-BE49-F238E27FC236}">
-                <a16:creationId xmlns:a16="http://schemas.microsoft.com/office/drawing/2014/main" id="{CF3D26A7-C590-6C7B-B6B6-B5BF872E339B}"/>
+                <a16:creationId xmlns:a16="http://schemas.microsoft.com/office/drawing/2014/main" id="{85A99F91-ECEE-2CD5-C860-ECBF47CB1180}"/>
               </a:ext>
             </a:extLst>
           </p:cNvPr>
@@ -9274,8 +9382,8 @@
         </p:nvSpPr>
         <p:spPr>
           <a:xfrm>
-            <a:off x="7429500" y="4953000"/>
-            <a:ext cx="1270000" cy="685800"/>
+            <a:off x="7175500" y="4953000"/>
+            <a:ext cx="1968500" cy="685800"/>
           </a:xfrm>
           <a:prstGeom prst="roundRect">
             <a:avLst/>
@@ -9311,15 +9419,42 @@
           <a:p>
             <a:pPr algn="ctr"/>
             <a:r>
-              <a:rPr lang="en-US" altLang="zh-CN" sz="1400" b="1">
+              <a:rPr lang="zh-CN" altLang="en-US" sz="1150" b="1">
                 <a:solidFill>
                   <a:srgbClr val="FFFFFF"/>
                 </a:solidFill>
                 <a:latin typeface="Microsoft YaHei" panose="020B0503020204020204" pitchFamily="34" charset="-122"/>
               </a:rPr>
-              <a:t>caf8ced</a:t>
-            </a:r>
-            <a:endParaRPr lang="zh-CN" altLang="en-US" sz="1400" b="1">
+              <a:t>工程复现 </a:t>
+            </a:r>
+            <a:r>
+              <a:rPr lang="en-US" altLang="zh-CN" sz="1150" b="1">
+                <a:solidFill>
+                  <a:srgbClr val="FFFFFF"/>
+                </a:solidFill>
+                <a:latin typeface="Microsoft YaHei" panose="020B0503020204020204" pitchFamily="34" charset="-122"/>
+              </a:rPr>
+              <a:t>commit</a:t>
+            </a:r>
+            <a:r>
+              <a:rPr lang="zh-CN" altLang="en-US" sz="1150" b="1">
+                <a:solidFill>
+                  <a:srgbClr val="FFFFFF"/>
+                </a:solidFill>
+                <a:latin typeface="Microsoft YaHei" panose="020B0503020204020204" pitchFamily="34" charset="-122"/>
+              </a:rPr>
+              <a:t>：</a:t>
+            </a:r>
+            <a:r>
+              <a:rPr lang="en-US" altLang="zh-CN" sz="1150" b="1">
+                <a:solidFill>
+                  <a:srgbClr val="FFFFFF"/>
+                </a:solidFill>
+                <a:latin typeface="Microsoft YaHei" panose="020B0503020204020204" pitchFamily="34" charset="-122"/>
+              </a:rPr>
+              <a:t>db85947</a:t>
+            </a:r>
+            <a:endParaRPr lang="zh-CN" altLang="en-US" sz="1150" b="1">
               <a:solidFill>
                 <a:srgbClr val="FFFFFF"/>
               </a:solidFill>
@@ -9331,7 +9466,7 @@
     </p:spTree>
     <p:extLst>
       <p:ext uri="{BB962C8B-B14F-4D97-AF65-F5344CB8AC3E}">
-        <p14:creationId xmlns:p14="http://schemas.microsoft.com/office/powerpoint/2010/main" val="317271590"/>
+        <p14:creationId xmlns:p14="http://schemas.microsoft.com/office/powerpoint/2010/main" val="3426855196"/>
       </p:ext>
     </p:extLst>
   </p:cSld>
@@ -9363,7 +9498,7 @@
           <p:cNvPr id="2" name="矩形 1">
             <a:extLst>
               <a:ext uri="{FF2B5EF4-FFF2-40B4-BE49-F238E27FC236}">
-                <a16:creationId xmlns:a16="http://schemas.microsoft.com/office/drawing/2014/main" id="{15965A22-5FF1-93C4-8B65-723CA9042A7D}"/>
+                <a16:creationId xmlns:a16="http://schemas.microsoft.com/office/drawing/2014/main" id="{D0B166DB-0E6E-B19E-9286-484041F910B9}"/>
               </a:ext>
             </a:extLst>
           </p:cNvPr>
@@ -9417,7 +9552,7 @@
           <p:cNvPr id="3" name="矩形 2">
             <a:extLst>
               <a:ext uri="{FF2B5EF4-FFF2-40B4-BE49-F238E27FC236}">
-                <a16:creationId xmlns:a16="http://schemas.microsoft.com/office/drawing/2014/main" id="{382DD70A-9024-87B3-2967-6B8B5590BBBD}"/>
+                <a16:creationId xmlns:a16="http://schemas.microsoft.com/office/drawing/2014/main" id="{A4DEBEEA-46E7-E90C-66AB-E053AC7597FD}"/>
               </a:ext>
             </a:extLst>
           </p:cNvPr>
@@ -9471,7 +9606,7 @@
           <p:cNvPr id="4" name="矩形 3">
             <a:extLst>
               <a:ext uri="{FF2B5EF4-FFF2-40B4-BE49-F238E27FC236}">
-                <a16:creationId xmlns:a16="http://schemas.microsoft.com/office/drawing/2014/main" id="{7F20B78F-8A6F-B0C9-97BA-5DFA7D15E208}"/>
+                <a16:creationId xmlns:a16="http://schemas.microsoft.com/office/drawing/2014/main" id="{AAEA8178-D74C-AC16-931D-6A6FF9BB21D5}"/>
               </a:ext>
             </a:extLst>
           </p:cNvPr>
@@ -9525,7 +9660,7 @@
           <p:cNvPr id="5" name="文本框 4">
             <a:extLst>
               <a:ext uri="{FF2B5EF4-FFF2-40B4-BE49-F238E27FC236}">
-                <a16:creationId xmlns:a16="http://schemas.microsoft.com/office/drawing/2014/main" id="{23148D1B-41E2-1ED0-A9BE-EB0634EE3930}"/>
+                <a16:creationId xmlns:a16="http://schemas.microsoft.com/office/drawing/2014/main" id="{25D7CE64-2F04-D4C3-5D2C-DF95B79A11A1}"/>
               </a:ext>
             </a:extLst>
           </p:cNvPr>
@@ -9565,7 +9700,7 @@
           <p:cNvPr id="6" name="文本框 5">
             <a:extLst>
               <a:ext uri="{FF2B5EF4-FFF2-40B4-BE49-F238E27FC236}">
-                <a16:creationId xmlns:a16="http://schemas.microsoft.com/office/drawing/2014/main" id="{3F0ACB02-1AB3-CA07-7F82-9642C3B4FBB6}"/>
+                <a16:creationId xmlns:a16="http://schemas.microsoft.com/office/drawing/2014/main" id="{70AACDF1-19A8-14EC-2A17-7D5788E3AE65}"/>
               </a:ext>
             </a:extLst>
           </p:cNvPr>
@@ -9612,7 +9747,7 @@
           <p:cNvPr id="7" name="文本框 6">
             <a:extLst>
               <a:ext uri="{FF2B5EF4-FFF2-40B4-BE49-F238E27FC236}">
-                <a16:creationId xmlns:a16="http://schemas.microsoft.com/office/drawing/2014/main" id="{3EFAFEBE-3581-10BB-42AE-1FC1BEBEF6B2}"/>
+                <a16:creationId xmlns:a16="http://schemas.microsoft.com/office/drawing/2014/main" id="{39BCE635-0551-729F-91BF-290E2E651937}"/>
               </a:ext>
             </a:extLst>
           </p:cNvPr>
@@ -9688,7 +9823,7 @@
           <p:cNvPr id="8" name="矩形: 圆角 7">
             <a:extLst>
               <a:ext uri="{FF2B5EF4-FFF2-40B4-BE49-F238E27FC236}">
-                <a16:creationId xmlns:a16="http://schemas.microsoft.com/office/drawing/2014/main" id="{2EBFB701-78F2-D74C-E27D-8761E8098F78}"/>
+                <a16:creationId xmlns:a16="http://schemas.microsoft.com/office/drawing/2014/main" id="{EE55043A-4983-1E53-77AB-5ABA4ADCBED3}"/>
               </a:ext>
             </a:extLst>
           </p:cNvPr>
@@ -9750,7 +9885,7 @@
           <p:cNvPr id="9" name="矩形: 圆角 8">
             <a:extLst>
               <a:ext uri="{FF2B5EF4-FFF2-40B4-BE49-F238E27FC236}">
-                <a16:creationId xmlns:a16="http://schemas.microsoft.com/office/drawing/2014/main" id="{D0A63C0A-CF8D-BE30-BCE7-9C3CFF1440E7}"/>
+                <a16:creationId xmlns:a16="http://schemas.microsoft.com/office/drawing/2014/main" id="{1098E7BB-E8B9-9793-2E2D-AB7AF59BF0A5}"/>
               </a:ext>
             </a:extLst>
           </p:cNvPr>
@@ -9920,7 +10055,7 @@
           <p:cNvPr id="10" name="矩形: 圆角 9">
             <a:extLst>
               <a:ext uri="{FF2B5EF4-FFF2-40B4-BE49-F238E27FC236}">
-                <a16:creationId xmlns:a16="http://schemas.microsoft.com/office/drawing/2014/main" id="{A467CD39-B115-B21A-D454-8A55698920D1}"/>
+                <a16:creationId xmlns:a16="http://schemas.microsoft.com/office/drawing/2014/main" id="{02DD9E41-4BA7-79CA-C170-41F7CD69BCF1}"/>
               </a:ext>
             </a:extLst>
           </p:cNvPr>
@@ -9988,7 +10123,7 @@
           <p:cNvPr id="11" name="矩形: 圆角 10">
             <a:extLst>
               <a:ext uri="{FF2B5EF4-FFF2-40B4-BE49-F238E27FC236}">
-                <a16:creationId xmlns:a16="http://schemas.microsoft.com/office/drawing/2014/main" id="{D89DE1D4-CB58-ED26-E61B-205A0F872427}"/>
+                <a16:creationId xmlns:a16="http://schemas.microsoft.com/office/drawing/2014/main" id="{A5DFC9E6-289B-1497-DC6C-0989098CFECE}"/>
               </a:ext>
             </a:extLst>
           </p:cNvPr>
@@ -10074,7 +10209,7 @@
           <p:cNvPr id="12" name="矩形: 圆角 11">
             <a:extLst>
               <a:ext uri="{FF2B5EF4-FFF2-40B4-BE49-F238E27FC236}">
-                <a16:creationId xmlns:a16="http://schemas.microsoft.com/office/drawing/2014/main" id="{7D57CD9B-3386-C86C-12B6-DBA9EEC90BA1}"/>
+                <a16:creationId xmlns:a16="http://schemas.microsoft.com/office/drawing/2014/main" id="{80598EA2-CA62-E673-8F63-8DB7DA11683A}"/>
               </a:ext>
             </a:extLst>
           </p:cNvPr>
@@ -10136,7 +10271,7 @@
           <p:cNvPr id="13" name="矩形: 圆角 12">
             <a:extLst>
               <a:ext uri="{FF2B5EF4-FFF2-40B4-BE49-F238E27FC236}">
-                <a16:creationId xmlns:a16="http://schemas.microsoft.com/office/drawing/2014/main" id="{CE453C33-125B-D8EF-9739-D87645338F5D}"/>
+                <a16:creationId xmlns:a16="http://schemas.microsoft.com/office/drawing/2014/main" id="{AC4A0E5D-F227-63B1-FDBA-E3E621D3677B}"/>
               </a:ext>
             </a:extLst>
           </p:cNvPr>
@@ -10243,7 +10378,7 @@
           <p:cNvPr id="14" name="矩形: 圆角 13">
             <a:extLst>
               <a:ext uri="{FF2B5EF4-FFF2-40B4-BE49-F238E27FC236}">
-                <a16:creationId xmlns:a16="http://schemas.microsoft.com/office/drawing/2014/main" id="{36988DC9-7538-4630-F33B-370EA4E350F2}"/>
+                <a16:creationId xmlns:a16="http://schemas.microsoft.com/office/drawing/2014/main" id="{C0D8D224-CC7D-D000-B59C-EEA4F39E2E00}"/>
               </a:ext>
             </a:extLst>
           </p:cNvPr>
@@ -10312,7 +10447,7 @@
     </p:spTree>
     <p:extLst>
       <p:ext uri="{BB962C8B-B14F-4D97-AF65-F5344CB8AC3E}">
-        <p14:creationId xmlns:p14="http://schemas.microsoft.com/office/powerpoint/2010/main" val="1427584936"/>
+        <p14:creationId xmlns:p14="http://schemas.microsoft.com/office/powerpoint/2010/main" val="3637271509"/>
       </p:ext>
     </p:extLst>
   </p:cSld>
@@ -10344,7 +10479,7 @@
           <p:cNvPr id="2" name="矩形 1">
             <a:extLst>
               <a:ext uri="{FF2B5EF4-FFF2-40B4-BE49-F238E27FC236}">
-                <a16:creationId xmlns:a16="http://schemas.microsoft.com/office/drawing/2014/main" id="{511294B4-0628-D779-A11C-96A54F568013}"/>
+                <a16:creationId xmlns:a16="http://schemas.microsoft.com/office/drawing/2014/main" id="{206A6C8C-250B-0CFE-059B-1E2750F066CF}"/>
               </a:ext>
             </a:extLst>
           </p:cNvPr>
@@ -10398,7 +10533,7 @@
           <p:cNvPr id="3" name="矩形 2">
             <a:extLst>
               <a:ext uri="{FF2B5EF4-FFF2-40B4-BE49-F238E27FC236}">
-                <a16:creationId xmlns:a16="http://schemas.microsoft.com/office/drawing/2014/main" id="{12FE0AFF-D064-0415-9221-3622DBB326F1}"/>
+                <a16:creationId xmlns:a16="http://schemas.microsoft.com/office/drawing/2014/main" id="{9EB82A33-4EAD-21FE-BB33-199205F2020D}"/>
               </a:ext>
             </a:extLst>
           </p:cNvPr>
@@ -10452,7 +10587,7 @@
           <p:cNvPr id="4" name="矩形 3">
             <a:extLst>
               <a:ext uri="{FF2B5EF4-FFF2-40B4-BE49-F238E27FC236}">
-                <a16:creationId xmlns:a16="http://schemas.microsoft.com/office/drawing/2014/main" id="{EF564619-15CB-F0FF-552B-CAB7F8D47D92}"/>
+                <a16:creationId xmlns:a16="http://schemas.microsoft.com/office/drawing/2014/main" id="{BC17FBE5-6F7D-FCE8-3F7D-E6CC7E447129}"/>
               </a:ext>
             </a:extLst>
           </p:cNvPr>
@@ -10506,7 +10641,7 @@
           <p:cNvPr id="5" name="文本框 4">
             <a:extLst>
               <a:ext uri="{FF2B5EF4-FFF2-40B4-BE49-F238E27FC236}">
-                <a16:creationId xmlns:a16="http://schemas.microsoft.com/office/drawing/2014/main" id="{8A73DB8D-AAA2-CBF5-749A-7AB7A92D1128}"/>
+                <a16:creationId xmlns:a16="http://schemas.microsoft.com/office/drawing/2014/main" id="{7CDFF329-8C14-2BE6-2BFF-5FF55B5D9C74}"/>
               </a:ext>
             </a:extLst>
           </p:cNvPr>
@@ -10564,7 +10699,7 @@
           <p:cNvPr id="6" name="文本框 5">
             <a:extLst>
               <a:ext uri="{FF2B5EF4-FFF2-40B4-BE49-F238E27FC236}">
-                <a16:creationId xmlns:a16="http://schemas.microsoft.com/office/drawing/2014/main" id="{D5F5C602-1D3B-D04A-E225-1FDD21C1CADA}"/>
+                <a16:creationId xmlns:a16="http://schemas.microsoft.com/office/drawing/2014/main" id="{79FB97AF-0EBD-34AF-F276-B2BAA51D3B53}"/>
               </a:ext>
             </a:extLst>
           </p:cNvPr>
@@ -10611,7 +10746,7 @@
           <p:cNvPr id="7" name="文本框 6">
             <a:extLst>
               <a:ext uri="{FF2B5EF4-FFF2-40B4-BE49-F238E27FC236}">
-                <a16:creationId xmlns:a16="http://schemas.microsoft.com/office/drawing/2014/main" id="{4177A79F-7EAB-A45E-02EA-0FC5CAA887DB}"/>
+                <a16:creationId xmlns:a16="http://schemas.microsoft.com/office/drawing/2014/main" id="{3D688512-BF21-B8B7-23D0-C721114717DB}"/>
               </a:ext>
             </a:extLst>
           </p:cNvPr>
@@ -10705,7 +10840,7 @@
           <p:cNvPr id="8" name="矩形: 圆角 7">
             <a:extLst>
               <a:ext uri="{FF2B5EF4-FFF2-40B4-BE49-F238E27FC236}">
-                <a16:creationId xmlns:a16="http://schemas.microsoft.com/office/drawing/2014/main" id="{6378E70B-5040-FE12-45F3-8F52BF7D5561}"/>
+                <a16:creationId xmlns:a16="http://schemas.microsoft.com/office/drawing/2014/main" id="{306631F9-DAC5-4037-B429-9170994CD0E7}"/>
               </a:ext>
             </a:extLst>
           </p:cNvPr>
@@ -10767,7 +10902,7 @@
           <p:cNvPr id="9" name="矩形: 圆角 8">
             <a:extLst>
               <a:ext uri="{FF2B5EF4-FFF2-40B4-BE49-F238E27FC236}">
-                <a16:creationId xmlns:a16="http://schemas.microsoft.com/office/drawing/2014/main" id="{334D1F55-4920-F03E-70E5-08AEC8690673}"/>
+                <a16:creationId xmlns:a16="http://schemas.microsoft.com/office/drawing/2014/main" id="{4087ED18-126D-749F-9EF2-9BE1F0F908E6}"/>
               </a:ext>
             </a:extLst>
           </p:cNvPr>
@@ -10829,7 +10964,7 @@
           <p:cNvPr id="10" name="矩形: 圆角 9">
             <a:extLst>
               <a:ext uri="{FF2B5EF4-FFF2-40B4-BE49-F238E27FC236}">
-                <a16:creationId xmlns:a16="http://schemas.microsoft.com/office/drawing/2014/main" id="{3EFEAAA6-0A25-AC93-5478-C52363346750}"/>
+                <a16:creationId xmlns:a16="http://schemas.microsoft.com/office/drawing/2014/main" id="{822FF61F-800F-98F9-77CE-A8C7086A1A73}"/>
               </a:ext>
             </a:extLst>
           </p:cNvPr>
@@ -10891,7 +11026,7 @@
           <p:cNvPr id="11" name="矩形: 圆角 10">
             <a:extLst>
               <a:ext uri="{FF2B5EF4-FFF2-40B4-BE49-F238E27FC236}">
-                <a16:creationId xmlns:a16="http://schemas.microsoft.com/office/drawing/2014/main" id="{D6CA5A00-7420-A614-6379-B38CBED9FB0D}"/>
+                <a16:creationId xmlns:a16="http://schemas.microsoft.com/office/drawing/2014/main" id="{405EE246-4EE1-F66D-B3AA-9A952E4A3997}"/>
               </a:ext>
             </a:extLst>
           </p:cNvPr>
@@ -10953,7 +11088,7 @@
           <p:cNvPr id="12" name="矩形: 圆角 11">
             <a:extLst>
               <a:ext uri="{FF2B5EF4-FFF2-40B4-BE49-F238E27FC236}">
-                <a16:creationId xmlns:a16="http://schemas.microsoft.com/office/drawing/2014/main" id="{1E9A901B-061A-5878-4CC1-4F0991D8765D}"/>
+                <a16:creationId xmlns:a16="http://schemas.microsoft.com/office/drawing/2014/main" id="{F02DD48F-BD88-4224-4269-6EC9521D6A3C}"/>
               </a:ext>
             </a:extLst>
           </p:cNvPr>
@@ -11015,7 +11150,7 @@
           <p:cNvPr id="13" name="矩形: 圆角 12">
             <a:extLst>
               <a:ext uri="{FF2B5EF4-FFF2-40B4-BE49-F238E27FC236}">
-                <a16:creationId xmlns:a16="http://schemas.microsoft.com/office/drawing/2014/main" id="{B10587A8-E2E2-9023-6932-49F24E89AB03}"/>
+                <a16:creationId xmlns:a16="http://schemas.microsoft.com/office/drawing/2014/main" id="{A22F496F-D8EF-B1AB-7319-FF7C6DFC8C09}"/>
               </a:ext>
             </a:extLst>
           </p:cNvPr>
@@ -11077,7 +11212,7 @@
           <p:cNvPr id="14" name="矩形: 圆角 13">
             <a:extLst>
               <a:ext uri="{FF2B5EF4-FFF2-40B4-BE49-F238E27FC236}">
-                <a16:creationId xmlns:a16="http://schemas.microsoft.com/office/drawing/2014/main" id="{6557A970-4C08-6425-FE1E-D0F778B2BD52}"/>
+                <a16:creationId xmlns:a16="http://schemas.microsoft.com/office/drawing/2014/main" id="{747B8D2C-3AD1-D4A0-E5EE-DD42157D8B33}"/>
               </a:ext>
             </a:extLst>
           </p:cNvPr>
@@ -11224,7 +11359,7 @@
     </p:spTree>
     <p:extLst>
       <p:ext uri="{BB962C8B-B14F-4D97-AF65-F5344CB8AC3E}">
-        <p14:creationId xmlns:p14="http://schemas.microsoft.com/office/powerpoint/2010/main" val="2885329354"/>
+        <p14:creationId xmlns:p14="http://schemas.microsoft.com/office/powerpoint/2010/main" val="1098303654"/>
       </p:ext>
     </p:extLst>
   </p:cSld>
@@ -11256,7 +11391,7 @@
           <p:cNvPr id="2" name="矩形 1">
             <a:extLst>
               <a:ext uri="{FF2B5EF4-FFF2-40B4-BE49-F238E27FC236}">
-                <a16:creationId xmlns:a16="http://schemas.microsoft.com/office/drawing/2014/main" id="{A2AA3F2D-EF8D-C1FD-B6F7-5257C1274909}"/>
+                <a16:creationId xmlns:a16="http://schemas.microsoft.com/office/drawing/2014/main" id="{EEF54E83-CA98-2BE5-2BC1-F07125319EB0}"/>
               </a:ext>
             </a:extLst>
           </p:cNvPr>
@@ -11310,7 +11445,7 @@
           <p:cNvPr id="3" name="矩形 2">
             <a:extLst>
               <a:ext uri="{FF2B5EF4-FFF2-40B4-BE49-F238E27FC236}">
-                <a16:creationId xmlns:a16="http://schemas.microsoft.com/office/drawing/2014/main" id="{D8C9C050-52AB-6408-3209-985411234261}"/>
+                <a16:creationId xmlns:a16="http://schemas.microsoft.com/office/drawing/2014/main" id="{6069DB9C-DF5B-0070-22F1-B538679B9FF2}"/>
               </a:ext>
             </a:extLst>
           </p:cNvPr>
@@ -11364,7 +11499,7 @@
           <p:cNvPr id="4" name="矩形 3">
             <a:extLst>
               <a:ext uri="{FF2B5EF4-FFF2-40B4-BE49-F238E27FC236}">
-                <a16:creationId xmlns:a16="http://schemas.microsoft.com/office/drawing/2014/main" id="{22A241DC-08DB-DCEA-BB9F-5B24AF3993B5}"/>
+                <a16:creationId xmlns:a16="http://schemas.microsoft.com/office/drawing/2014/main" id="{5AC42705-1FB7-2A33-0B40-D9526861EFB1}"/>
               </a:ext>
             </a:extLst>
           </p:cNvPr>
@@ -11418,7 +11553,7 @@
           <p:cNvPr id="5" name="文本框 4">
             <a:extLst>
               <a:ext uri="{FF2B5EF4-FFF2-40B4-BE49-F238E27FC236}">
-                <a16:creationId xmlns:a16="http://schemas.microsoft.com/office/drawing/2014/main" id="{21EAD965-D48D-4215-2C9A-8487E7997238}"/>
+                <a16:creationId xmlns:a16="http://schemas.microsoft.com/office/drawing/2014/main" id="{B4FC390B-0F95-E712-AB7D-B7571AB96F0B}"/>
               </a:ext>
             </a:extLst>
           </p:cNvPr>
@@ -11458,7 +11593,7 @@
           <p:cNvPr id="6" name="文本框 5">
             <a:extLst>
               <a:ext uri="{FF2B5EF4-FFF2-40B4-BE49-F238E27FC236}">
-                <a16:creationId xmlns:a16="http://schemas.microsoft.com/office/drawing/2014/main" id="{E752C2FD-94B8-796B-EE6A-1B83811A79AD}"/>
+                <a16:creationId xmlns:a16="http://schemas.microsoft.com/office/drawing/2014/main" id="{4651AA81-5CE9-55F7-EA75-D1688970EC9E}"/>
               </a:ext>
             </a:extLst>
           </p:cNvPr>
@@ -11505,7 +11640,7 @@
           <p:cNvPr id="7" name="文本框 6">
             <a:extLst>
               <a:ext uri="{FF2B5EF4-FFF2-40B4-BE49-F238E27FC236}">
-                <a16:creationId xmlns:a16="http://schemas.microsoft.com/office/drawing/2014/main" id="{58A6B020-47B0-7C8D-3D00-1C24DD347166}"/>
+                <a16:creationId xmlns:a16="http://schemas.microsoft.com/office/drawing/2014/main" id="{17CA93F3-A2A9-6E37-1467-97A1A84151D8}"/>
               </a:ext>
             </a:extLst>
           </p:cNvPr>
@@ -11545,7 +11680,7 @@
           <p:cNvPr id="8" name="矩形: 圆角 7">
             <a:extLst>
               <a:ext uri="{FF2B5EF4-FFF2-40B4-BE49-F238E27FC236}">
-                <a16:creationId xmlns:a16="http://schemas.microsoft.com/office/drawing/2014/main" id="{2511E8CF-E4ED-66A6-877C-7D40A4FB4311}"/>
+                <a16:creationId xmlns:a16="http://schemas.microsoft.com/office/drawing/2014/main" id="{0A8FB2D9-7F04-5446-BF93-346B894AD0F3}"/>
               </a:ext>
             </a:extLst>
           </p:cNvPr>
@@ -11607,7 +11742,7 @@
           <p:cNvPr id="9" name="矩形: 圆角 8">
             <a:extLst>
               <a:ext uri="{FF2B5EF4-FFF2-40B4-BE49-F238E27FC236}">
-                <a16:creationId xmlns:a16="http://schemas.microsoft.com/office/drawing/2014/main" id="{007B27B8-3024-5DBF-E928-1A853DB392BF}"/>
+                <a16:creationId xmlns:a16="http://schemas.microsoft.com/office/drawing/2014/main" id="{D9B9DAD1-FCA5-627A-05E6-EB7F7B167BDE}"/>
               </a:ext>
             </a:extLst>
           </p:cNvPr>
@@ -11678,7 +11813,7 @@
           <p:cNvPr id="10" name="矩形: 圆角 9">
             <a:extLst>
               <a:ext uri="{FF2B5EF4-FFF2-40B4-BE49-F238E27FC236}">
-                <a16:creationId xmlns:a16="http://schemas.microsoft.com/office/drawing/2014/main" id="{4F9E3B89-5BAD-2725-85FE-6C65BFE94C32}"/>
+                <a16:creationId xmlns:a16="http://schemas.microsoft.com/office/drawing/2014/main" id="{BA604C46-E707-6E30-01BA-61D7C84C3C57}"/>
               </a:ext>
             </a:extLst>
           </p:cNvPr>
@@ -11740,7 +11875,7 @@
           <p:cNvPr id="11" name="矩形: 圆角 10">
             <a:extLst>
               <a:ext uri="{FF2B5EF4-FFF2-40B4-BE49-F238E27FC236}">
-                <a16:creationId xmlns:a16="http://schemas.microsoft.com/office/drawing/2014/main" id="{89653ADE-FCCF-CE4A-4885-393FA1707D3A}"/>
+                <a16:creationId xmlns:a16="http://schemas.microsoft.com/office/drawing/2014/main" id="{C29DAF71-D7B3-FA61-E14F-B99B91EE3CE9}"/>
               </a:ext>
             </a:extLst>
           </p:cNvPr>
@@ -11802,7 +11937,7 @@
           <p:cNvPr id="12" name="矩形: 圆角 11">
             <a:extLst>
               <a:ext uri="{FF2B5EF4-FFF2-40B4-BE49-F238E27FC236}">
-                <a16:creationId xmlns:a16="http://schemas.microsoft.com/office/drawing/2014/main" id="{83D55DFD-8386-B962-EDC5-BADC5DE18EDB}"/>
+                <a16:creationId xmlns:a16="http://schemas.microsoft.com/office/drawing/2014/main" id="{2DBD55EA-45AE-5034-FB46-F7E12F337091}"/>
               </a:ext>
             </a:extLst>
           </p:cNvPr>
@@ -11864,7 +11999,7 @@
           <p:cNvPr id="13" name="矩形: 圆角 12">
             <a:extLst>
               <a:ext uri="{FF2B5EF4-FFF2-40B4-BE49-F238E27FC236}">
-                <a16:creationId xmlns:a16="http://schemas.microsoft.com/office/drawing/2014/main" id="{9126176B-A8C8-9A8A-EE3D-B4C90381C387}"/>
+                <a16:creationId xmlns:a16="http://schemas.microsoft.com/office/drawing/2014/main" id="{88C09052-C740-95DE-686B-131EBF95BF7A}"/>
               </a:ext>
             </a:extLst>
           </p:cNvPr>
@@ -11924,7 +12059,7 @@
     </p:spTree>
     <p:extLst>
       <p:ext uri="{BB962C8B-B14F-4D97-AF65-F5344CB8AC3E}">
-        <p14:creationId xmlns:p14="http://schemas.microsoft.com/office/powerpoint/2010/main" val="3271704059"/>
+        <p14:creationId xmlns:p14="http://schemas.microsoft.com/office/powerpoint/2010/main" val="2013697404"/>
       </p:ext>
     </p:extLst>
   </p:cSld>
@@ -11956,7 +12091,7 @@
           <p:cNvPr id="2" name="矩形 1">
             <a:extLst>
               <a:ext uri="{FF2B5EF4-FFF2-40B4-BE49-F238E27FC236}">
-                <a16:creationId xmlns:a16="http://schemas.microsoft.com/office/drawing/2014/main" id="{27B75D67-3F4D-C6C4-B480-6498181CC589}"/>
+                <a16:creationId xmlns:a16="http://schemas.microsoft.com/office/drawing/2014/main" id="{5FDFD445-7A41-D118-0583-D455D023E9F4}"/>
               </a:ext>
             </a:extLst>
           </p:cNvPr>
@@ -12010,7 +12145,7 @@
           <p:cNvPr id="3" name="矩形 2">
             <a:extLst>
               <a:ext uri="{FF2B5EF4-FFF2-40B4-BE49-F238E27FC236}">
-                <a16:creationId xmlns:a16="http://schemas.microsoft.com/office/drawing/2014/main" id="{8AC3752F-299C-F800-9EC3-21F96FA7ECBF}"/>
+                <a16:creationId xmlns:a16="http://schemas.microsoft.com/office/drawing/2014/main" id="{8A5DF01A-437C-3393-F429-D3C259DD7E2A}"/>
               </a:ext>
             </a:extLst>
           </p:cNvPr>
@@ -12064,7 +12199,7 @@
           <p:cNvPr id="4" name="矩形 3">
             <a:extLst>
               <a:ext uri="{FF2B5EF4-FFF2-40B4-BE49-F238E27FC236}">
-                <a16:creationId xmlns:a16="http://schemas.microsoft.com/office/drawing/2014/main" id="{404D031B-0E3C-A126-034A-D70BEE446BCE}"/>
+                <a16:creationId xmlns:a16="http://schemas.microsoft.com/office/drawing/2014/main" id="{2DDBED0F-596B-98A9-8C9F-2C381F1208F2}"/>
               </a:ext>
             </a:extLst>
           </p:cNvPr>
@@ -12118,7 +12253,7 @@
           <p:cNvPr id="5" name="文本框 4">
             <a:extLst>
               <a:ext uri="{FF2B5EF4-FFF2-40B4-BE49-F238E27FC236}">
-                <a16:creationId xmlns:a16="http://schemas.microsoft.com/office/drawing/2014/main" id="{AE04FA8B-FB97-A8F9-FC16-A11BFB27A563}"/>
+                <a16:creationId xmlns:a16="http://schemas.microsoft.com/office/drawing/2014/main" id="{8C8B1F01-DBFF-73A0-2E82-67B5DB594325}"/>
               </a:ext>
             </a:extLst>
           </p:cNvPr>
@@ -12158,7 +12293,7 @@
           <p:cNvPr id="6" name="文本框 5">
             <a:extLst>
               <a:ext uri="{FF2B5EF4-FFF2-40B4-BE49-F238E27FC236}">
-                <a16:creationId xmlns:a16="http://schemas.microsoft.com/office/drawing/2014/main" id="{898E1F90-DD7C-8501-655E-6657AC21CE3A}"/>
+                <a16:creationId xmlns:a16="http://schemas.microsoft.com/office/drawing/2014/main" id="{95DE15A8-3B7F-8ACB-514E-76B8B76D42E2}"/>
               </a:ext>
             </a:extLst>
           </p:cNvPr>
@@ -12205,7 +12340,7 @@
           <p:cNvPr id="7" name="文本框 6">
             <a:extLst>
               <a:ext uri="{FF2B5EF4-FFF2-40B4-BE49-F238E27FC236}">
-                <a16:creationId xmlns:a16="http://schemas.microsoft.com/office/drawing/2014/main" id="{7B4ECD76-BB6B-0DC3-1993-B90E49A6538C}"/>
+                <a16:creationId xmlns:a16="http://schemas.microsoft.com/office/drawing/2014/main" id="{C2D03E13-9DC9-804C-A6CB-9C8A09A87F62}"/>
               </a:ext>
             </a:extLst>
           </p:cNvPr>
@@ -12245,7 +12380,7 @@
           <p:cNvPr id="8" name="矩形: 圆角 7">
             <a:extLst>
               <a:ext uri="{FF2B5EF4-FFF2-40B4-BE49-F238E27FC236}">
-                <a16:creationId xmlns:a16="http://schemas.microsoft.com/office/drawing/2014/main" id="{7EE3F375-E6D6-722A-AFDA-DED1367F8848}"/>
+                <a16:creationId xmlns:a16="http://schemas.microsoft.com/office/drawing/2014/main" id="{1BE4324C-F196-E932-9A23-E5B7FAE2F223}"/>
               </a:ext>
             </a:extLst>
           </p:cNvPr>
@@ -12355,7 +12490,7 @@
           <p:cNvPr id="9" name="矩形: 圆角 8">
             <a:extLst>
               <a:ext uri="{FF2B5EF4-FFF2-40B4-BE49-F238E27FC236}">
-                <a16:creationId xmlns:a16="http://schemas.microsoft.com/office/drawing/2014/main" id="{6E198301-1667-B5AD-6267-71C21B67E859}"/>
+                <a16:creationId xmlns:a16="http://schemas.microsoft.com/office/drawing/2014/main" id="{C1150211-6874-524B-2AE0-C04DBD8BB98E}"/>
               </a:ext>
             </a:extLst>
           </p:cNvPr>
@@ -12462,7 +12597,7 @@
           <p:cNvPr id="10" name="矩形: 圆角 9">
             <a:extLst>
               <a:ext uri="{FF2B5EF4-FFF2-40B4-BE49-F238E27FC236}">
-                <a16:creationId xmlns:a16="http://schemas.microsoft.com/office/drawing/2014/main" id="{1B5D774C-9E5F-AEE8-2451-7075F8544244}"/>
+                <a16:creationId xmlns:a16="http://schemas.microsoft.com/office/drawing/2014/main" id="{518633BE-27C6-C730-1C05-F218D5E784D5}"/>
               </a:ext>
             </a:extLst>
           </p:cNvPr>
@@ -12554,7 +12689,7 @@
           <p:cNvPr id="11" name="矩形: 圆角 10">
             <a:extLst>
               <a:ext uri="{FF2B5EF4-FFF2-40B4-BE49-F238E27FC236}">
-                <a16:creationId xmlns:a16="http://schemas.microsoft.com/office/drawing/2014/main" id="{D45B3F30-B5C9-6AEC-9952-5666C68A2CD8}"/>
+                <a16:creationId xmlns:a16="http://schemas.microsoft.com/office/drawing/2014/main" id="{95BC7F9D-EB15-33A9-E652-3A7C068F2CE5}"/>
               </a:ext>
             </a:extLst>
           </p:cNvPr>
@@ -12664,7 +12799,7 @@
           <p:cNvPr id="12" name="矩形: 圆角 11">
             <a:extLst>
               <a:ext uri="{FF2B5EF4-FFF2-40B4-BE49-F238E27FC236}">
-                <a16:creationId xmlns:a16="http://schemas.microsoft.com/office/drawing/2014/main" id="{983D5001-ACE0-B12E-01ED-0D2C5801C3C4}"/>
+                <a16:creationId xmlns:a16="http://schemas.microsoft.com/office/drawing/2014/main" id="{F97CB929-C239-5904-70F0-E6EE6C03A4A6}"/>
               </a:ext>
             </a:extLst>
           </p:cNvPr>
@@ -12774,7 +12909,7 @@
           <p:cNvPr id="13" name="矩形: 圆角 12">
             <a:extLst>
               <a:ext uri="{FF2B5EF4-FFF2-40B4-BE49-F238E27FC236}">
-                <a16:creationId xmlns:a16="http://schemas.microsoft.com/office/drawing/2014/main" id="{E5A801C3-3381-DAE0-C6A7-37F8D6D5ECCA}"/>
+                <a16:creationId xmlns:a16="http://schemas.microsoft.com/office/drawing/2014/main" id="{39B5FF1E-5EBA-F69B-C5B3-65C63A34F2EE}"/>
               </a:ext>
             </a:extLst>
           </p:cNvPr>
@@ -12870,7 +13005,7 @@
     </p:spTree>
     <p:extLst>
       <p:ext uri="{BB962C8B-B14F-4D97-AF65-F5344CB8AC3E}">
-        <p14:creationId xmlns:p14="http://schemas.microsoft.com/office/powerpoint/2010/main" val="1111639262"/>
+        <p14:creationId xmlns:p14="http://schemas.microsoft.com/office/powerpoint/2010/main" val="1042310129"/>
       </p:ext>
     </p:extLst>
   </p:cSld>
@@ -12902,7 +13037,7 @@
           <p:cNvPr id="2" name="矩形 1">
             <a:extLst>
               <a:ext uri="{FF2B5EF4-FFF2-40B4-BE49-F238E27FC236}">
-                <a16:creationId xmlns:a16="http://schemas.microsoft.com/office/drawing/2014/main" id="{5F43E655-DB2D-E5B5-EF61-D79494B291A2}"/>
+                <a16:creationId xmlns:a16="http://schemas.microsoft.com/office/drawing/2014/main" id="{49D83675-E0A0-236C-CF6E-52909B95C4F5}"/>
               </a:ext>
             </a:extLst>
           </p:cNvPr>
@@ -12956,7 +13091,7 @@
           <p:cNvPr id="3" name="矩形 2">
             <a:extLst>
               <a:ext uri="{FF2B5EF4-FFF2-40B4-BE49-F238E27FC236}">
-                <a16:creationId xmlns:a16="http://schemas.microsoft.com/office/drawing/2014/main" id="{9CC0B8D9-B572-0E1A-5866-7B9F7D8669CA}"/>
+                <a16:creationId xmlns:a16="http://schemas.microsoft.com/office/drawing/2014/main" id="{6FA2BE58-B7D2-C670-CEAC-BC7815E1BD01}"/>
               </a:ext>
             </a:extLst>
           </p:cNvPr>
@@ -13010,7 +13145,7 @@
           <p:cNvPr id="4" name="矩形 3">
             <a:extLst>
               <a:ext uri="{FF2B5EF4-FFF2-40B4-BE49-F238E27FC236}">
-                <a16:creationId xmlns:a16="http://schemas.microsoft.com/office/drawing/2014/main" id="{2BF24689-DAFA-E235-D0F4-4D81501E4FA1}"/>
+                <a16:creationId xmlns:a16="http://schemas.microsoft.com/office/drawing/2014/main" id="{42635A55-ACF1-F470-BAB8-C2AB1AA77ED0}"/>
               </a:ext>
             </a:extLst>
           </p:cNvPr>
@@ -13064,7 +13199,7 @@
           <p:cNvPr id="5" name="文本框 4">
             <a:extLst>
               <a:ext uri="{FF2B5EF4-FFF2-40B4-BE49-F238E27FC236}">
-                <a16:creationId xmlns:a16="http://schemas.microsoft.com/office/drawing/2014/main" id="{0076CD90-C33C-261D-B049-493B641BD643}"/>
+                <a16:creationId xmlns:a16="http://schemas.microsoft.com/office/drawing/2014/main" id="{13EE4469-EA96-7C3A-E938-F161D31B8CC3}"/>
               </a:ext>
             </a:extLst>
           </p:cNvPr>
@@ -13104,7 +13239,7 @@
           <p:cNvPr id="6" name="文本框 5">
             <a:extLst>
               <a:ext uri="{FF2B5EF4-FFF2-40B4-BE49-F238E27FC236}">
-                <a16:creationId xmlns:a16="http://schemas.microsoft.com/office/drawing/2014/main" id="{752FEC61-8044-26B3-F56F-A88072DCDE81}"/>
+                <a16:creationId xmlns:a16="http://schemas.microsoft.com/office/drawing/2014/main" id="{D17BA5F8-D9D4-7EFD-D798-EFA929FD2503}"/>
               </a:ext>
             </a:extLst>
           </p:cNvPr>
@@ -13151,7 +13286,7 @@
           <p:cNvPr id="7" name="文本框 6">
             <a:extLst>
               <a:ext uri="{FF2B5EF4-FFF2-40B4-BE49-F238E27FC236}">
-                <a16:creationId xmlns:a16="http://schemas.microsoft.com/office/drawing/2014/main" id="{1FED3B8F-D989-E84B-3A0F-2DE1834D728B}"/>
+                <a16:creationId xmlns:a16="http://schemas.microsoft.com/office/drawing/2014/main" id="{81986F58-B2C5-918D-E87C-C258090996C5}"/>
               </a:ext>
             </a:extLst>
           </p:cNvPr>
@@ -13209,7 +13344,7 @@
           <p:cNvPr id="8" name="矩形: 圆角 7">
             <a:extLst>
               <a:ext uri="{FF2B5EF4-FFF2-40B4-BE49-F238E27FC236}">
-                <a16:creationId xmlns:a16="http://schemas.microsoft.com/office/drawing/2014/main" id="{B19A2EC1-ADCA-40AE-7485-D91379F41BD7}"/>
+                <a16:creationId xmlns:a16="http://schemas.microsoft.com/office/drawing/2014/main" id="{213A9D80-C89E-08AB-6057-E8D230270740}"/>
               </a:ext>
             </a:extLst>
           </p:cNvPr>
@@ -13271,7 +13406,7 @@
           <p:cNvPr id="9" name="矩形: 圆角 8">
             <a:extLst>
               <a:ext uri="{FF2B5EF4-FFF2-40B4-BE49-F238E27FC236}">
-                <a16:creationId xmlns:a16="http://schemas.microsoft.com/office/drawing/2014/main" id="{160E4742-FEC4-4E54-3FDC-39CCA0FDF402}"/>
+                <a16:creationId xmlns:a16="http://schemas.microsoft.com/office/drawing/2014/main" id="{FE15E8DD-6089-9F4D-C7AE-F2519B12FDF0}"/>
               </a:ext>
             </a:extLst>
           </p:cNvPr>
@@ -13369,7 +13504,7 @@
           <p:cNvPr id="10" name="矩形: 圆角 9">
             <a:extLst>
               <a:ext uri="{FF2B5EF4-FFF2-40B4-BE49-F238E27FC236}">
-                <a16:creationId xmlns:a16="http://schemas.microsoft.com/office/drawing/2014/main" id="{AD8B77FD-A80D-2435-9B2B-B4A14CA20D16}"/>
+                <a16:creationId xmlns:a16="http://schemas.microsoft.com/office/drawing/2014/main" id="{C208BB2D-50E4-353B-0D5B-A9B4FC30A29B}"/>
               </a:ext>
             </a:extLst>
           </p:cNvPr>
@@ -13431,7 +13566,7 @@
           <p:cNvPr id="11" name="矩形: 圆角 10">
             <a:extLst>
               <a:ext uri="{FF2B5EF4-FFF2-40B4-BE49-F238E27FC236}">
-                <a16:creationId xmlns:a16="http://schemas.microsoft.com/office/drawing/2014/main" id="{7B30FDED-7B99-57E2-6A4A-CE7F0E1155B1}"/>
+                <a16:creationId xmlns:a16="http://schemas.microsoft.com/office/drawing/2014/main" id="{C9D5C731-B6EA-976A-E343-A7D4804B600B}"/>
               </a:ext>
             </a:extLst>
           </p:cNvPr>
@@ -13529,7 +13664,7 @@
           <p:cNvPr id="12" name="矩形: 圆角 11">
             <a:extLst>
               <a:ext uri="{FF2B5EF4-FFF2-40B4-BE49-F238E27FC236}">
-                <a16:creationId xmlns:a16="http://schemas.microsoft.com/office/drawing/2014/main" id="{A171909A-8D46-FF4E-04BA-F41843D7D1D5}"/>
+                <a16:creationId xmlns:a16="http://schemas.microsoft.com/office/drawing/2014/main" id="{04C5FC0D-D1FF-0FF6-B0F0-17BA01586394}"/>
               </a:ext>
             </a:extLst>
           </p:cNvPr>
@@ -13591,7 +13726,7 @@
           <p:cNvPr id="13" name="矩形: 圆角 12">
             <a:extLst>
               <a:ext uri="{FF2B5EF4-FFF2-40B4-BE49-F238E27FC236}">
-                <a16:creationId xmlns:a16="http://schemas.microsoft.com/office/drawing/2014/main" id="{34830F4A-BAE8-C520-87C6-F77D9B2DCF50}"/>
+                <a16:creationId xmlns:a16="http://schemas.microsoft.com/office/drawing/2014/main" id="{3B34170F-11EA-FE97-D9A6-FE4C8E86347D}"/>
               </a:ext>
             </a:extLst>
           </p:cNvPr>
@@ -13764,7 +13899,7 @@
           <p:cNvPr id="14" name="矩形: 圆角 13">
             <a:extLst>
               <a:ext uri="{FF2B5EF4-FFF2-40B4-BE49-F238E27FC236}">
-                <a16:creationId xmlns:a16="http://schemas.microsoft.com/office/drawing/2014/main" id="{6C2EBFCE-B437-3D48-5C98-A577CE123BD2}"/>
+                <a16:creationId xmlns:a16="http://schemas.microsoft.com/office/drawing/2014/main" id="{92A4F831-B355-9E84-E630-71D0805158BC}"/>
               </a:ext>
             </a:extLst>
           </p:cNvPr>
@@ -13824,7 +13959,7 @@
     </p:spTree>
     <p:extLst>
       <p:ext uri="{BB962C8B-B14F-4D97-AF65-F5344CB8AC3E}">
-        <p14:creationId xmlns:p14="http://schemas.microsoft.com/office/powerpoint/2010/main" val="999091455"/>
+        <p14:creationId xmlns:p14="http://schemas.microsoft.com/office/powerpoint/2010/main" val="1252256392"/>
       </p:ext>
     </p:extLst>
   </p:cSld>
@@ -13856,7 +13991,7 @@
           <p:cNvPr id="2" name="矩形 1">
             <a:extLst>
               <a:ext uri="{FF2B5EF4-FFF2-40B4-BE49-F238E27FC236}">
-                <a16:creationId xmlns:a16="http://schemas.microsoft.com/office/drawing/2014/main" id="{26FF78C4-76D3-E89C-2E6B-F87D37E92142}"/>
+                <a16:creationId xmlns:a16="http://schemas.microsoft.com/office/drawing/2014/main" id="{3DA79FE8-CF63-F07D-78C6-7F8DB786D69A}"/>
               </a:ext>
             </a:extLst>
           </p:cNvPr>
@@ -13910,7 +14045,7 @@
           <p:cNvPr id="3" name="矩形 2">
             <a:extLst>
               <a:ext uri="{FF2B5EF4-FFF2-40B4-BE49-F238E27FC236}">
-                <a16:creationId xmlns:a16="http://schemas.microsoft.com/office/drawing/2014/main" id="{3484DBCB-D134-2A38-4018-C4E398162FE8}"/>
+                <a16:creationId xmlns:a16="http://schemas.microsoft.com/office/drawing/2014/main" id="{DD0B7127-AD90-552C-CDE1-D871933482F7}"/>
               </a:ext>
             </a:extLst>
           </p:cNvPr>
@@ -13964,7 +14099,7 @@
           <p:cNvPr id="4" name="矩形 3">
             <a:extLst>
               <a:ext uri="{FF2B5EF4-FFF2-40B4-BE49-F238E27FC236}">
-                <a16:creationId xmlns:a16="http://schemas.microsoft.com/office/drawing/2014/main" id="{51ADEB70-F04D-CC22-80F6-2C8F464F96B1}"/>
+                <a16:creationId xmlns:a16="http://schemas.microsoft.com/office/drawing/2014/main" id="{0853E130-C83B-B40B-F38B-B82F0C120E9D}"/>
               </a:ext>
             </a:extLst>
           </p:cNvPr>
@@ -14018,7 +14153,7 @@
           <p:cNvPr id="5" name="文本框 4">
             <a:extLst>
               <a:ext uri="{FF2B5EF4-FFF2-40B4-BE49-F238E27FC236}">
-                <a16:creationId xmlns:a16="http://schemas.microsoft.com/office/drawing/2014/main" id="{B6AF0C70-C5F7-F8DC-B5ED-951E4235082F}"/>
+                <a16:creationId xmlns:a16="http://schemas.microsoft.com/office/drawing/2014/main" id="{2DA31D88-0FED-4201-E86A-D9E39297B5ED}"/>
               </a:ext>
             </a:extLst>
           </p:cNvPr>
@@ -14058,7 +14193,7 @@
           <p:cNvPr id="6" name="文本框 5">
             <a:extLst>
               <a:ext uri="{FF2B5EF4-FFF2-40B4-BE49-F238E27FC236}">
-                <a16:creationId xmlns:a16="http://schemas.microsoft.com/office/drawing/2014/main" id="{D1B85E17-CE23-83B3-17C1-C447A47749E8}"/>
+                <a16:creationId xmlns:a16="http://schemas.microsoft.com/office/drawing/2014/main" id="{2ABD4BF3-E626-EE23-A2B5-267FE8B2E02B}"/>
               </a:ext>
             </a:extLst>
           </p:cNvPr>
@@ -14105,7 +14240,7 @@
           <p:cNvPr id="7" name="文本框 6">
             <a:extLst>
               <a:ext uri="{FF2B5EF4-FFF2-40B4-BE49-F238E27FC236}">
-                <a16:creationId xmlns:a16="http://schemas.microsoft.com/office/drawing/2014/main" id="{E1EFCBA2-6D89-8A94-E4C6-2C748E07F1BF}"/>
+                <a16:creationId xmlns:a16="http://schemas.microsoft.com/office/drawing/2014/main" id="{99F1F51B-AD60-546F-7008-92D6F22106E7}"/>
               </a:ext>
             </a:extLst>
           </p:cNvPr>
@@ -14163,7 +14298,7 @@
           <p:cNvPr id="8" name="矩形: 圆角 7">
             <a:extLst>
               <a:ext uri="{FF2B5EF4-FFF2-40B4-BE49-F238E27FC236}">
-                <a16:creationId xmlns:a16="http://schemas.microsoft.com/office/drawing/2014/main" id="{EE32A9C4-B94B-1DFC-FBC2-452F89F608BE}"/>
+                <a16:creationId xmlns:a16="http://schemas.microsoft.com/office/drawing/2014/main" id="{83F0A11D-81F6-8F21-DFA2-6E09F50EB218}"/>
               </a:ext>
             </a:extLst>
           </p:cNvPr>
@@ -14225,7 +14360,7 @@
           <p:cNvPr id="9" name="矩形: 圆角 8">
             <a:extLst>
               <a:ext uri="{FF2B5EF4-FFF2-40B4-BE49-F238E27FC236}">
-                <a16:creationId xmlns:a16="http://schemas.microsoft.com/office/drawing/2014/main" id="{0D5268FE-1847-46D7-73E1-C200DC24AA2F}"/>
+                <a16:creationId xmlns:a16="http://schemas.microsoft.com/office/drawing/2014/main" id="{9247DC42-9A99-F829-9CDC-560471E1F09B}"/>
               </a:ext>
             </a:extLst>
           </p:cNvPr>
@@ -14341,7 +14476,7 @@
           <p:cNvPr id="10" name="矩形: 圆角 9">
             <a:extLst>
               <a:ext uri="{FF2B5EF4-FFF2-40B4-BE49-F238E27FC236}">
-                <a16:creationId xmlns:a16="http://schemas.microsoft.com/office/drawing/2014/main" id="{8FCCAF66-37B0-59A1-F6CB-E568CA04FACB}"/>
+                <a16:creationId xmlns:a16="http://schemas.microsoft.com/office/drawing/2014/main" id="{2ABE4BAE-DEF5-A8F3-B282-5214C704E558}"/>
               </a:ext>
             </a:extLst>
           </p:cNvPr>
@@ -14403,7 +14538,7 @@
           <p:cNvPr id="11" name="矩形: 圆角 10">
             <a:extLst>
               <a:ext uri="{FF2B5EF4-FFF2-40B4-BE49-F238E27FC236}">
-                <a16:creationId xmlns:a16="http://schemas.microsoft.com/office/drawing/2014/main" id="{D75133DA-B89D-A34D-D093-3E06CCD3B90B}"/>
+                <a16:creationId xmlns:a16="http://schemas.microsoft.com/office/drawing/2014/main" id="{3A2B0BB8-D7BF-5906-5922-B1A7A54B5F3D}"/>
               </a:ext>
             </a:extLst>
           </p:cNvPr>
@@ -14465,7 +14600,7 @@
           <p:cNvPr id="12" name="矩形: 圆角 11">
             <a:extLst>
               <a:ext uri="{FF2B5EF4-FFF2-40B4-BE49-F238E27FC236}">
-                <a16:creationId xmlns:a16="http://schemas.microsoft.com/office/drawing/2014/main" id="{8B00E2E5-623A-834B-99EC-4140A6A1EEE2}"/>
+                <a16:creationId xmlns:a16="http://schemas.microsoft.com/office/drawing/2014/main" id="{2B9FBC85-4639-BC25-0CB4-AD2929CC727D}"/>
               </a:ext>
             </a:extLst>
           </p:cNvPr>
@@ -14527,7 +14662,7 @@
           <p:cNvPr id="13" name="矩形: 圆角 12">
             <a:extLst>
               <a:ext uri="{FF2B5EF4-FFF2-40B4-BE49-F238E27FC236}">
-                <a16:creationId xmlns:a16="http://schemas.microsoft.com/office/drawing/2014/main" id="{C32DAE82-36A6-84CE-9CC8-9963E31B4AE1}"/>
+                <a16:creationId xmlns:a16="http://schemas.microsoft.com/office/drawing/2014/main" id="{DFC09D55-2B83-8E37-8C4B-73C1102FFE8A}"/>
               </a:ext>
             </a:extLst>
           </p:cNvPr>
@@ -14625,7 +14760,7 @@
           <p:cNvPr id="14" name="矩形: 圆角 13">
             <a:extLst>
               <a:ext uri="{FF2B5EF4-FFF2-40B4-BE49-F238E27FC236}">
-                <a16:creationId xmlns:a16="http://schemas.microsoft.com/office/drawing/2014/main" id="{947FFDC9-0D9B-6963-1271-6B4538A21844}"/>
+                <a16:creationId xmlns:a16="http://schemas.microsoft.com/office/drawing/2014/main" id="{53F6AE69-620C-B027-0DB4-6D818F3C1ABD}"/>
               </a:ext>
             </a:extLst>
           </p:cNvPr>
@@ -14687,7 +14822,7 @@
           <p:cNvPr id="15" name="矩形: 圆角 14">
             <a:extLst>
               <a:ext uri="{FF2B5EF4-FFF2-40B4-BE49-F238E27FC236}">
-                <a16:creationId xmlns:a16="http://schemas.microsoft.com/office/drawing/2014/main" id="{4FD6B118-EE5C-83DD-E910-A1DEC7369F36}"/>
+                <a16:creationId xmlns:a16="http://schemas.microsoft.com/office/drawing/2014/main" id="{072A8661-A487-D17A-CFA1-3CECF2480107}"/>
               </a:ext>
             </a:extLst>
           </p:cNvPr>
@@ -14764,7 +14899,7 @@
           <p:cNvPr id="16" name="矩形: 圆角 15">
             <a:extLst>
               <a:ext uri="{FF2B5EF4-FFF2-40B4-BE49-F238E27FC236}">
-                <a16:creationId xmlns:a16="http://schemas.microsoft.com/office/drawing/2014/main" id="{1C473767-B44D-79F8-2455-54762036C923}"/>
+                <a16:creationId xmlns:a16="http://schemas.microsoft.com/office/drawing/2014/main" id="{DB06E10F-01AF-F793-55D8-30DF975A814D}"/>
               </a:ext>
             </a:extLst>
           </p:cNvPr>
@@ -14826,7 +14961,7 @@
           <p:cNvPr id="17" name="文本框 16">
             <a:extLst>
               <a:ext uri="{FF2B5EF4-FFF2-40B4-BE49-F238E27FC236}">
-                <a16:creationId xmlns:a16="http://schemas.microsoft.com/office/drawing/2014/main" id="{E43A804F-B5B0-138E-70F5-7634FE52A1AA}"/>
+                <a16:creationId xmlns:a16="http://schemas.microsoft.com/office/drawing/2014/main" id="{E9C13F2D-F3CE-B251-98C5-88E6CAB41F11}"/>
               </a:ext>
             </a:extLst>
           </p:cNvPr>
@@ -14873,7 +15008,7 @@
           <p:cNvPr id="18" name="矩形: 圆角 17">
             <a:extLst>
               <a:ext uri="{FF2B5EF4-FFF2-40B4-BE49-F238E27FC236}">
-                <a16:creationId xmlns:a16="http://schemas.microsoft.com/office/drawing/2014/main" id="{07AB4DD7-02FD-F2DC-8D4B-D360DDE1E6A0}"/>
+                <a16:creationId xmlns:a16="http://schemas.microsoft.com/office/drawing/2014/main" id="{2E7146E6-1467-70BB-A666-B2569CBEF283}"/>
               </a:ext>
             </a:extLst>
           </p:cNvPr>
@@ -14935,7 +15070,7 @@
           <p:cNvPr id="19" name="文本框 18">
             <a:extLst>
               <a:ext uri="{FF2B5EF4-FFF2-40B4-BE49-F238E27FC236}">
-                <a16:creationId xmlns:a16="http://schemas.microsoft.com/office/drawing/2014/main" id="{7C5181FE-96B5-55CA-9CF1-C2414E76F52D}"/>
+                <a16:creationId xmlns:a16="http://schemas.microsoft.com/office/drawing/2014/main" id="{B260A40D-0B7B-021D-484E-9CFC778453E6}"/>
               </a:ext>
             </a:extLst>
           </p:cNvPr>
@@ -14982,7 +15117,7 @@
           <p:cNvPr id="20" name="矩形: 圆角 19">
             <a:extLst>
               <a:ext uri="{FF2B5EF4-FFF2-40B4-BE49-F238E27FC236}">
-                <a16:creationId xmlns:a16="http://schemas.microsoft.com/office/drawing/2014/main" id="{82CB9D33-E992-816C-7FF0-6FC5A46DAF9F}"/>
+                <a16:creationId xmlns:a16="http://schemas.microsoft.com/office/drawing/2014/main" id="{7890C9C4-1AE6-5EFF-14A6-A15D18E355B3}"/>
               </a:ext>
             </a:extLst>
           </p:cNvPr>
@@ -15044,7 +15179,7 @@
           <p:cNvPr id="21" name="文本框 20">
             <a:extLst>
               <a:ext uri="{FF2B5EF4-FFF2-40B4-BE49-F238E27FC236}">
-                <a16:creationId xmlns:a16="http://schemas.microsoft.com/office/drawing/2014/main" id="{CB9D510D-0DE2-D08B-A60B-A696EA6D1ABF}"/>
+                <a16:creationId xmlns:a16="http://schemas.microsoft.com/office/drawing/2014/main" id="{447C5875-1E3D-526E-3267-8AE90249075C}"/>
               </a:ext>
             </a:extLst>
           </p:cNvPr>
@@ -15091,7 +15226,7 @@
           <p:cNvPr id="22" name="矩形: 圆角 21">
             <a:extLst>
               <a:ext uri="{FF2B5EF4-FFF2-40B4-BE49-F238E27FC236}">
-                <a16:creationId xmlns:a16="http://schemas.microsoft.com/office/drawing/2014/main" id="{F8449F42-E555-3CA4-2057-F65EE54DF46E}"/>
+                <a16:creationId xmlns:a16="http://schemas.microsoft.com/office/drawing/2014/main" id="{6019AE57-97CC-56AB-A6F0-8F0C2AB88A42}"/>
               </a:ext>
             </a:extLst>
           </p:cNvPr>
@@ -15153,7 +15288,7 @@
           <p:cNvPr id="23" name="文本框 22">
             <a:extLst>
               <a:ext uri="{FF2B5EF4-FFF2-40B4-BE49-F238E27FC236}">
-                <a16:creationId xmlns:a16="http://schemas.microsoft.com/office/drawing/2014/main" id="{2346919E-9668-EA44-A28A-07CC81E76B9E}"/>
+                <a16:creationId xmlns:a16="http://schemas.microsoft.com/office/drawing/2014/main" id="{3E836B7E-ED5A-C8BE-FA6B-4F26C0974542}"/>
               </a:ext>
             </a:extLst>
           </p:cNvPr>
@@ -15200,7 +15335,7 @@
           <p:cNvPr id="24" name="矩形: 圆角 23">
             <a:extLst>
               <a:ext uri="{FF2B5EF4-FFF2-40B4-BE49-F238E27FC236}">
-                <a16:creationId xmlns:a16="http://schemas.microsoft.com/office/drawing/2014/main" id="{43EDFA4B-9808-EEF7-089E-5FB7D350792D}"/>
+                <a16:creationId xmlns:a16="http://schemas.microsoft.com/office/drawing/2014/main" id="{36AF84E5-8C7D-65C8-C12A-A0A014DF3489}"/>
               </a:ext>
             </a:extLst>
           </p:cNvPr>
@@ -15260,7 +15395,7 @@
     </p:spTree>
     <p:extLst>
       <p:ext uri="{BB962C8B-B14F-4D97-AF65-F5344CB8AC3E}">
-        <p14:creationId xmlns:p14="http://schemas.microsoft.com/office/powerpoint/2010/main" val="1032934071"/>
+        <p14:creationId xmlns:p14="http://schemas.microsoft.com/office/powerpoint/2010/main" val="1698543353"/>
       </p:ext>
     </p:extLst>
   </p:cSld>
@@ -15292,7 +15427,7 @@
           <p:cNvPr id="2" name="矩形 1">
             <a:extLst>
               <a:ext uri="{FF2B5EF4-FFF2-40B4-BE49-F238E27FC236}">
-                <a16:creationId xmlns:a16="http://schemas.microsoft.com/office/drawing/2014/main" id="{6A298FF6-0725-19DF-9D40-70DA62A6A578}"/>
+                <a16:creationId xmlns:a16="http://schemas.microsoft.com/office/drawing/2014/main" id="{C2DD82D5-8DB7-3B41-E73E-5EA7D9BBE2EF}"/>
               </a:ext>
             </a:extLst>
           </p:cNvPr>
@@ -15346,7 +15481,7 @@
           <p:cNvPr id="3" name="矩形 2">
             <a:extLst>
               <a:ext uri="{FF2B5EF4-FFF2-40B4-BE49-F238E27FC236}">
-                <a16:creationId xmlns:a16="http://schemas.microsoft.com/office/drawing/2014/main" id="{E4B1599F-944E-BAFC-95DF-6E285216865D}"/>
+                <a16:creationId xmlns:a16="http://schemas.microsoft.com/office/drawing/2014/main" id="{DF29530C-1F06-ED1F-AD00-F61B97B2B734}"/>
               </a:ext>
             </a:extLst>
           </p:cNvPr>
@@ -15400,7 +15535,7 @@
           <p:cNvPr id="4" name="矩形 3">
             <a:extLst>
               <a:ext uri="{FF2B5EF4-FFF2-40B4-BE49-F238E27FC236}">
-                <a16:creationId xmlns:a16="http://schemas.microsoft.com/office/drawing/2014/main" id="{DF79A070-764A-A166-A1AE-7A0072883226}"/>
+                <a16:creationId xmlns:a16="http://schemas.microsoft.com/office/drawing/2014/main" id="{DA8D2977-E2F6-D45B-7280-5E2E5F48A596}"/>
               </a:ext>
             </a:extLst>
           </p:cNvPr>
@@ -15454,7 +15589,7 @@
           <p:cNvPr id="5" name="文本框 4">
             <a:extLst>
               <a:ext uri="{FF2B5EF4-FFF2-40B4-BE49-F238E27FC236}">
-                <a16:creationId xmlns:a16="http://schemas.microsoft.com/office/drawing/2014/main" id="{0D9535FC-5580-7E0A-F3BD-D14D17307F45}"/>
+                <a16:creationId xmlns:a16="http://schemas.microsoft.com/office/drawing/2014/main" id="{391E46AA-62CF-1EFC-DAF9-705EBCEB81EF}"/>
               </a:ext>
             </a:extLst>
           </p:cNvPr>
@@ -15494,7 +15629,7 @@
           <p:cNvPr id="6" name="文本框 5">
             <a:extLst>
               <a:ext uri="{FF2B5EF4-FFF2-40B4-BE49-F238E27FC236}">
-                <a16:creationId xmlns:a16="http://schemas.microsoft.com/office/drawing/2014/main" id="{37734CA4-389B-5E26-F657-5FABBD599937}"/>
+                <a16:creationId xmlns:a16="http://schemas.microsoft.com/office/drawing/2014/main" id="{B559A0F8-F7F5-D7F5-3359-5DAFFC6111EB}"/>
               </a:ext>
             </a:extLst>
           </p:cNvPr>
@@ -15541,7 +15676,7 @@
           <p:cNvPr id="7" name="文本框 6">
             <a:extLst>
               <a:ext uri="{FF2B5EF4-FFF2-40B4-BE49-F238E27FC236}">
-                <a16:creationId xmlns:a16="http://schemas.microsoft.com/office/drawing/2014/main" id="{9CBF6306-F862-CE46-C57A-6E074A2E2F86}"/>
+                <a16:creationId xmlns:a16="http://schemas.microsoft.com/office/drawing/2014/main" id="{6E81F967-9D1C-B88A-2276-2625B109BE66}"/>
               </a:ext>
             </a:extLst>
           </p:cNvPr>
@@ -15581,7 +15716,7 @@
           <p:cNvPr id="8" name="矩形: 圆角 7">
             <a:extLst>
               <a:ext uri="{FF2B5EF4-FFF2-40B4-BE49-F238E27FC236}">
-                <a16:creationId xmlns:a16="http://schemas.microsoft.com/office/drawing/2014/main" id="{03AED200-EB58-709E-7094-0B8124B58A95}"/>
+                <a16:creationId xmlns:a16="http://schemas.microsoft.com/office/drawing/2014/main" id="{8D7A5063-97C4-1248-4440-3631C8E15160}"/>
               </a:ext>
             </a:extLst>
           </p:cNvPr>
@@ -15652,7 +15787,7 @@
           <p:cNvPr id="9" name="矩形: 圆角 8">
             <a:extLst>
               <a:ext uri="{FF2B5EF4-FFF2-40B4-BE49-F238E27FC236}">
-                <a16:creationId xmlns:a16="http://schemas.microsoft.com/office/drawing/2014/main" id="{4B3F8395-0362-D2CD-85FC-58F2C700FB26}"/>
+                <a16:creationId xmlns:a16="http://schemas.microsoft.com/office/drawing/2014/main" id="{5DE843AF-60CB-0F3D-728D-7DC6745AAC0A}"/>
               </a:ext>
             </a:extLst>
           </p:cNvPr>
@@ -15714,7 +15849,7 @@
           <p:cNvPr id="10" name="矩形: 圆角 9">
             <a:extLst>
               <a:ext uri="{FF2B5EF4-FFF2-40B4-BE49-F238E27FC236}">
-                <a16:creationId xmlns:a16="http://schemas.microsoft.com/office/drawing/2014/main" id="{E813793D-039C-0FB1-1D81-F9E2A3ADF88E}"/>
+                <a16:creationId xmlns:a16="http://schemas.microsoft.com/office/drawing/2014/main" id="{E389DC9A-E733-590E-7880-D660D9D682D9}"/>
               </a:ext>
             </a:extLst>
           </p:cNvPr>
@@ -15830,7 +15965,7 @@
           <p:cNvPr id="11" name="矩形: 圆角 10">
             <a:extLst>
               <a:ext uri="{FF2B5EF4-FFF2-40B4-BE49-F238E27FC236}">
-                <a16:creationId xmlns:a16="http://schemas.microsoft.com/office/drawing/2014/main" id="{2EC859BC-ECA6-B24E-1BF5-F2F34E7DD240}"/>
+                <a16:creationId xmlns:a16="http://schemas.microsoft.com/office/drawing/2014/main" id="{710D2C95-0E57-4EBE-91D0-373ADE35C176}"/>
               </a:ext>
             </a:extLst>
           </p:cNvPr>
@@ -15892,7 +16027,7 @@
           <p:cNvPr id="12" name="矩形: 圆角 11">
             <a:extLst>
               <a:ext uri="{FF2B5EF4-FFF2-40B4-BE49-F238E27FC236}">
-                <a16:creationId xmlns:a16="http://schemas.microsoft.com/office/drawing/2014/main" id="{9166CCA9-C252-FAFF-AA50-F0A9C5282FBE}"/>
+                <a16:creationId xmlns:a16="http://schemas.microsoft.com/office/drawing/2014/main" id="{61B51659-B39E-B966-7E8C-D139EA40AAD5}"/>
               </a:ext>
             </a:extLst>
           </p:cNvPr>
@@ -15987,7 +16122,7 @@
           <p:cNvPr id="13" name="矩形: 圆角 12">
             <a:extLst>
               <a:ext uri="{FF2B5EF4-FFF2-40B4-BE49-F238E27FC236}">
-                <a16:creationId xmlns:a16="http://schemas.microsoft.com/office/drawing/2014/main" id="{93ADCCBE-ADE9-4518-F0F8-3696A7A384F2}"/>
+                <a16:creationId xmlns:a16="http://schemas.microsoft.com/office/drawing/2014/main" id="{35027F12-CC2C-E307-766C-35F43548E97B}"/>
               </a:ext>
             </a:extLst>
           </p:cNvPr>
@@ -16049,7 +16184,7 @@
           <p:cNvPr id="14" name="矩形: 圆角 13">
             <a:extLst>
               <a:ext uri="{FF2B5EF4-FFF2-40B4-BE49-F238E27FC236}">
-                <a16:creationId xmlns:a16="http://schemas.microsoft.com/office/drawing/2014/main" id="{799C3134-F45B-1610-DD50-7CE8EAA51C9F}"/>
+                <a16:creationId xmlns:a16="http://schemas.microsoft.com/office/drawing/2014/main" id="{F3998BBD-89F8-F3B4-DB15-D1924B87B570}"/>
               </a:ext>
             </a:extLst>
           </p:cNvPr>
@@ -16144,7 +16279,7 @@
           <p:cNvPr id="15" name="矩形: 圆角 14">
             <a:extLst>
               <a:ext uri="{FF2B5EF4-FFF2-40B4-BE49-F238E27FC236}">
-                <a16:creationId xmlns:a16="http://schemas.microsoft.com/office/drawing/2014/main" id="{B1878514-38DD-3163-297E-217BC9A51931}"/>
+                <a16:creationId xmlns:a16="http://schemas.microsoft.com/office/drawing/2014/main" id="{CE390067-2D6F-FFF8-A0A0-E104AA247072}"/>
               </a:ext>
             </a:extLst>
           </p:cNvPr>
@@ -16206,7 +16341,7 @@
           <p:cNvPr id="16" name="矩形: 圆角 15">
             <a:extLst>
               <a:ext uri="{FF2B5EF4-FFF2-40B4-BE49-F238E27FC236}">
-                <a16:creationId xmlns:a16="http://schemas.microsoft.com/office/drawing/2014/main" id="{65EF225F-8E0B-73D8-B030-9FC6CE7097EC}"/>
+                <a16:creationId xmlns:a16="http://schemas.microsoft.com/office/drawing/2014/main" id="{40C8ECD2-0C48-9290-AAA4-CE57253C5185}"/>
               </a:ext>
             </a:extLst>
           </p:cNvPr>
@@ -16284,7 +16419,7 @@
     </p:spTree>
     <p:extLst>
       <p:ext uri="{BB962C8B-B14F-4D97-AF65-F5344CB8AC3E}">
-        <p14:creationId xmlns:p14="http://schemas.microsoft.com/office/powerpoint/2010/main" val="1562466698"/>
+        <p14:creationId xmlns:p14="http://schemas.microsoft.com/office/powerpoint/2010/main" val="2048422869"/>
       </p:ext>
     </p:extLst>
   </p:cSld>
@@ -16316,7 +16451,7 @@
           <p:cNvPr id="2" name="矩形 1">
             <a:extLst>
               <a:ext uri="{FF2B5EF4-FFF2-40B4-BE49-F238E27FC236}">
-                <a16:creationId xmlns:a16="http://schemas.microsoft.com/office/drawing/2014/main" id="{9AF0C016-A56E-EE38-6F24-141C3A2469BF}"/>
+                <a16:creationId xmlns:a16="http://schemas.microsoft.com/office/drawing/2014/main" id="{F048C080-2990-A098-21CE-3C320ED9B697}"/>
               </a:ext>
             </a:extLst>
           </p:cNvPr>
@@ -16370,7 +16505,7 @@
           <p:cNvPr id="3" name="矩形 2">
             <a:extLst>
               <a:ext uri="{FF2B5EF4-FFF2-40B4-BE49-F238E27FC236}">
-                <a16:creationId xmlns:a16="http://schemas.microsoft.com/office/drawing/2014/main" id="{F251F052-954B-9F0C-BC68-AEC490866627}"/>
+                <a16:creationId xmlns:a16="http://schemas.microsoft.com/office/drawing/2014/main" id="{B0C189B0-E30A-714E-2584-B86929D090FB}"/>
               </a:ext>
             </a:extLst>
           </p:cNvPr>
@@ -16424,7 +16559,7 @@
           <p:cNvPr id="4" name="矩形 3">
             <a:extLst>
               <a:ext uri="{FF2B5EF4-FFF2-40B4-BE49-F238E27FC236}">
-                <a16:creationId xmlns:a16="http://schemas.microsoft.com/office/drawing/2014/main" id="{A1BFE0E9-C865-8F11-FD2A-45742BD36C2F}"/>
+                <a16:creationId xmlns:a16="http://schemas.microsoft.com/office/drawing/2014/main" id="{D8BF5BFD-F0DA-EFED-54C9-1745505E888D}"/>
               </a:ext>
             </a:extLst>
           </p:cNvPr>
@@ -16478,7 +16613,7 @@
           <p:cNvPr id="5" name="文本框 4">
             <a:extLst>
               <a:ext uri="{FF2B5EF4-FFF2-40B4-BE49-F238E27FC236}">
-                <a16:creationId xmlns:a16="http://schemas.microsoft.com/office/drawing/2014/main" id="{FE8817AC-01B9-3238-5CE4-F58F40B3A8E9}"/>
+                <a16:creationId xmlns:a16="http://schemas.microsoft.com/office/drawing/2014/main" id="{0D25A788-ED5F-3E41-BEBE-A25E2348A1C2}"/>
               </a:ext>
             </a:extLst>
           </p:cNvPr>
@@ -16518,7 +16653,7 @@
           <p:cNvPr id="6" name="文本框 5">
             <a:extLst>
               <a:ext uri="{FF2B5EF4-FFF2-40B4-BE49-F238E27FC236}">
-                <a16:creationId xmlns:a16="http://schemas.microsoft.com/office/drawing/2014/main" id="{4A950FDE-8EA3-1879-EF9A-F46AD690C916}"/>
+                <a16:creationId xmlns:a16="http://schemas.microsoft.com/office/drawing/2014/main" id="{1DB5863E-84AC-F138-9078-A11F9902B78A}"/>
               </a:ext>
             </a:extLst>
           </p:cNvPr>
@@ -16565,7 +16700,7 @@
           <p:cNvPr id="7" name="文本框 6">
             <a:extLst>
               <a:ext uri="{FF2B5EF4-FFF2-40B4-BE49-F238E27FC236}">
-                <a16:creationId xmlns:a16="http://schemas.microsoft.com/office/drawing/2014/main" id="{544BF4C9-B82B-814A-79A0-8BF39CC0CBBB}"/>
+                <a16:creationId xmlns:a16="http://schemas.microsoft.com/office/drawing/2014/main" id="{E76CEA43-50B7-A70B-86DB-0E6FB45E65B1}"/>
               </a:ext>
             </a:extLst>
           </p:cNvPr>
@@ -16623,7 +16758,7 @@
           <p:cNvPr id="8" name="矩形: 圆角 7">
             <a:extLst>
               <a:ext uri="{FF2B5EF4-FFF2-40B4-BE49-F238E27FC236}">
-                <a16:creationId xmlns:a16="http://schemas.microsoft.com/office/drawing/2014/main" id="{311D6505-74A9-56D8-2534-348BC08CEC7B}"/>
+                <a16:creationId xmlns:a16="http://schemas.microsoft.com/office/drawing/2014/main" id="{5E935D74-4C2C-D115-3F5B-CE3DABE5DDA0}"/>
               </a:ext>
             </a:extLst>
           </p:cNvPr>
@@ -16685,7 +16820,7 @@
           <p:cNvPr id="9" name="文本框 8">
             <a:extLst>
               <a:ext uri="{FF2B5EF4-FFF2-40B4-BE49-F238E27FC236}">
-                <a16:creationId xmlns:a16="http://schemas.microsoft.com/office/drawing/2014/main" id="{DA973C7E-BCE9-21C7-C8F2-F2E97F8A0DF2}"/>
+                <a16:creationId xmlns:a16="http://schemas.microsoft.com/office/drawing/2014/main" id="{637983ED-D64F-A578-9611-EE9E38970046}"/>
               </a:ext>
             </a:extLst>
           </p:cNvPr>
@@ -16732,7 +16867,7 @@
           <p:cNvPr id="10" name="矩形: 圆角 9">
             <a:extLst>
               <a:ext uri="{FF2B5EF4-FFF2-40B4-BE49-F238E27FC236}">
-                <a16:creationId xmlns:a16="http://schemas.microsoft.com/office/drawing/2014/main" id="{5DCB67EE-42AD-BD3C-1C38-9BC1BEE4FCB3}"/>
+                <a16:creationId xmlns:a16="http://schemas.microsoft.com/office/drawing/2014/main" id="{9EB280CF-6BFC-E7C5-39EB-1143C4DE39AD}"/>
               </a:ext>
             </a:extLst>
           </p:cNvPr>
@@ -16794,7 +16929,7 @@
           <p:cNvPr id="11" name="文本框 10">
             <a:extLst>
               <a:ext uri="{FF2B5EF4-FFF2-40B4-BE49-F238E27FC236}">
-                <a16:creationId xmlns:a16="http://schemas.microsoft.com/office/drawing/2014/main" id="{08D81BB7-0CA7-2557-37A6-C249FB900429}"/>
+                <a16:creationId xmlns:a16="http://schemas.microsoft.com/office/drawing/2014/main" id="{90E4AEB0-3AFF-15A7-C23C-74EA0224557F}"/>
               </a:ext>
             </a:extLst>
           </p:cNvPr>
@@ -16841,7 +16976,7 @@
           <p:cNvPr id="12" name="矩形: 圆角 11">
             <a:extLst>
               <a:ext uri="{FF2B5EF4-FFF2-40B4-BE49-F238E27FC236}">
-                <a16:creationId xmlns:a16="http://schemas.microsoft.com/office/drawing/2014/main" id="{E2E09850-F33F-DB4E-42F7-95D18D348A45}"/>
+                <a16:creationId xmlns:a16="http://schemas.microsoft.com/office/drawing/2014/main" id="{D036D0CC-2BE9-2B89-6084-1A9BEB1CA3D6}"/>
               </a:ext>
             </a:extLst>
           </p:cNvPr>
@@ -16918,7 +17053,7 @@
           <p:cNvPr id="13" name="文本框 12">
             <a:extLst>
               <a:ext uri="{FF2B5EF4-FFF2-40B4-BE49-F238E27FC236}">
-                <a16:creationId xmlns:a16="http://schemas.microsoft.com/office/drawing/2014/main" id="{6C0DD56B-44B4-AEA0-E91B-0BC558E36B0E}"/>
+                <a16:creationId xmlns:a16="http://schemas.microsoft.com/office/drawing/2014/main" id="{5DA4028F-4B8C-B79E-F8F8-905FD800D893}"/>
               </a:ext>
             </a:extLst>
           </p:cNvPr>
@@ -16965,7 +17100,7 @@
           <p:cNvPr id="14" name="矩形: 圆角 13">
             <a:extLst>
               <a:ext uri="{FF2B5EF4-FFF2-40B4-BE49-F238E27FC236}">
-                <a16:creationId xmlns:a16="http://schemas.microsoft.com/office/drawing/2014/main" id="{F079F0A6-70C5-B95E-C2A2-010AEDB0C1C3}"/>
+                <a16:creationId xmlns:a16="http://schemas.microsoft.com/office/drawing/2014/main" id="{16BD6A9A-5B88-46D0-C2BC-FA68C03EB12F}"/>
               </a:ext>
             </a:extLst>
           </p:cNvPr>
@@ -17036,7 +17171,7 @@
           <p:cNvPr id="15" name="文本框 14">
             <a:extLst>
               <a:ext uri="{FF2B5EF4-FFF2-40B4-BE49-F238E27FC236}">
-                <a16:creationId xmlns:a16="http://schemas.microsoft.com/office/drawing/2014/main" id="{C41BB01B-D40F-DA29-4FE5-63DF2D3A8962}"/>
+                <a16:creationId xmlns:a16="http://schemas.microsoft.com/office/drawing/2014/main" id="{2F11D09F-B762-D2AA-16E1-37941B1278D0}"/>
               </a:ext>
             </a:extLst>
           </p:cNvPr>
@@ -17083,7 +17218,7 @@
           <p:cNvPr id="16" name="矩形: 圆角 15">
             <a:extLst>
               <a:ext uri="{FF2B5EF4-FFF2-40B4-BE49-F238E27FC236}">
-                <a16:creationId xmlns:a16="http://schemas.microsoft.com/office/drawing/2014/main" id="{7AC026D6-31FF-C1B9-0524-0F7CBF28BA7F}"/>
+                <a16:creationId xmlns:a16="http://schemas.microsoft.com/office/drawing/2014/main" id="{C92C179D-75FF-58E2-F570-EAD0B5724C51}"/>
               </a:ext>
             </a:extLst>
           </p:cNvPr>
@@ -17163,7 +17298,7 @@
           <p:cNvPr id="17" name="文本框 16">
             <a:extLst>
               <a:ext uri="{FF2B5EF4-FFF2-40B4-BE49-F238E27FC236}">
-                <a16:creationId xmlns:a16="http://schemas.microsoft.com/office/drawing/2014/main" id="{44C2DECA-3B44-00A3-BFC5-115AA94172E0}"/>
+                <a16:creationId xmlns:a16="http://schemas.microsoft.com/office/drawing/2014/main" id="{36677F0C-B5EC-826E-5743-FCF03779BA87}"/>
               </a:ext>
             </a:extLst>
           </p:cNvPr>
@@ -17210,7 +17345,7 @@
           <p:cNvPr id="18" name="矩形: 圆角 17">
             <a:extLst>
               <a:ext uri="{FF2B5EF4-FFF2-40B4-BE49-F238E27FC236}">
-                <a16:creationId xmlns:a16="http://schemas.microsoft.com/office/drawing/2014/main" id="{1D80052B-570E-0E60-BEB9-58C7F83B3E64}"/>
+                <a16:creationId xmlns:a16="http://schemas.microsoft.com/office/drawing/2014/main" id="{A00196DC-BEE3-D176-59E3-0DD07ABEEBE7}"/>
               </a:ext>
             </a:extLst>
           </p:cNvPr>
@@ -17272,7 +17407,7 @@
           <p:cNvPr id="19" name="矩形: 圆角 18">
             <a:extLst>
               <a:ext uri="{FF2B5EF4-FFF2-40B4-BE49-F238E27FC236}">
-                <a16:creationId xmlns:a16="http://schemas.microsoft.com/office/drawing/2014/main" id="{6374EE89-D490-625A-5787-91052F5F0A14}"/>
+                <a16:creationId xmlns:a16="http://schemas.microsoft.com/office/drawing/2014/main" id="{7459C7F2-0A48-B88C-2173-4584BA1D77EC}"/>
               </a:ext>
             </a:extLst>
           </p:cNvPr>
@@ -17353,7 +17488,7 @@
     </p:spTree>
     <p:extLst>
       <p:ext uri="{BB962C8B-B14F-4D97-AF65-F5344CB8AC3E}">
-        <p14:creationId xmlns:p14="http://schemas.microsoft.com/office/powerpoint/2010/main" val="3990242608"/>
+        <p14:creationId xmlns:p14="http://schemas.microsoft.com/office/powerpoint/2010/main" val="582548579"/>
       </p:ext>
     </p:extLst>
   </p:cSld>
@@ -17385,7 +17520,7 @@
           <p:cNvPr id="2" name="矩形 1">
             <a:extLst>
               <a:ext uri="{FF2B5EF4-FFF2-40B4-BE49-F238E27FC236}">
-                <a16:creationId xmlns:a16="http://schemas.microsoft.com/office/drawing/2014/main" id="{E038F658-CF82-EBA2-C335-6A17858DC142}"/>
+                <a16:creationId xmlns:a16="http://schemas.microsoft.com/office/drawing/2014/main" id="{5797DBF7-C6BF-E57D-3DC0-1B7C7678D788}"/>
               </a:ext>
             </a:extLst>
           </p:cNvPr>
@@ -17439,7 +17574,7 @@
           <p:cNvPr id="3" name="矩形 2">
             <a:extLst>
               <a:ext uri="{FF2B5EF4-FFF2-40B4-BE49-F238E27FC236}">
-                <a16:creationId xmlns:a16="http://schemas.microsoft.com/office/drawing/2014/main" id="{9D047C85-9BE8-61F2-787A-5A51E37A82AB}"/>
+                <a16:creationId xmlns:a16="http://schemas.microsoft.com/office/drawing/2014/main" id="{2BAF8B06-5681-AE7E-D334-53FE91C22380}"/>
               </a:ext>
             </a:extLst>
           </p:cNvPr>
@@ -17493,7 +17628,7 @@
           <p:cNvPr id="4" name="矩形 3">
             <a:extLst>
               <a:ext uri="{FF2B5EF4-FFF2-40B4-BE49-F238E27FC236}">
-                <a16:creationId xmlns:a16="http://schemas.microsoft.com/office/drawing/2014/main" id="{D5E1DAD8-94F7-5BD3-824C-180F9585A7C0}"/>
+                <a16:creationId xmlns:a16="http://schemas.microsoft.com/office/drawing/2014/main" id="{FD034EBD-5C3B-6566-06C1-A2A5E137E9A0}"/>
               </a:ext>
             </a:extLst>
           </p:cNvPr>
@@ -17547,7 +17682,7 @@
           <p:cNvPr id="5" name="文本框 4">
             <a:extLst>
               <a:ext uri="{FF2B5EF4-FFF2-40B4-BE49-F238E27FC236}">
-                <a16:creationId xmlns:a16="http://schemas.microsoft.com/office/drawing/2014/main" id="{D9CF52B0-C243-7A2E-49E9-203D7790AE39}"/>
+                <a16:creationId xmlns:a16="http://schemas.microsoft.com/office/drawing/2014/main" id="{2EF9EC36-3FDA-F4A6-A796-A29FABFA3D1D}"/>
               </a:ext>
             </a:extLst>
           </p:cNvPr>
@@ -17596,7 +17731,7 @@
           <p:cNvPr id="6" name="文本框 5">
             <a:extLst>
               <a:ext uri="{FF2B5EF4-FFF2-40B4-BE49-F238E27FC236}">
-                <a16:creationId xmlns:a16="http://schemas.microsoft.com/office/drawing/2014/main" id="{AFCB88B4-61BD-571C-D8BC-97727E04C6B8}"/>
+                <a16:creationId xmlns:a16="http://schemas.microsoft.com/office/drawing/2014/main" id="{BDB931A5-AC89-BEB7-8E3E-795B2BFD4878}"/>
               </a:ext>
             </a:extLst>
           </p:cNvPr>
@@ -17643,7 +17778,7 @@
           <p:cNvPr id="7" name="文本框 6">
             <a:extLst>
               <a:ext uri="{FF2B5EF4-FFF2-40B4-BE49-F238E27FC236}">
-                <a16:creationId xmlns:a16="http://schemas.microsoft.com/office/drawing/2014/main" id="{B6716092-F32C-D294-DC5A-E292A9301EEB}"/>
+                <a16:creationId xmlns:a16="http://schemas.microsoft.com/office/drawing/2014/main" id="{430178FE-8494-0D58-0391-554C05EFF4EE}"/>
               </a:ext>
             </a:extLst>
           </p:cNvPr>
@@ -17710,7 +17845,7 @@
           <p:cNvPr id="8" name="矩形: 圆角 7">
             <a:extLst>
               <a:ext uri="{FF2B5EF4-FFF2-40B4-BE49-F238E27FC236}">
-                <a16:creationId xmlns:a16="http://schemas.microsoft.com/office/drawing/2014/main" id="{1BB1E84B-1232-07CE-6F78-1FD426DB3FF1}"/>
+                <a16:creationId xmlns:a16="http://schemas.microsoft.com/office/drawing/2014/main" id="{00E13656-9DAE-7ABF-ACB2-0DBD73997DDC}"/>
               </a:ext>
             </a:extLst>
           </p:cNvPr>
@@ -17764,7 +17899,7 @@
           <p:cNvPr id="9" name="文本框 8">
             <a:extLst>
               <a:ext uri="{FF2B5EF4-FFF2-40B4-BE49-F238E27FC236}">
-                <a16:creationId xmlns:a16="http://schemas.microsoft.com/office/drawing/2014/main" id="{A6D27610-FE98-EF95-8135-0D44425F0702}"/>
+                <a16:creationId xmlns:a16="http://schemas.microsoft.com/office/drawing/2014/main" id="{1137ADC4-1423-F9EB-A693-2296BB9CCF80}"/>
               </a:ext>
             </a:extLst>
           </p:cNvPr>
@@ -17805,7 +17940,7 @@
           <p:cNvPr id="10" name="矩形: 圆角 9">
             <a:extLst>
               <a:ext uri="{FF2B5EF4-FFF2-40B4-BE49-F238E27FC236}">
-                <a16:creationId xmlns:a16="http://schemas.microsoft.com/office/drawing/2014/main" id="{D8849EB2-AB50-9604-01CF-7213647F2B61}"/>
+                <a16:creationId xmlns:a16="http://schemas.microsoft.com/office/drawing/2014/main" id="{E42269B1-DDBD-2875-088B-90C0BD2596B6}"/>
               </a:ext>
             </a:extLst>
           </p:cNvPr>
@@ -17859,7 +17994,7 @@
           <p:cNvPr id="11" name="文本框 10">
             <a:extLst>
               <a:ext uri="{FF2B5EF4-FFF2-40B4-BE49-F238E27FC236}">
-                <a16:creationId xmlns:a16="http://schemas.microsoft.com/office/drawing/2014/main" id="{D4017CFA-707D-200D-70BC-771262D5B009}"/>
+                <a16:creationId xmlns:a16="http://schemas.microsoft.com/office/drawing/2014/main" id="{8E4D7B98-4A4A-5D92-6A51-871D585061B3}"/>
               </a:ext>
             </a:extLst>
           </p:cNvPr>
@@ -17900,7 +18035,7 @@
           <p:cNvPr id="12" name="矩形: 圆角 11">
             <a:extLst>
               <a:ext uri="{FF2B5EF4-FFF2-40B4-BE49-F238E27FC236}">
-                <a16:creationId xmlns:a16="http://schemas.microsoft.com/office/drawing/2014/main" id="{CCD67054-95F8-7354-A1DF-C55FF9ECF513}"/>
+                <a16:creationId xmlns:a16="http://schemas.microsoft.com/office/drawing/2014/main" id="{CDCB650E-67FC-350A-8CF2-28AF1D56BF72}"/>
               </a:ext>
             </a:extLst>
           </p:cNvPr>
@@ -17954,7 +18089,7 @@
           <p:cNvPr id="13" name="文本框 12">
             <a:extLst>
               <a:ext uri="{FF2B5EF4-FFF2-40B4-BE49-F238E27FC236}">
-                <a16:creationId xmlns:a16="http://schemas.microsoft.com/office/drawing/2014/main" id="{1D06E7AE-6380-58A6-18EF-A3FBDF4CA924}"/>
+                <a16:creationId xmlns:a16="http://schemas.microsoft.com/office/drawing/2014/main" id="{82D22EDD-53A9-3052-9464-424D53AD1921}"/>
               </a:ext>
             </a:extLst>
           </p:cNvPr>
@@ -17995,7 +18130,7 @@
           <p:cNvPr id="14" name="矩形: 圆角 13">
             <a:extLst>
               <a:ext uri="{FF2B5EF4-FFF2-40B4-BE49-F238E27FC236}">
-                <a16:creationId xmlns:a16="http://schemas.microsoft.com/office/drawing/2014/main" id="{BF410E46-1462-313F-0FB7-8FEE4250EB6F}"/>
+                <a16:creationId xmlns:a16="http://schemas.microsoft.com/office/drawing/2014/main" id="{F4AE2D3C-71C5-4128-EAA1-A3414C6A3258}"/>
               </a:ext>
             </a:extLst>
           </p:cNvPr>
@@ -18049,7 +18184,7 @@
           <p:cNvPr id="15" name="文本框 14">
             <a:extLst>
               <a:ext uri="{FF2B5EF4-FFF2-40B4-BE49-F238E27FC236}">
-                <a16:creationId xmlns:a16="http://schemas.microsoft.com/office/drawing/2014/main" id="{E4326AC8-334B-F57F-2AD0-94CB457C339A}"/>
+                <a16:creationId xmlns:a16="http://schemas.microsoft.com/office/drawing/2014/main" id="{8D8C65D9-77C0-E6C2-4411-5D31BED12A8B}"/>
               </a:ext>
             </a:extLst>
           </p:cNvPr>
@@ -18096,7 +18231,7 @@
           <p:cNvPr id="16" name="矩形: 圆角 15">
             <a:extLst>
               <a:ext uri="{FF2B5EF4-FFF2-40B4-BE49-F238E27FC236}">
-                <a16:creationId xmlns:a16="http://schemas.microsoft.com/office/drawing/2014/main" id="{110C1715-9710-5A09-D90C-1793407F91B3}"/>
+                <a16:creationId xmlns:a16="http://schemas.microsoft.com/office/drawing/2014/main" id="{E845404B-AA89-5075-4826-DD902AFD9518}"/>
               </a:ext>
             </a:extLst>
           </p:cNvPr>
@@ -18150,7 +18285,7 @@
           <p:cNvPr id="17" name="文本框 16">
             <a:extLst>
               <a:ext uri="{FF2B5EF4-FFF2-40B4-BE49-F238E27FC236}">
-                <a16:creationId xmlns:a16="http://schemas.microsoft.com/office/drawing/2014/main" id="{BE5963B5-7D72-4281-E498-0629B4307EA4}"/>
+                <a16:creationId xmlns:a16="http://schemas.microsoft.com/office/drawing/2014/main" id="{A3193A8F-6F23-042B-9369-A02EF2B2CADA}"/>
               </a:ext>
             </a:extLst>
           </p:cNvPr>
@@ -18191,7 +18326,7 @@
           <p:cNvPr id="18" name="矩形: 圆角 17">
             <a:extLst>
               <a:ext uri="{FF2B5EF4-FFF2-40B4-BE49-F238E27FC236}">
-                <a16:creationId xmlns:a16="http://schemas.microsoft.com/office/drawing/2014/main" id="{5D6CD70E-C8D2-F1E4-C262-19AFDDFDD3EA}"/>
+                <a16:creationId xmlns:a16="http://schemas.microsoft.com/office/drawing/2014/main" id="{D1591C9F-D7CD-7CC5-89FE-B61B19BFD9B8}"/>
               </a:ext>
             </a:extLst>
           </p:cNvPr>
@@ -18245,7 +18380,7 @@
           <p:cNvPr id="19" name="文本框 18">
             <a:extLst>
               <a:ext uri="{FF2B5EF4-FFF2-40B4-BE49-F238E27FC236}">
-                <a16:creationId xmlns:a16="http://schemas.microsoft.com/office/drawing/2014/main" id="{997DFBF3-B480-FCDA-C56B-9D9A47C7A4C6}"/>
+                <a16:creationId xmlns:a16="http://schemas.microsoft.com/office/drawing/2014/main" id="{7CE2D3D1-484C-DFCD-F612-395FABE659AF}"/>
               </a:ext>
             </a:extLst>
           </p:cNvPr>
@@ -18292,7 +18427,7 @@
           <p:cNvPr id="20" name="矩形: 圆角 19">
             <a:extLst>
               <a:ext uri="{FF2B5EF4-FFF2-40B4-BE49-F238E27FC236}">
-                <a16:creationId xmlns:a16="http://schemas.microsoft.com/office/drawing/2014/main" id="{5909FE7B-0041-FA4A-8A5A-9B648A4907D9}"/>
+                <a16:creationId xmlns:a16="http://schemas.microsoft.com/office/drawing/2014/main" id="{F5FFA4D3-A636-4227-7E6E-C83004E36D8E}"/>
               </a:ext>
             </a:extLst>
           </p:cNvPr>
@@ -18346,7 +18481,7 @@
           <p:cNvPr id="21" name="文本框 20">
             <a:extLst>
               <a:ext uri="{FF2B5EF4-FFF2-40B4-BE49-F238E27FC236}">
-                <a16:creationId xmlns:a16="http://schemas.microsoft.com/office/drawing/2014/main" id="{CCE20850-864B-3DB2-023A-A7F66350A9AA}"/>
+                <a16:creationId xmlns:a16="http://schemas.microsoft.com/office/drawing/2014/main" id="{7F8527FC-9AC6-1A41-8E3B-3635F0676876}"/>
               </a:ext>
             </a:extLst>
           </p:cNvPr>
@@ -18393,7 +18528,7 @@
           <p:cNvPr id="22" name="矩形: 圆角 21">
             <a:extLst>
               <a:ext uri="{FF2B5EF4-FFF2-40B4-BE49-F238E27FC236}">
-                <a16:creationId xmlns:a16="http://schemas.microsoft.com/office/drawing/2014/main" id="{9E95601D-E805-CF66-CA46-0AF0CE1C7F39}"/>
+                <a16:creationId xmlns:a16="http://schemas.microsoft.com/office/drawing/2014/main" id="{1B01C8A7-F845-0CAF-B237-B4C2DB1F352C}"/>
               </a:ext>
             </a:extLst>
           </p:cNvPr>
@@ -18447,7 +18582,7 @@
           <p:cNvPr id="23" name="文本框 22">
             <a:extLst>
               <a:ext uri="{FF2B5EF4-FFF2-40B4-BE49-F238E27FC236}">
-                <a16:creationId xmlns:a16="http://schemas.microsoft.com/office/drawing/2014/main" id="{59E1129F-7DB1-E6A2-3F68-CEC59B56980E}"/>
+                <a16:creationId xmlns:a16="http://schemas.microsoft.com/office/drawing/2014/main" id="{6837514C-38E9-137E-A9CB-F1F2D4E2BF89}"/>
               </a:ext>
             </a:extLst>
           </p:cNvPr>
@@ -18488,7 +18623,7 @@
           <p:cNvPr id="24" name="矩形: 圆角 23">
             <a:extLst>
               <a:ext uri="{FF2B5EF4-FFF2-40B4-BE49-F238E27FC236}">
-                <a16:creationId xmlns:a16="http://schemas.microsoft.com/office/drawing/2014/main" id="{2F245A0F-1E03-17E9-83CA-455E229BA931}"/>
+                <a16:creationId xmlns:a16="http://schemas.microsoft.com/office/drawing/2014/main" id="{23531F6C-5CCD-5601-76C6-F65C19ECBBE4}"/>
               </a:ext>
             </a:extLst>
           </p:cNvPr>
@@ -18542,7 +18677,7 @@
           <p:cNvPr id="25" name="文本框 24">
             <a:extLst>
               <a:ext uri="{FF2B5EF4-FFF2-40B4-BE49-F238E27FC236}">
-                <a16:creationId xmlns:a16="http://schemas.microsoft.com/office/drawing/2014/main" id="{2A837C41-D0DB-7904-3042-A267508DBD67}"/>
+                <a16:creationId xmlns:a16="http://schemas.microsoft.com/office/drawing/2014/main" id="{7C9822ED-037B-7C7F-9A0F-D2444292692D}"/>
               </a:ext>
             </a:extLst>
           </p:cNvPr>
@@ -18589,7 +18724,7 @@
           <p:cNvPr id="26" name="矩形: 圆角 25">
             <a:extLst>
               <a:ext uri="{FF2B5EF4-FFF2-40B4-BE49-F238E27FC236}">
-                <a16:creationId xmlns:a16="http://schemas.microsoft.com/office/drawing/2014/main" id="{8A6E7FBF-9840-A17D-631E-8F27EC1D27AE}"/>
+                <a16:creationId xmlns:a16="http://schemas.microsoft.com/office/drawing/2014/main" id="{653C4DC3-EA3F-A3A9-2A08-31628895428E}"/>
               </a:ext>
             </a:extLst>
           </p:cNvPr>
@@ -18643,7 +18778,7 @@
           <p:cNvPr id="27" name="文本框 26">
             <a:extLst>
               <a:ext uri="{FF2B5EF4-FFF2-40B4-BE49-F238E27FC236}">
-                <a16:creationId xmlns:a16="http://schemas.microsoft.com/office/drawing/2014/main" id="{16EC5B64-E996-2E74-A4BB-A30C2BF7D6BC}"/>
+                <a16:creationId xmlns:a16="http://schemas.microsoft.com/office/drawing/2014/main" id="{553301D0-CB6D-6A2A-F89B-C3DB85D4932A}"/>
               </a:ext>
             </a:extLst>
           </p:cNvPr>
@@ -18690,7 +18825,7 @@
           <p:cNvPr id="28" name="矩形: 圆角 27">
             <a:extLst>
               <a:ext uri="{FF2B5EF4-FFF2-40B4-BE49-F238E27FC236}">
-                <a16:creationId xmlns:a16="http://schemas.microsoft.com/office/drawing/2014/main" id="{B357DE83-CA6A-D803-40FC-45A7FCE0A1AD}"/>
+                <a16:creationId xmlns:a16="http://schemas.microsoft.com/office/drawing/2014/main" id="{3967EFE5-38C0-0777-1A0A-08640A1F126A}"/>
               </a:ext>
             </a:extLst>
           </p:cNvPr>
@@ -18744,7 +18879,7 @@
           <p:cNvPr id="29" name="文本框 28">
             <a:extLst>
               <a:ext uri="{FF2B5EF4-FFF2-40B4-BE49-F238E27FC236}">
-                <a16:creationId xmlns:a16="http://schemas.microsoft.com/office/drawing/2014/main" id="{A04F90D9-738D-C4F9-496F-08D119C6C8CF}"/>
+                <a16:creationId xmlns:a16="http://schemas.microsoft.com/office/drawing/2014/main" id="{1446868A-E30F-1A1C-2B7C-21BD17F93AF3}"/>
               </a:ext>
             </a:extLst>
           </p:cNvPr>
@@ -18785,7 +18920,7 @@
           <p:cNvPr id="30" name="矩形: 圆角 29">
             <a:extLst>
               <a:ext uri="{FF2B5EF4-FFF2-40B4-BE49-F238E27FC236}">
-                <a16:creationId xmlns:a16="http://schemas.microsoft.com/office/drawing/2014/main" id="{D997D452-92F3-CC0C-2C0C-B5DFB329AD01}"/>
+                <a16:creationId xmlns:a16="http://schemas.microsoft.com/office/drawing/2014/main" id="{3223FD6B-6728-3861-4A8D-5541E4D8B8A7}"/>
               </a:ext>
             </a:extLst>
           </p:cNvPr>
@@ -18839,7 +18974,7 @@
           <p:cNvPr id="31" name="文本框 30">
             <a:extLst>
               <a:ext uri="{FF2B5EF4-FFF2-40B4-BE49-F238E27FC236}">
-                <a16:creationId xmlns:a16="http://schemas.microsoft.com/office/drawing/2014/main" id="{875BEC22-5400-87E4-28F5-93DB15D6A51F}"/>
+                <a16:creationId xmlns:a16="http://schemas.microsoft.com/office/drawing/2014/main" id="{AEB17E6D-A807-430E-BEB0-376B3B612BC0}"/>
               </a:ext>
             </a:extLst>
           </p:cNvPr>
@@ -18886,7 +19021,7 @@
           <p:cNvPr id="32" name="矩形: 圆角 31">
             <a:extLst>
               <a:ext uri="{FF2B5EF4-FFF2-40B4-BE49-F238E27FC236}">
-                <a16:creationId xmlns:a16="http://schemas.microsoft.com/office/drawing/2014/main" id="{9C0021AE-CA5F-0D79-0673-5F74505813DE}"/>
+                <a16:creationId xmlns:a16="http://schemas.microsoft.com/office/drawing/2014/main" id="{D07246B6-2CAF-FE58-73EC-638DF3140A5D}"/>
               </a:ext>
             </a:extLst>
           </p:cNvPr>
@@ -18940,7 +19075,7 @@
           <p:cNvPr id="33" name="文本框 32">
             <a:extLst>
               <a:ext uri="{FF2B5EF4-FFF2-40B4-BE49-F238E27FC236}">
-                <a16:creationId xmlns:a16="http://schemas.microsoft.com/office/drawing/2014/main" id="{4CBCE64C-B9A8-8D5B-D267-900EBA615582}"/>
+                <a16:creationId xmlns:a16="http://schemas.microsoft.com/office/drawing/2014/main" id="{A7844AC0-900F-22A9-EABB-BE51726F9790}"/>
               </a:ext>
             </a:extLst>
           </p:cNvPr>
@@ -18987,7 +19122,7 @@
           <p:cNvPr id="34" name="矩形: 圆角 33">
             <a:extLst>
               <a:ext uri="{FF2B5EF4-FFF2-40B4-BE49-F238E27FC236}">
-                <a16:creationId xmlns:a16="http://schemas.microsoft.com/office/drawing/2014/main" id="{31A3BFDD-F929-C0B1-5B25-E1737479C509}"/>
+                <a16:creationId xmlns:a16="http://schemas.microsoft.com/office/drawing/2014/main" id="{5F343455-1D39-1353-C367-3FCB6324C720}"/>
               </a:ext>
             </a:extLst>
           </p:cNvPr>
@@ -19041,7 +19176,7 @@
           <p:cNvPr id="35" name="文本框 34">
             <a:extLst>
               <a:ext uri="{FF2B5EF4-FFF2-40B4-BE49-F238E27FC236}">
-                <a16:creationId xmlns:a16="http://schemas.microsoft.com/office/drawing/2014/main" id="{07839D99-DEDF-2744-6FCF-E33CD77F29C9}"/>
+                <a16:creationId xmlns:a16="http://schemas.microsoft.com/office/drawing/2014/main" id="{D6B7DE3E-A3DB-AB26-E367-C9846DD9E638}"/>
               </a:ext>
             </a:extLst>
           </p:cNvPr>
@@ -19097,7 +19232,7 @@
           <p:cNvPr id="36" name="矩形: 圆角 35">
             <a:extLst>
               <a:ext uri="{FF2B5EF4-FFF2-40B4-BE49-F238E27FC236}">
-                <a16:creationId xmlns:a16="http://schemas.microsoft.com/office/drawing/2014/main" id="{FC52EC91-1B06-7F86-D526-3FE763BED032}"/>
+                <a16:creationId xmlns:a16="http://schemas.microsoft.com/office/drawing/2014/main" id="{608EE805-C997-526F-0ACF-2AFEBABB3C03}"/>
               </a:ext>
             </a:extLst>
           </p:cNvPr>
@@ -19151,7 +19286,7 @@
           <p:cNvPr id="37" name="文本框 36">
             <a:extLst>
               <a:ext uri="{FF2B5EF4-FFF2-40B4-BE49-F238E27FC236}">
-                <a16:creationId xmlns:a16="http://schemas.microsoft.com/office/drawing/2014/main" id="{6666ED15-E185-8DBF-93AB-30B90815AAE9}"/>
+                <a16:creationId xmlns:a16="http://schemas.microsoft.com/office/drawing/2014/main" id="{CFC1907D-A57A-DDBF-F39E-72562CEE433B}"/>
               </a:ext>
             </a:extLst>
           </p:cNvPr>
@@ -19198,7 +19333,7 @@
           <p:cNvPr id="38" name="矩形: 圆角 37">
             <a:extLst>
               <a:ext uri="{FF2B5EF4-FFF2-40B4-BE49-F238E27FC236}">
-                <a16:creationId xmlns:a16="http://schemas.microsoft.com/office/drawing/2014/main" id="{141B9242-1C60-BFEE-95B8-739F248F42FE}"/>
+                <a16:creationId xmlns:a16="http://schemas.microsoft.com/office/drawing/2014/main" id="{BF60151A-6B3E-0EC8-8E91-EE2917919605}"/>
               </a:ext>
             </a:extLst>
           </p:cNvPr>
@@ -19252,7 +19387,7 @@
           <p:cNvPr id="39" name="文本框 38">
             <a:extLst>
               <a:ext uri="{FF2B5EF4-FFF2-40B4-BE49-F238E27FC236}">
-                <a16:creationId xmlns:a16="http://schemas.microsoft.com/office/drawing/2014/main" id="{D8AF5787-76EE-5AEE-66AB-698B2D265FA2}"/>
+                <a16:creationId xmlns:a16="http://schemas.microsoft.com/office/drawing/2014/main" id="{C7FAF9D0-2901-059E-DD5F-CF7C27B3597F}"/>
               </a:ext>
             </a:extLst>
           </p:cNvPr>
@@ -19299,7 +19434,7 @@
           <p:cNvPr id="40" name="矩形: 圆角 39">
             <a:extLst>
               <a:ext uri="{FF2B5EF4-FFF2-40B4-BE49-F238E27FC236}">
-                <a16:creationId xmlns:a16="http://schemas.microsoft.com/office/drawing/2014/main" id="{5E7E4088-EB2A-A5CB-3308-A2A93547F7E3}"/>
+                <a16:creationId xmlns:a16="http://schemas.microsoft.com/office/drawing/2014/main" id="{B7058C76-1804-832C-5AA6-6550B13B9B93}"/>
               </a:ext>
             </a:extLst>
           </p:cNvPr>
@@ -19353,7 +19488,7 @@
           <p:cNvPr id="41" name="文本框 40">
             <a:extLst>
               <a:ext uri="{FF2B5EF4-FFF2-40B4-BE49-F238E27FC236}">
-                <a16:creationId xmlns:a16="http://schemas.microsoft.com/office/drawing/2014/main" id="{1BC1972C-6F75-FC2A-3250-B8A4A61FF09B}"/>
+                <a16:creationId xmlns:a16="http://schemas.microsoft.com/office/drawing/2014/main" id="{A9B9DBC3-5E54-C0AC-B978-2BF4F2A65AA5}"/>
               </a:ext>
             </a:extLst>
           </p:cNvPr>
@@ -19418,7 +19553,7 @@
           <p:cNvPr id="42" name="矩形: 圆角 41">
             <a:extLst>
               <a:ext uri="{FF2B5EF4-FFF2-40B4-BE49-F238E27FC236}">
-                <a16:creationId xmlns:a16="http://schemas.microsoft.com/office/drawing/2014/main" id="{5C12E5DC-B65B-64A6-0433-22BF7D97B34E}"/>
+                <a16:creationId xmlns:a16="http://schemas.microsoft.com/office/drawing/2014/main" id="{3858D396-B2F8-0F3A-585D-BB9A145BEE95}"/>
               </a:ext>
             </a:extLst>
           </p:cNvPr>
@@ -19472,7 +19607,7 @@
           <p:cNvPr id="43" name="文本框 42">
             <a:extLst>
               <a:ext uri="{FF2B5EF4-FFF2-40B4-BE49-F238E27FC236}">
-                <a16:creationId xmlns:a16="http://schemas.microsoft.com/office/drawing/2014/main" id="{7DF6A811-FD5D-164A-BFF1-432A9D5CC7BC}"/>
+                <a16:creationId xmlns:a16="http://schemas.microsoft.com/office/drawing/2014/main" id="{6DF2A841-4722-0CD0-794C-1CDA473C3116}"/>
               </a:ext>
             </a:extLst>
           </p:cNvPr>
@@ -19519,7 +19654,7 @@
           <p:cNvPr id="44" name="矩形: 圆角 43">
             <a:extLst>
               <a:ext uri="{FF2B5EF4-FFF2-40B4-BE49-F238E27FC236}">
-                <a16:creationId xmlns:a16="http://schemas.microsoft.com/office/drawing/2014/main" id="{40E94B7E-F5F9-540F-2838-65522E3915F9}"/>
+                <a16:creationId xmlns:a16="http://schemas.microsoft.com/office/drawing/2014/main" id="{1819C80F-235B-8A6A-F842-AAD3E1EE1718}"/>
               </a:ext>
             </a:extLst>
           </p:cNvPr>
@@ -19573,7 +19708,7 @@
           <p:cNvPr id="45" name="文本框 44">
             <a:extLst>
               <a:ext uri="{FF2B5EF4-FFF2-40B4-BE49-F238E27FC236}">
-                <a16:creationId xmlns:a16="http://schemas.microsoft.com/office/drawing/2014/main" id="{C5B730A0-408F-66BC-2AE1-198667697BC3}"/>
+                <a16:creationId xmlns:a16="http://schemas.microsoft.com/office/drawing/2014/main" id="{97B7F6F4-0A69-0476-DD01-CDF9807DFB18}"/>
               </a:ext>
             </a:extLst>
           </p:cNvPr>
@@ -19620,7 +19755,7 @@
           <p:cNvPr id="46" name="矩形: 圆角 45">
             <a:extLst>
               <a:ext uri="{FF2B5EF4-FFF2-40B4-BE49-F238E27FC236}">
-                <a16:creationId xmlns:a16="http://schemas.microsoft.com/office/drawing/2014/main" id="{2C53A651-5D6A-3AB9-919A-CEDD5DB2731D}"/>
+                <a16:creationId xmlns:a16="http://schemas.microsoft.com/office/drawing/2014/main" id="{4CC9AE7F-A69F-2473-D293-345F06412E16}"/>
               </a:ext>
             </a:extLst>
           </p:cNvPr>
@@ -19674,7 +19809,7 @@
           <p:cNvPr id="47" name="文本框 46">
             <a:extLst>
               <a:ext uri="{FF2B5EF4-FFF2-40B4-BE49-F238E27FC236}">
-                <a16:creationId xmlns:a16="http://schemas.microsoft.com/office/drawing/2014/main" id="{4C1ED720-75D1-A478-8127-1DDA56DF0DB1}"/>
+                <a16:creationId xmlns:a16="http://schemas.microsoft.com/office/drawing/2014/main" id="{305EA2D1-913A-8F9C-F661-E62130CFCF9D}"/>
               </a:ext>
             </a:extLst>
           </p:cNvPr>
@@ -19715,7 +19850,7 @@
           <p:cNvPr id="48" name="矩形: 圆角 47">
             <a:extLst>
               <a:ext uri="{FF2B5EF4-FFF2-40B4-BE49-F238E27FC236}">
-                <a16:creationId xmlns:a16="http://schemas.microsoft.com/office/drawing/2014/main" id="{50E3BE7D-1080-5271-F873-5A83EA91DFB9}"/>
+                <a16:creationId xmlns:a16="http://schemas.microsoft.com/office/drawing/2014/main" id="{986D0943-1086-6908-EA63-28AB9224E25B}"/>
               </a:ext>
             </a:extLst>
           </p:cNvPr>
@@ -19769,7 +19904,7 @@
           <p:cNvPr id="49" name="文本框 48">
             <a:extLst>
               <a:ext uri="{FF2B5EF4-FFF2-40B4-BE49-F238E27FC236}">
-                <a16:creationId xmlns:a16="http://schemas.microsoft.com/office/drawing/2014/main" id="{6B5F9ED5-21F4-FBE7-6C52-5F413C3C14DB}"/>
+                <a16:creationId xmlns:a16="http://schemas.microsoft.com/office/drawing/2014/main" id="{94C3CF41-CBD4-D726-9301-9E239D8557FE}"/>
               </a:ext>
             </a:extLst>
           </p:cNvPr>
@@ -19808,7 +19943,7 @@
     </p:spTree>
     <p:extLst>
       <p:ext uri="{BB962C8B-B14F-4D97-AF65-F5344CB8AC3E}">
-        <p14:creationId xmlns:p14="http://schemas.microsoft.com/office/powerpoint/2010/main" val="3179467736"/>
+        <p14:creationId xmlns:p14="http://schemas.microsoft.com/office/powerpoint/2010/main" val="4048136120"/>
       </p:ext>
     </p:extLst>
   </p:cSld>
@@ -19840,7 +19975,7 @@
           <p:cNvPr id="2" name="矩形 1">
             <a:extLst>
               <a:ext uri="{FF2B5EF4-FFF2-40B4-BE49-F238E27FC236}">
-                <a16:creationId xmlns:a16="http://schemas.microsoft.com/office/drawing/2014/main" id="{69E41E8F-ABB6-CCEF-AAC2-7282C421BD86}"/>
+                <a16:creationId xmlns:a16="http://schemas.microsoft.com/office/drawing/2014/main" id="{BF38D550-A8FE-4CFB-6667-B194B860B062}"/>
               </a:ext>
             </a:extLst>
           </p:cNvPr>
@@ -19894,7 +20029,7 @@
           <p:cNvPr id="3" name="矩形 2">
             <a:extLst>
               <a:ext uri="{FF2B5EF4-FFF2-40B4-BE49-F238E27FC236}">
-                <a16:creationId xmlns:a16="http://schemas.microsoft.com/office/drawing/2014/main" id="{8A208C56-547F-CDA0-740F-6D074E24EEA6}"/>
+                <a16:creationId xmlns:a16="http://schemas.microsoft.com/office/drawing/2014/main" id="{5E7EACE8-5DF9-8FD0-2CB7-8071E0774EB5}"/>
               </a:ext>
             </a:extLst>
           </p:cNvPr>
@@ -19948,7 +20083,7 @@
           <p:cNvPr id="4" name="矩形 3">
             <a:extLst>
               <a:ext uri="{FF2B5EF4-FFF2-40B4-BE49-F238E27FC236}">
-                <a16:creationId xmlns:a16="http://schemas.microsoft.com/office/drawing/2014/main" id="{26383075-D1F5-1524-ED95-FA109B9D1005}"/>
+                <a16:creationId xmlns:a16="http://schemas.microsoft.com/office/drawing/2014/main" id="{AC5AF92E-EEAE-68BF-BD26-F66CA85FB733}"/>
               </a:ext>
             </a:extLst>
           </p:cNvPr>
@@ -20002,7 +20137,7 @@
           <p:cNvPr id="5" name="文本框 4">
             <a:extLst>
               <a:ext uri="{FF2B5EF4-FFF2-40B4-BE49-F238E27FC236}">
-                <a16:creationId xmlns:a16="http://schemas.microsoft.com/office/drawing/2014/main" id="{E316E935-2B85-F3C4-742F-2DF574CBDDD7}"/>
+                <a16:creationId xmlns:a16="http://schemas.microsoft.com/office/drawing/2014/main" id="{053D74C7-9048-D208-D246-429580331750}"/>
               </a:ext>
             </a:extLst>
           </p:cNvPr>
@@ -20051,7 +20186,7 @@
           <p:cNvPr id="6" name="文本框 5">
             <a:extLst>
               <a:ext uri="{FF2B5EF4-FFF2-40B4-BE49-F238E27FC236}">
-                <a16:creationId xmlns:a16="http://schemas.microsoft.com/office/drawing/2014/main" id="{3A0A8B90-58D1-8481-E440-939309339128}"/>
+                <a16:creationId xmlns:a16="http://schemas.microsoft.com/office/drawing/2014/main" id="{DB26F40A-91E3-1251-B426-55972E1DEA1E}"/>
               </a:ext>
             </a:extLst>
           </p:cNvPr>
@@ -20098,7 +20233,7 @@
           <p:cNvPr id="7" name="文本框 6">
             <a:extLst>
               <a:ext uri="{FF2B5EF4-FFF2-40B4-BE49-F238E27FC236}">
-                <a16:creationId xmlns:a16="http://schemas.microsoft.com/office/drawing/2014/main" id="{A48C7C75-FE0F-E6A0-CEB9-07D284A8D08C}"/>
+                <a16:creationId xmlns:a16="http://schemas.microsoft.com/office/drawing/2014/main" id="{B5E1EF20-882D-3D10-03F0-9A9B93D462C2}"/>
               </a:ext>
             </a:extLst>
           </p:cNvPr>
@@ -20147,7 +20282,7 @@
           <p:cNvPr id="8" name="矩形: 圆角 7">
             <a:extLst>
               <a:ext uri="{FF2B5EF4-FFF2-40B4-BE49-F238E27FC236}">
-                <a16:creationId xmlns:a16="http://schemas.microsoft.com/office/drawing/2014/main" id="{C7C36DF3-AD1D-932B-7BF5-01AF6E73820E}"/>
+                <a16:creationId xmlns:a16="http://schemas.microsoft.com/office/drawing/2014/main" id="{C2763EF1-AC8F-02B6-87D2-7438DC030C18}"/>
               </a:ext>
             </a:extLst>
           </p:cNvPr>
@@ -20209,7 +20344,7 @@
           <p:cNvPr id="9" name="文本框 8">
             <a:extLst>
               <a:ext uri="{FF2B5EF4-FFF2-40B4-BE49-F238E27FC236}">
-                <a16:creationId xmlns:a16="http://schemas.microsoft.com/office/drawing/2014/main" id="{E27C6E2E-34CB-33B6-F1DF-984ACFFF3AEA}"/>
+                <a16:creationId xmlns:a16="http://schemas.microsoft.com/office/drawing/2014/main" id="{1D6CBD6B-0944-3785-C4B0-F0F13B0F9A84}"/>
               </a:ext>
             </a:extLst>
           </p:cNvPr>
@@ -20256,7 +20391,7 @@
           <p:cNvPr id="10" name="矩形: 圆角 9">
             <a:extLst>
               <a:ext uri="{FF2B5EF4-FFF2-40B4-BE49-F238E27FC236}">
-                <a16:creationId xmlns:a16="http://schemas.microsoft.com/office/drawing/2014/main" id="{435B38A3-12B5-D747-8541-0A5B4567ABEA}"/>
+                <a16:creationId xmlns:a16="http://schemas.microsoft.com/office/drawing/2014/main" id="{0905E7C2-375B-CB8A-516D-E846B58F315A}"/>
               </a:ext>
             </a:extLst>
           </p:cNvPr>
@@ -20324,7 +20459,7 @@
           <p:cNvPr id="11" name="文本框 10">
             <a:extLst>
               <a:ext uri="{FF2B5EF4-FFF2-40B4-BE49-F238E27FC236}">
-                <a16:creationId xmlns:a16="http://schemas.microsoft.com/office/drawing/2014/main" id="{0247E00F-E785-7761-6329-64D6252907E0}"/>
+                <a16:creationId xmlns:a16="http://schemas.microsoft.com/office/drawing/2014/main" id="{24D47909-9A03-9106-C733-DC42CC7E3DB6}"/>
               </a:ext>
             </a:extLst>
           </p:cNvPr>
@@ -20371,7 +20506,7 @@
           <p:cNvPr id="12" name="矩形: 圆角 11">
             <a:extLst>
               <a:ext uri="{FF2B5EF4-FFF2-40B4-BE49-F238E27FC236}">
-                <a16:creationId xmlns:a16="http://schemas.microsoft.com/office/drawing/2014/main" id="{14935513-27C5-B5FC-9F9C-E031F015393E}"/>
+                <a16:creationId xmlns:a16="http://schemas.microsoft.com/office/drawing/2014/main" id="{1E814D49-7D69-AFA7-BF30-2A4F7BD4EAC9}"/>
               </a:ext>
             </a:extLst>
           </p:cNvPr>
@@ -20439,7 +20574,7 @@
           <p:cNvPr id="13" name="文本框 12">
             <a:extLst>
               <a:ext uri="{FF2B5EF4-FFF2-40B4-BE49-F238E27FC236}">
-                <a16:creationId xmlns:a16="http://schemas.microsoft.com/office/drawing/2014/main" id="{9F9D3A6C-208D-E470-2BB8-43E7CE080B7C}"/>
+                <a16:creationId xmlns:a16="http://schemas.microsoft.com/office/drawing/2014/main" id="{C31DC655-C1C4-23D5-51D9-874391FAFBF3}"/>
               </a:ext>
             </a:extLst>
           </p:cNvPr>
@@ -20486,7 +20621,7 @@
           <p:cNvPr id="14" name="矩形: 圆角 13">
             <a:extLst>
               <a:ext uri="{FF2B5EF4-FFF2-40B4-BE49-F238E27FC236}">
-                <a16:creationId xmlns:a16="http://schemas.microsoft.com/office/drawing/2014/main" id="{18BB67D3-5151-A4AC-2D50-EC0537FDFE9A}"/>
+                <a16:creationId xmlns:a16="http://schemas.microsoft.com/office/drawing/2014/main" id="{39CFE8B6-687D-9C1F-E606-DF2D65FD1421}"/>
               </a:ext>
             </a:extLst>
           </p:cNvPr>
@@ -20554,7 +20689,7 @@
           <p:cNvPr id="15" name="文本框 14">
             <a:extLst>
               <a:ext uri="{FF2B5EF4-FFF2-40B4-BE49-F238E27FC236}">
-                <a16:creationId xmlns:a16="http://schemas.microsoft.com/office/drawing/2014/main" id="{C5EC134B-87EF-1753-AADF-E9640690BA82}"/>
+                <a16:creationId xmlns:a16="http://schemas.microsoft.com/office/drawing/2014/main" id="{7F97989B-F590-51F8-F27C-7922C43F9D05}"/>
               </a:ext>
             </a:extLst>
           </p:cNvPr>
@@ -20601,7 +20736,7 @@
           <p:cNvPr id="16" name="矩形: 圆角 15">
             <a:extLst>
               <a:ext uri="{FF2B5EF4-FFF2-40B4-BE49-F238E27FC236}">
-                <a16:creationId xmlns:a16="http://schemas.microsoft.com/office/drawing/2014/main" id="{DD85CBB7-B92F-7A76-BA69-E58A56724307}"/>
+                <a16:creationId xmlns:a16="http://schemas.microsoft.com/office/drawing/2014/main" id="{58633062-492C-0413-44CA-1EBF948A7A80}"/>
               </a:ext>
             </a:extLst>
           </p:cNvPr>
@@ -20669,7 +20804,7 @@
           <p:cNvPr id="17" name="矩形: 圆角 16">
             <a:extLst>
               <a:ext uri="{FF2B5EF4-FFF2-40B4-BE49-F238E27FC236}">
-                <a16:creationId xmlns:a16="http://schemas.microsoft.com/office/drawing/2014/main" id="{47AC1C18-8696-2901-576E-CF813A16483C}"/>
+                <a16:creationId xmlns:a16="http://schemas.microsoft.com/office/drawing/2014/main" id="{102DA8FD-31FE-841B-2422-AD04C8742D78}"/>
               </a:ext>
             </a:extLst>
           </p:cNvPr>
@@ -20731,7 +20866,7 @@
           <p:cNvPr id="18" name="矩形: 圆角 17">
             <a:extLst>
               <a:ext uri="{FF2B5EF4-FFF2-40B4-BE49-F238E27FC236}">
-                <a16:creationId xmlns:a16="http://schemas.microsoft.com/office/drawing/2014/main" id="{C6F9F8FE-20C6-BA22-AB8A-0A36DC87798A}"/>
+                <a16:creationId xmlns:a16="http://schemas.microsoft.com/office/drawing/2014/main" id="{17E0A099-30CD-EEBF-B249-A4D91F28D879}"/>
               </a:ext>
             </a:extLst>
           </p:cNvPr>
@@ -20802,7 +20937,7 @@
           <p:cNvPr id="19" name="矩形: 圆角 18">
             <a:extLst>
               <a:ext uri="{FF2B5EF4-FFF2-40B4-BE49-F238E27FC236}">
-                <a16:creationId xmlns:a16="http://schemas.microsoft.com/office/drawing/2014/main" id="{B4A57B77-7C62-D5F8-2D67-145BACB6078A}"/>
+                <a16:creationId xmlns:a16="http://schemas.microsoft.com/office/drawing/2014/main" id="{0FFB25CB-98B0-BF4B-7B8D-B6BA37F8C551}"/>
               </a:ext>
             </a:extLst>
           </p:cNvPr>
@@ -20862,7 +20997,7 @@
     </p:spTree>
     <p:extLst>
       <p:ext uri="{BB962C8B-B14F-4D97-AF65-F5344CB8AC3E}">
-        <p14:creationId xmlns:p14="http://schemas.microsoft.com/office/powerpoint/2010/main" val="1539363347"/>
+        <p14:creationId xmlns:p14="http://schemas.microsoft.com/office/powerpoint/2010/main" val="4245473320"/>
       </p:ext>
     </p:extLst>
   </p:cSld>
@@ -20894,7 +21029,7 @@
           <p:cNvPr id="2" name="矩形 1">
             <a:extLst>
               <a:ext uri="{FF2B5EF4-FFF2-40B4-BE49-F238E27FC236}">
-                <a16:creationId xmlns:a16="http://schemas.microsoft.com/office/drawing/2014/main" id="{33128404-9D0B-11ED-2162-FE88131DC26A}"/>
+                <a16:creationId xmlns:a16="http://schemas.microsoft.com/office/drawing/2014/main" id="{1C95DFFC-46DE-C693-E21F-C6FA2A6199C7}"/>
               </a:ext>
             </a:extLst>
           </p:cNvPr>
@@ -20948,7 +21083,7 @@
           <p:cNvPr id="3" name="矩形 2">
             <a:extLst>
               <a:ext uri="{FF2B5EF4-FFF2-40B4-BE49-F238E27FC236}">
-                <a16:creationId xmlns:a16="http://schemas.microsoft.com/office/drawing/2014/main" id="{244E3CD1-5F90-9F79-7E39-91EA36812344}"/>
+                <a16:creationId xmlns:a16="http://schemas.microsoft.com/office/drawing/2014/main" id="{6A433284-BA7F-9CB8-0948-5142B8402780}"/>
               </a:ext>
             </a:extLst>
           </p:cNvPr>
@@ -21002,7 +21137,7 @@
           <p:cNvPr id="4" name="矩形 3">
             <a:extLst>
               <a:ext uri="{FF2B5EF4-FFF2-40B4-BE49-F238E27FC236}">
-                <a16:creationId xmlns:a16="http://schemas.microsoft.com/office/drawing/2014/main" id="{99157A91-406F-4C53-BA8B-F7C72FA4E853}"/>
+                <a16:creationId xmlns:a16="http://schemas.microsoft.com/office/drawing/2014/main" id="{17DE1820-2C96-3896-DB3E-B527E1F9E02A}"/>
               </a:ext>
             </a:extLst>
           </p:cNvPr>
@@ -21056,7 +21191,7 @@
           <p:cNvPr id="5" name="文本框 4">
             <a:extLst>
               <a:ext uri="{FF2B5EF4-FFF2-40B4-BE49-F238E27FC236}">
-                <a16:creationId xmlns:a16="http://schemas.microsoft.com/office/drawing/2014/main" id="{F2801A77-524B-D858-1343-FE8CAB0EA3A2}"/>
+                <a16:creationId xmlns:a16="http://schemas.microsoft.com/office/drawing/2014/main" id="{05EBBE16-1957-4C71-3C76-E28E43C74BDD}"/>
               </a:ext>
             </a:extLst>
           </p:cNvPr>
@@ -21120,7 +21255,7 @@
           <p:cNvPr id="6" name="文本框 5">
             <a:extLst>
               <a:ext uri="{FF2B5EF4-FFF2-40B4-BE49-F238E27FC236}">
-                <a16:creationId xmlns:a16="http://schemas.microsoft.com/office/drawing/2014/main" id="{C1EFEC95-1BE6-B5E7-5B9E-D22FBAE85274}"/>
+                <a16:creationId xmlns:a16="http://schemas.microsoft.com/office/drawing/2014/main" id="{8B6AE7C9-508C-B553-5A6F-FE03A3F5D3CD}"/>
               </a:ext>
             </a:extLst>
           </p:cNvPr>
@@ -21167,7 +21302,7 @@
           <p:cNvPr id="7" name="文本框 6">
             <a:extLst>
               <a:ext uri="{FF2B5EF4-FFF2-40B4-BE49-F238E27FC236}">
-                <a16:creationId xmlns:a16="http://schemas.microsoft.com/office/drawing/2014/main" id="{435A66AA-63BB-D558-0566-115FF11D72BD}"/>
+                <a16:creationId xmlns:a16="http://schemas.microsoft.com/office/drawing/2014/main" id="{571A4016-4CE9-8317-188A-574338819006}"/>
               </a:ext>
             </a:extLst>
           </p:cNvPr>
@@ -21252,7 +21387,7 @@
           <p:cNvPr id="8" name="矩形: 圆角 7">
             <a:extLst>
               <a:ext uri="{FF2B5EF4-FFF2-40B4-BE49-F238E27FC236}">
-                <a16:creationId xmlns:a16="http://schemas.microsoft.com/office/drawing/2014/main" id="{CAEB756F-1ED2-06CC-E5C2-F5B4D64B9AEB}"/>
+                <a16:creationId xmlns:a16="http://schemas.microsoft.com/office/drawing/2014/main" id="{7663D9D9-1828-7F40-4343-7517517C931E}"/>
               </a:ext>
             </a:extLst>
           </p:cNvPr>
@@ -21320,7 +21455,7 @@
           <p:cNvPr id="9" name="矩形: 圆角 8">
             <a:extLst>
               <a:ext uri="{FF2B5EF4-FFF2-40B4-BE49-F238E27FC236}">
-                <a16:creationId xmlns:a16="http://schemas.microsoft.com/office/drawing/2014/main" id="{2516A111-1FBB-D08B-BDDD-E9D82ABB81EC}"/>
+                <a16:creationId xmlns:a16="http://schemas.microsoft.com/office/drawing/2014/main" id="{9455E2DF-A5D5-E8CA-2FFB-D24F672178CC}"/>
               </a:ext>
             </a:extLst>
           </p:cNvPr>
@@ -21400,7 +21535,7 @@
           <p:cNvPr id="10" name="矩形: 圆角 9">
             <a:extLst>
               <a:ext uri="{FF2B5EF4-FFF2-40B4-BE49-F238E27FC236}">
-                <a16:creationId xmlns:a16="http://schemas.microsoft.com/office/drawing/2014/main" id="{CB67A4C8-3077-F982-2E65-A0B0AAC6BF8A}"/>
+                <a16:creationId xmlns:a16="http://schemas.microsoft.com/office/drawing/2014/main" id="{08447280-1F63-BB5B-6F6A-AA847594AF4E}"/>
               </a:ext>
             </a:extLst>
           </p:cNvPr>
@@ -21468,7 +21603,7 @@
           <p:cNvPr id="11" name="矩形: 圆角 10">
             <a:extLst>
               <a:ext uri="{FF2B5EF4-FFF2-40B4-BE49-F238E27FC236}">
-                <a16:creationId xmlns:a16="http://schemas.microsoft.com/office/drawing/2014/main" id="{3010B670-CAE2-049D-13FF-00ED38795A7B}"/>
+                <a16:creationId xmlns:a16="http://schemas.microsoft.com/office/drawing/2014/main" id="{121F8BDF-0A0A-E7DC-DF24-3D28B3D0524E}"/>
               </a:ext>
             </a:extLst>
           </p:cNvPr>
@@ -21554,7 +21689,7 @@
           <p:cNvPr id="12" name="矩形: 圆角 11">
             <a:extLst>
               <a:ext uri="{FF2B5EF4-FFF2-40B4-BE49-F238E27FC236}">
-                <a16:creationId xmlns:a16="http://schemas.microsoft.com/office/drawing/2014/main" id="{BCDFD363-F14C-A34C-C505-E98192576B71}"/>
+                <a16:creationId xmlns:a16="http://schemas.microsoft.com/office/drawing/2014/main" id="{1B1FC52C-DCBF-4D92-0292-3D234EDF4A41}"/>
               </a:ext>
             </a:extLst>
           </p:cNvPr>
@@ -21640,7 +21775,7 @@
           <p:cNvPr id="13" name="矩形: 圆角 12">
             <a:extLst>
               <a:ext uri="{FF2B5EF4-FFF2-40B4-BE49-F238E27FC236}">
-                <a16:creationId xmlns:a16="http://schemas.microsoft.com/office/drawing/2014/main" id="{AB247C2D-9A1B-1614-0CD5-09F872E15FC8}"/>
+                <a16:creationId xmlns:a16="http://schemas.microsoft.com/office/drawing/2014/main" id="{CC670CC3-887F-E658-F25E-A2A7FDB16CB2}"/>
               </a:ext>
             </a:extLst>
           </p:cNvPr>
@@ -21708,7 +21843,7 @@
           <p:cNvPr id="14" name="文本框 13">
             <a:extLst>
               <a:ext uri="{FF2B5EF4-FFF2-40B4-BE49-F238E27FC236}">
-                <a16:creationId xmlns:a16="http://schemas.microsoft.com/office/drawing/2014/main" id="{6355ADB9-C8C5-853F-3D99-E6D72E90CD31}"/>
+                <a16:creationId xmlns:a16="http://schemas.microsoft.com/office/drawing/2014/main" id="{DD22757D-7C60-D813-7487-0BB8A9D568EC}"/>
               </a:ext>
             </a:extLst>
           </p:cNvPr>
@@ -21755,7 +21890,7 @@
           <p:cNvPr id="15" name="矩形: 圆角 14">
             <a:extLst>
               <a:ext uri="{FF2B5EF4-FFF2-40B4-BE49-F238E27FC236}">
-                <a16:creationId xmlns:a16="http://schemas.microsoft.com/office/drawing/2014/main" id="{7C45DD54-DBC3-70D5-AA98-6962F2AB8274}"/>
+                <a16:creationId xmlns:a16="http://schemas.microsoft.com/office/drawing/2014/main" id="{4034AD1E-3FE6-AF01-EC7F-55BA2080446E}"/>
               </a:ext>
             </a:extLst>
           </p:cNvPr>
@@ -21823,7 +21958,7 @@
           <p:cNvPr id="16" name="文本框 15">
             <a:extLst>
               <a:ext uri="{FF2B5EF4-FFF2-40B4-BE49-F238E27FC236}">
-                <a16:creationId xmlns:a16="http://schemas.microsoft.com/office/drawing/2014/main" id="{0DAAE7A9-A9AF-DDA1-E4FA-4DDD3A1B2EB8}"/>
+                <a16:creationId xmlns:a16="http://schemas.microsoft.com/office/drawing/2014/main" id="{20AC813A-E4B4-F9C8-B6D9-95DAFCF7AAF5}"/>
               </a:ext>
             </a:extLst>
           </p:cNvPr>
@@ -21870,7 +22005,7 @@
           <p:cNvPr id="17" name="矩形: 圆角 16">
             <a:extLst>
               <a:ext uri="{FF2B5EF4-FFF2-40B4-BE49-F238E27FC236}">
-                <a16:creationId xmlns:a16="http://schemas.microsoft.com/office/drawing/2014/main" id="{16156001-A597-5230-D4A0-2959BA870364}"/>
+                <a16:creationId xmlns:a16="http://schemas.microsoft.com/office/drawing/2014/main" id="{72806305-7F19-D3D4-A98D-5AFF5E7B8E5C}"/>
               </a:ext>
             </a:extLst>
           </p:cNvPr>
@@ -21938,7 +22073,7 @@
           <p:cNvPr id="18" name="矩形: 圆角 17">
             <a:extLst>
               <a:ext uri="{FF2B5EF4-FFF2-40B4-BE49-F238E27FC236}">
-                <a16:creationId xmlns:a16="http://schemas.microsoft.com/office/drawing/2014/main" id="{E69A4709-A634-9689-BA99-3CDD4F7CD5D0}"/>
+                <a16:creationId xmlns:a16="http://schemas.microsoft.com/office/drawing/2014/main" id="{2CA6E9B0-974D-EED2-A177-40375DB8CAD1}"/>
               </a:ext>
             </a:extLst>
           </p:cNvPr>
@@ -21998,7 +22133,7 @@
     </p:spTree>
     <p:extLst>
       <p:ext uri="{BB962C8B-B14F-4D97-AF65-F5344CB8AC3E}">
-        <p14:creationId xmlns:p14="http://schemas.microsoft.com/office/powerpoint/2010/main" val="2801204807"/>
+        <p14:creationId xmlns:p14="http://schemas.microsoft.com/office/powerpoint/2010/main" val="3956391940"/>
       </p:ext>
     </p:extLst>
   </p:cSld>
@@ -22030,7 +22165,7 @@
           <p:cNvPr id="2" name="矩形 1">
             <a:extLst>
               <a:ext uri="{FF2B5EF4-FFF2-40B4-BE49-F238E27FC236}">
-                <a16:creationId xmlns:a16="http://schemas.microsoft.com/office/drawing/2014/main" id="{978A380B-528C-7509-3887-6566161DBD1F}"/>
+                <a16:creationId xmlns:a16="http://schemas.microsoft.com/office/drawing/2014/main" id="{F8A3F3F7-DBBF-8CDB-EE28-13C52E566644}"/>
               </a:ext>
             </a:extLst>
           </p:cNvPr>
@@ -22084,7 +22219,7 @@
           <p:cNvPr id="3" name="矩形 2">
             <a:extLst>
               <a:ext uri="{FF2B5EF4-FFF2-40B4-BE49-F238E27FC236}">
-                <a16:creationId xmlns:a16="http://schemas.microsoft.com/office/drawing/2014/main" id="{4C0B03A2-3D6A-A1B0-203E-75550E4D91EA}"/>
+                <a16:creationId xmlns:a16="http://schemas.microsoft.com/office/drawing/2014/main" id="{88142B2B-6B02-0744-8BAE-A7C9CDC53629}"/>
               </a:ext>
             </a:extLst>
           </p:cNvPr>
@@ -22138,7 +22273,7 @@
           <p:cNvPr id="4" name="矩形 3">
             <a:extLst>
               <a:ext uri="{FF2B5EF4-FFF2-40B4-BE49-F238E27FC236}">
-                <a16:creationId xmlns:a16="http://schemas.microsoft.com/office/drawing/2014/main" id="{DC574FED-F390-6DCA-4D70-036FC86B519B}"/>
+                <a16:creationId xmlns:a16="http://schemas.microsoft.com/office/drawing/2014/main" id="{1AAFE58E-7266-B473-966D-C67A6C5CD8D7}"/>
               </a:ext>
             </a:extLst>
           </p:cNvPr>
@@ -22192,7 +22327,7 @@
           <p:cNvPr id="5" name="文本框 4">
             <a:extLst>
               <a:ext uri="{FF2B5EF4-FFF2-40B4-BE49-F238E27FC236}">
-                <a16:creationId xmlns:a16="http://schemas.microsoft.com/office/drawing/2014/main" id="{0486CAA3-8658-0C4C-1EEB-8703FCC375C9}"/>
+                <a16:creationId xmlns:a16="http://schemas.microsoft.com/office/drawing/2014/main" id="{B470A85A-BACE-0686-C4D8-4431C81DDF71}"/>
               </a:ext>
             </a:extLst>
           </p:cNvPr>
@@ -22277,7 +22412,7 @@
           <p:cNvPr id="6" name="文本框 5">
             <a:extLst>
               <a:ext uri="{FF2B5EF4-FFF2-40B4-BE49-F238E27FC236}">
-                <a16:creationId xmlns:a16="http://schemas.microsoft.com/office/drawing/2014/main" id="{C3EB2FDE-3494-DFCD-FAD4-2D2CDC70E6C0}"/>
+                <a16:creationId xmlns:a16="http://schemas.microsoft.com/office/drawing/2014/main" id="{AB8C54CE-95FF-4F33-1493-0D8B2F8A4EE0}"/>
               </a:ext>
             </a:extLst>
           </p:cNvPr>
@@ -22324,7 +22459,7 @@
           <p:cNvPr id="7" name="文本框 6">
             <a:extLst>
               <a:ext uri="{FF2B5EF4-FFF2-40B4-BE49-F238E27FC236}">
-                <a16:creationId xmlns:a16="http://schemas.microsoft.com/office/drawing/2014/main" id="{6F27A977-D766-2EE4-9DBA-B49656D8B636}"/>
+                <a16:creationId xmlns:a16="http://schemas.microsoft.com/office/drawing/2014/main" id="{6FCA3398-2A1E-6888-F70E-A15F58EDD3A4}"/>
               </a:ext>
             </a:extLst>
           </p:cNvPr>
@@ -22409,7 +22544,7 @@
           <p:cNvPr id="8" name="矩形: 圆角 7">
             <a:extLst>
               <a:ext uri="{FF2B5EF4-FFF2-40B4-BE49-F238E27FC236}">
-                <a16:creationId xmlns:a16="http://schemas.microsoft.com/office/drawing/2014/main" id="{26C20024-99EF-0AA3-EC63-0A67B8CCAD35}"/>
+                <a16:creationId xmlns:a16="http://schemas.microsoft.com/office/drawing/2014/main" id="{801089B4-AF5F-7F71-FF50-9E6026EBE80F}"/>
               </a:ext>
             </a:extLst>
           </p:cNvPr>
@@ -22498,7 +22633,7 @@
           <p:cNvPr id="9" name="文本框 8">
             <a:extLst>
               <a:ext uri="{FF2B5EF4-FFF2-40B4-BE49-F238E27FC236}">
-                <a16:creationId xmlns:a16="http://schemas.microsoft.com/office/drawing/2014/main" id="{25BCD5EA-5F03-A6C4-497D-A1A61B12DA72}"/>
+                <a16:creationId xmlns:a16="http://schemas.microsoft.com/office/drawing/2014/main" id="{70D74A64-70AC-80C7-95CF-702CEB63BBF0}"/>
               </a:ext>
             </a:extLst>
           </p:cNvPr>
@@ -22545,7 +22680,7 @@
           <p:cNvPr id="10" name="矩形: 圆角 9">
             <a:extLst>
               <a:ext uri="{FF2B5EF4-FFF2-40B4-BE49-F238E27FC236}">
-                <a16:creationId xmlns:a16="http://schemas.microsoft.com/office/drawing/2014/main" id="{11175DAB-FD40-F641-0F33-728B0DD996DC}"/>
+                <a16:creationId xmlns:a16="http://schemas.microsoft.com/office/drawing/2014/main" id="{4167F29C-8CB8-4D0C-AC67-6872FE7D20D7}"/>
               </a:ext>
             </a:extLst>
           </p:cNvPr>
@@ -22613,7 +22748,7 @@
           <p:cNvPr id="11" name="文本框 10">
             <a:extLst>
               <a:ext uri="{FF2B5EF4-FFF2-40B4-BE49-F238E27FC236}">
-                <a16:creationId xmlns:a16="http://schemas.microsoft.com/office/drawing/2014/main" id="{5A5CFCC1-65F7-73E5-A593-117BE6FE0505}"/>
+                <a16:creationId xmlns:a16="http://schemas.microsoft.com/office/drawing/2014/main" id="{0388CA8A-A701-B333-9FC3-CF5001CCB376}"/>
               </a:ext>
             </a:extLst>
           </p:cNvPr>
@@ -22660,7 +22795,7 @@
           <p:cNvPr id="12" name="矩形: 圆角 11">
             <a:extLst>
               <a:ext uri="{FF2B5EF4-FFF2-40B4-BE49-F238E27FC236}">
-                <a16:creationId xmlns:a16="http://schemas.microsoft.com/office/drawing/2014/main" id="{5227D62B-D50C-EC07-BBB1-E61CF096EE51}"/>
+                <a16:creationId xmlns:a16="http://schemas.microsoft.com/office/drawing/2014/main" id="{6F20611B-269B-3DF3-8B86-ACCB8059911F}"/>
               </a:ext>
             </a:extLst>
           </p:cNvPr>
@@ -22737,7 +22872,7 @@
           <p:cNvPr id="13" name="矩形: 圆角 12">
             <a:extLst>
               <a:ext uri="{FF2B5EF4-FFF2-40B4-BE49-F238E27FC236}">
-                <a16:creationId xmlns:a16="http://schemas.microsoft.com/office/drawing/2014/main" id="{DEFC6357-9EB1-3C85-FE6A-16F0142C4609}"/>
+                <a16:creationId xmlns:a16="http://schemas.microsoft.com/office/drawing/2014/main" id="{AEEB12A4-B920-B85E-165F-D2F105B2F4C7}"/>
               </a:ext>
             </a:extLst>
           </p:cNvPr>
@@ -22805,7 +22940,7 @@
           <p:cNvPr id="14" name="矩形: 圆角 13">
             <a:extLst>
               <a:ext uri="{FF2B5EF4-FFF2-40B4-BE49-F238E27FC236}">
-                <a16:creationId xmlns:a16="http://schemas.microsoft.com/office/drawing/2014/main" id="{FE727FBA-01BE-CFF1-B204-1A0F2C78437F}"/>
+                <a16:creationId xmlns:a16="http://schemas.microsoft.com/office/drawing/2014/main" id="{4FBF4056-4D36-F9CD-6492-F8A8C487FEBE}"/>
               </a:ext>
             </a:extLst>
           </p:cNvPr>
@@ -22873,7 +23008,7 @@
           <p:cNvPr id="15" name="矩形: 圆角 14">
             <a:extLst>
               <a:ext uri="{FF2B5EF4-FFF2-40B4-BE49-F238E27FC236}">
-                <a16:creationId xmlns:a16="http://schemas.microsoft.com/office/drawing/2014/main" id="{9D0034CA-65F3-C25E-9F0B-76AF3F1D51D9}"/>
+                <a16:creationId xmlns:a16="http://schemas.microsoft.com/office/drawing/2014/main" id="{C2AB15C0-477E-000E-9F24-3B7DCA143479}"/>
               </a:ext>
             </a:extLst>
           </p:cNvPr>
@@ -22941,7 +23076,7 @@
           <p:cNvPr id="16" name="矩形: 圆角 15">
             <a:extLst>
               <a:ext uri="{FF2B5EF4-FFF2-40B4-BE49-F238E27FC236}">
-                <a16:creationId xmlns:a16="http://schemas.microsoft.com/office/drawing/2014/main" id="{5F224039-9340-EB87-3BA9-E506C3EA151A}"/>
+                <a16:creationId xmlns:a16="http://schemas.microsoft.com/office/drawing/2014/main" id="{8BA17EBB-70A1-044B-22BD-DB8F6FDD2D1B}"/>
               </a:ext>
             </a:extLst>
           </p:cNvPr>
@@ -23001,7 +23136,7 @@
     </p:spTree>
     <p:extLst>
       <p:ext uri="{BB962C8B-B14F-4D97-AF65-F5344CB8AC3E}">
-        <p14:creationId xmlns:p14="http://schemas.microsoft.com/office/powerpoint/2010/main" val="1624667486"/>
+        <p14:creationId xmlns:p14="http://schemas.microsoft.com/office/powerpoint/2010/main" val="4237499338"/>
       </p:ext>
     </p:extLst>
   </p:cSld>

</xml_diff>